<commit_message>
fix: Resolve mobile app initialization error, update backend URL, and fix icon compatibility.
</commit_message>
<xml_diff>
--- a/STUDENT REGISTRATION.pptx
+++ b/STUDENT REGISTRATION.pptx
@@ -9,8 +9,12 @@
     <p:sldId id="257" r:id="rId3"/>
     <p:sldId id="261" r:id="rId4"/>
     <p:sldId id="258" r:id="rId5"/>
-    <p:sldId id="259" r:id="rId6"/>
-    <p:sldId id="260" r:id="rId7"/>
+    <p:sldId id="265" r:id="rId6"/>
+    <p:sldId id="262" r:id="rId7"/>
+    <p:sldId id="259" r:id="rId8"/>
+    <p:sldId id="263" r:id="rId9"/>
+    <p:sldId id="264" r:id="rId10"/>
+    <p:sldId id="260" r:id="rId11"/>
   </p:sldIdLst>
   <p:sldSz cx="12192000" cy="6858000"/>
   <p:notesSz cx="6858000" cy="9144000"/>
@@ -266,7 +270,7 @@
           <a:p>
             <a:fld id="{59730A62-9116-4267-99FC-E7DD97509EF7}" type="datetimeFigureOut">
               <a:rPr lang="en-PK" smtClean="0"/>
-              <a:t>28/03/2026</a:t>
+              <a:t>29/03/2026</a:t>
             </a:fld>
             <a:endParaRPr lang="en-PK"/>
           </a:p>
@@ -466,7 +470,7 @@
           <a:p>
             <a:fld id="{59730A62-9116-4267-99FC-E7DD97509EF7}" type="datetimeFigureOut">
               <a:rPr lang="en-PK" smtClean="0"/>
-              <a:t>28/03/2026</a:t>
+              <a:t>29/03/2026</a:t>
             </a:fld>
             <a:endParaRPr lang="en-PK"/>
           </a:p>
@@ -676,7 +680,7 @@
           <a:p>
             <a:fld id="{59730A62-9116-4267-99FC-E7DD97509EF7}" type="datetimeFigureOut">
               <a:rPr lang="en-PK" smtClean="0"/>
-              <a:t>28/03/2026</a:t>
+              <a:t>29/03/2026</a:t>
             </a:fld>
             <a:endParaRPr lang="en-PK"/>
           </a:p>
@@ -876,7 +880,7 @@
           <a:p>
             <a:fld id="{59730A62-9116-4267-99FC-E7DD97509EF7}" type="datetimeFigureOut">
               <a:rPr lang="en-PK" smtClean="0"/>
-              <a:t>28/03/2026</a:t>
+              <a:t>29/03/2026</a:t>
             </a:fld>
             <a:endParaRPr lang="en-PK"/>
           </a:p>
@@ -1152,7 +1156,7 @@
           <a:p>
             <a:fld id="{59730A62-9116-4267-99FC-E7DD97509EF7}" type="datetimeFigureOut">
               <a:rPr lang="en-PK" smtClean="0"/>
-              <a:t>28/03/2026</a:t>
+              <a:t>29/03/2026</a:t>
             </a:fld>
             <a:endParaRPr lang="en-PK"/>
           </a:p>
@@ -1420,7 +1424,7 @@
           <a:p>
             <a:fld id="{59730A62-9116-4267-99FC-E7DD97509EF7}" type="datetimeFigureOut">
               <a:rPr lang="en-PK" smtClean="0"/>
-              <a:t>28/03/2026</a:t>
+              <a:t>29/03/2026</a:t>
             </a:fld>
             <a:endParaRPr lang="en-PK"/>
           </a:p>
@@ -1835,7 +1839,7 @@
           <a:p>
             <a:fld id="{59730A62-9116-4267-99FC-E7DD97509EF7}" type="datetimeFigureOut">
               <a:rPr lang="en-PK" smtClean="0"/>
-              <a:t>28/03/2026</a:t>
+              <a:t>29/03/2026</a:t>
             </a:fld>
             <a:endParaRPr lang="en-PK"/>
           </a:p>
@@ -1977,7 +1981,7 @@
           <a:p>
             <a:fld id="{59730A62-9116-4267-99FC-E7DD97509EF7}" type="datetimeFigureOut">
               <a:rPr lang="en-PK" smtClean="0"/>
-              <a:t>28/03/2026</a:t>
+              <a:t>29/03/2026</a:t>
             </a:fld>
             <a:endParaRPr lang="en-PK"/>
           </a:p>
@@ -2090,7 +2094,7 @@
           <a:p>
             <a:fld id="{59730A62-9116-4267-99FC-E7DD97509EF7}" type="datetimeFigureOut">
               <a:rPr lang="en-PK" smtClean="0"/>
-              <a:t>28/03/2026</a:t>
+              <a:t>29/03/2026</a:t>
             </a:fld>
             <a:endParaRPr lang="en-PK"/>
           </a:p>
@@ -2403,7 +2407,7 @@
           <a:p>
             <a:fld id="{59730A62-9116-4267-99FC-E7DD97509EF7}" type="datetimeFigureOut">
               <a:rPr lang="en-PK" smtClean="0"/>
-              <a:t>28/03/2026</a:t>
+              <a:t>29/03/2026</a:t>
             </a:fld>
             <a:endParaRPr lang="en-PK"/>
           </a:p>
@@ -2692,7 +2696,7 @@
           <a:p>
             <a:fld id="{59730A62-9116-4267-99FC-E7DD97509EF7}" type="datetimeFigureOut">
               <a:rPr lang="en-PK" smtClean="0"/>
-              <a:t>28/03/2026</a:t>
+              <a:t>29/03/2026</a:t>
             </a:fld>
             <a:endParaRPr lang="en-PK"/>
           </a:p>
@@ -2935,7 +2939,7 @@
           <a:p>
             <a:fld id="{59730A62-9116-4267-99FC-E7DD97509EF7}" type="datetimeFigureOut">
               <a:rPr lang="en-PK" smtClean="0"/>
-              <a:t>28/03/2026</a:t>
+              <a:t>29/03/2026</a:t>
             </a:fld>
             <a:endParaRPr lang="en-PK"/>
           </a:p>
@@ -3557,6 +3561,144 @@
 </p:sld>
 </file>
 
+<file path=ppt/slides/slide10.xml><?xml version="1.0" encoding="utf-8"?>
+<p:sld xmlns:a="http://schemas.openxmlformats.org/drawingml/2006/main" xmlns:r="http://schemas.openxmlformats.org/officeDocument/2006/relationships" xmlns:p="http://schemas.openxmlformats.org/presentationml/2006/main">
+  <p:cSld>
+    <p:spTree>
+      <p:nvGrpSpPr>
+        <p:cNvPr id="1" name="">
+          <a:extLst>
+            <a:ext uri="{FF2B5EF4-FFF2-40B4-BE49-F238E27FC236}">
+              <a16:creationId xmlns:a16="http://schemas.microsoft.com/office/drawing/2014/main" id="{D6188D29-524E-9030-DDF9-2FFBFB948A03}"/>
+            </a:ext>
+          </a:extLst>
+        </p:cNvPr>
+        <p:cNvGrpSpPr/>
+        <p:nvPr/>
+      </p:nvGrpSpPr>
+      <p:grpSpPr>
+        <a:xfrm>
+          <a:off x="0" y="0"/>
+          <a:ext cx="0" cy="0"/>
+          <a:chOff x="0" y="0"/>
+          <a:chExt cx="0" cy="0"/>
+        </a:xfrm>
+      </p:grpSpPr>
+      <p:sp>
+        <p:nvSpPr>
+          <p:cNvPr id="2" name="Title 1">
+            <a:extLst>
+              <a:ext uri="{FF2B5EF4-FFF2-40B4-BE49-F238E27FC236}">
+                <a16:creationId xmlns:a16="http://schemas.microsoft.com/office/drawing/2014/main" id="{2745430A-9B0F-D826-8B17-198B41B9B6E3}"/>
+              </a:ext>
+            </a:extLst>
+          </p:cNvPr>
+          <p:cNvSpPr>
+            <a:spLocks noGrp="1"/>
+          </p:cNvSpPr>
+          <p:nvPr>
+            <p:ph type="title"/>
+          </p:nvPr>
+        </p:nvSpPr>
+        <p:spPr/>
+        <p:txBody>
+          <a:bodyPr/>
+          <a:lstStyle/>
+          <a:p>
+            <a:endParaRPr lang="en-PK"/>
+          </a:p>
+        </p:txBody>
+      </p:sp>
+      <p:sp>
+        <p:nvSpPr>
+          <p:cNvPr id="3" name="Content Placeholder 2">
+            <a:extLst>
+              <a:ext uri="{FF2B5EF4-FFF2-40B4-BE49-F238E27FC236}">
+                <a16:creationId xmlns:a16="http://schemas.microsoft.com/office/drawing/2014/main" id="{C686B506-1C06-0EC6-7279-1083653DB0F7}"/>
+              </a:ext>
+            </a:extLst>
+          </p:cNvPr>
+          <p:cNvSpPr>
+            <a:spLocks noGrp="1"/>
+          </p:cNvSpPr>
+          <p:nvPr>
+            <p:ph idx="1"/>
+          </p:nvPr>
+        </p:nvSpPr>
+        <p:spPr/>
+        <p:txBody>
+          <a:bodyPr/>
+          <a:lstStyle/>
+          <a:p>
+            <a:endParaRPr lang="en-PK"/>
+          </a:p>
+        </p:txBody>
+      </p:sp>
+      <p:sp>
+        <p:nvSpPr>
+          <p:cNvPr id="4" name="TextBox 3">
+            <a:extLst>
+              <a:ext uri="{FF2B5EF4-FFF2-40B4-BE49-F238E27FC236}">
+                <a16:creationId xmlns:a16="http://schemas.microsoft.com/office/drawing/2014/main" id="{B389A75D-8D27-03FF-9B3B-4F371BF90BCE}"/>
+              </a:ext>
+            </a:extLst>
+          </p:cNvPr>
+          <p:cNvSpPr txBox="1"/>
+          <p:nvPr/>
+        </p:nvSpPr>
+        <p:spPr>
+          <a:xfrm>
+            <a:off x="152400" y="6488668"/>
+            <a:ext cx="11887200" cy="369332"/>
+          </a:xfrm>
+          <a:prstGeom prst="rect">
+            <a:avLst/>
+          </a:prstGeom>
+          <a:noFill/>
+        </p:spPr>
+        <p:txBody>
+          <a:bodyPr wrap="square" rtlCol="0">
+            <a:spAutoFit/>
+          </a:bodyPr>
+          <a:lstStyle/>
+          <a:p>
+            <a:r>
+              <a:rPr lang="en-US" b="1" dirty="0">
+                <a:solidFill>
+                  <a:srgbClr val="0070C0"/>
+                </a:solidFill>
+              </a:rPr>
+              <a:t>FACULTY OF PHARMACY AND PHARMACEUTICAL SCIENCES                                                                               </a:t>
+            </a:r>
+            <a:r>
+              <a:rPr lang="en-US" b="1" dirty="0">
+                <a:solidFill>
+                  <a:schemeClr val="accent2"/>
+                </a:solidFill>
+              </a:rPr>
+              <a:t>SOFTSOLS PAKISTAN</a:t>
+            </a:r>
+            <a:endParaRPr lang="en-PK" b="1" dirty="0">
+              <a:solidFill>
+                <a:schemeClr val="accent2"/>
+              </a:solidFill>
+            </a:endParaRPr>
+          </a:p>
+        </p:txBody>
+      </p:sp>
+    </p:spTree>
+    <p:extLst>
+      <p:ext uri="{BB962C8B-B14F-4D97-AF65-F5344CB8AC3E}">
+        <p14:creationId xmlns:p14="http://schemas.microsoft.com/office/powerpoint/2010/main" val="3053948027"/>
+      </p:ext>
+    </p:extLst>
+  </p:cSld>
+  <p:clrMapOvr>
+    <a:masterClrMapping/>
+  </p:clrMapOvr>
+</p:sld>
+</file>
+
 <file path=ppt/slides/slide2.xml><?xml version="1.0" encoding="utf-8"?>
 <p:sld xmlns:a="http://schemas.openxmlformats.org/drawingml/2006/main" xmlns:r="http://schemas.openxmlformats.org/officeDocument/2006/relationships" xmlns:p="http://schemas.openxmlformats.org/presentationml/2006/main">
   <p:cSld>
@@ -3787,7 +3929,7 @@
         <p:spPr>
           <a:xfrm>
             <a:off x="5407378" y="270933"/>
-            <a:ext cx="5944833" cy="6333067"/>
+            <a:ext cx="5944833" cy="6217735"/>
           </a:xfrm>
           <a:prstGeom prst="rect">
             <a:avLst/>
@@ -3852,6 +3994,58 @@
           </a:p>
           <a:p>
             <a:endParaRPr lang="en-PK" dirty="0"/>
+          </a:p>
+        </p:txBody>
+      </p:sp>
+      <p:sp>
+        <p:nvSpPr>
+          <p:cNvPr id="3" name="TextBox 2">
+            <a:extLst>
+              <a:ext uri="{FF2B5EF4-FFF2-40B4-BE49-F238E27FC236}">
+                <a16:creationId xmlns:a16="http://schemas.microsoft.com/office/drawing/2014/main" id="{9B821D15-7A31-AD68-4798-1AC554714170}"/>
+              </a:ext>
+            </a:extLst>
+          </p:cNvPr>
+          <p:cNvSpPr txBox="1"/>
+          <p:nvPr/>
+        </p:nvSpPr>
+        <p:spPr>
+          <a:xfrm>
+            <a:off x="152400" y="6488668"/>
+            <a:ext cx="11887200" cy="369332"/>
+          </a:xfrm>
+          <a:prstGeom prst="rect">
+            <a:avLst/>
+          </a:prstGeom>
+          <a:noFill/>
+        </p:spPr>
+        <p:txBody>
+          <a:bodyPr wrap="square" rtlCol="0">
+            <a:spAutoFit/>
+          </a:bodyPr>
+          <a:lstStyle/>
+          <a:p>
+            <a:r>
+              <a:rPr lang="en-US" b="1" dirty="0">
+                <a:solidFill>
+                  <a:srgbClr val="0070C0"/>
+                </a:solidFill>
+              </a:rPr>
+              <a:t>FACULTY OF PHARMACY AND PHARMACEUTICAL SCIENCES                                                                               </a:t>
+            </a:r>
+            <a:r>
+              <a:rPr lang="en-US" b="1" dirty="0">
+                <a:solidFill>
+                  <a:schemeClr val="accent2"/>
+                </a:solidFill>
+              </a:rPr>
+              <a:t>SOFTSOLS PAKISTAN</a:t>
+            </a:r>
+            <a:endParaRPr lang="en-PK" b="1" dirty="0">
+              <a:solidFill>
+                <a:schemeClr val="accent2"/>
+              </a:solidFill>
+            </a:endParaRPr>
           </a:p>
         </p:txBody>
       </p:sp>
@@ -3912,7 +4106,7 @@
           <a:bodyPr/>
           <a:lstStyle/>
           <a:p>
-            <a:endParaRPr lang="en-PK"/>
+            <a:endParaRPr lang="en-PK" dirty="0"/>
           </a:p>
         </p:txBody>
       </p:sp>
@@ -4007,6 +4201,359 @@
 </file>
 
 <file path=ppt/slides/slide5.xml><?xml version="1.0" encoding="utf-8"?>
+<p:sld xmlns:a="http://schemas.openxmlformats.org/drawingml/2006/main" xmlns:r="http://schemas.openxmlformats.org/officeDocument/2006/relationships" xmlns:p="http://schemas.openxmlformats.org/presentationml/2006/main">
+  <p:cSld>
+    <p:spTree>
+      <p:nvGrpSpPr>
+        <p:cNvPr id="1" name="">
+          <a:extLst>
+            <a:ext uri="{FF2B5EF4-FFF2-40B4-BE49-F238E27FC236}">
+              <a16:creationId xmlns:a16="http://schemas.microsoft.com/office/drawing/2014/main" id="{9815AFDF-CD74-2B84-06E3-4431C143DE4A}"/>
+            </a:ext>
+          </a:extLst>
+        </p:cNvPr>
+        <p:cNvGrpSpPr/>
+        <p:nvPr/>
+      </p:nvGrpSpPr>
+      <p:grpSpPr>
+        <a:xfrm>
+          <a:off x="0" y="0"/>
+          <a:ext cx="0" cy="0"/>
+          <a:chOff x="0" y="0"/>
+          <a:chExt cx="0" cy="0"/>
+        </a:xfrm>
+      </p:grpSpPr>
+      <p:sp>
+        <p:nvSpPr>
+          <p:cNvPr id="2" name="Title 1">
+            <a:extLst>
+              <a:ext uri="{FF2B5EF4-FFF2-40B4-BE49-F238E27FC236}">
+                <a16:creationId xmlns:a16="http://schemas.microsoft.com/office/drawing/2014/main" id="{0A6BB056-094D-A333-8EC5-466C2B90E3C8}"/>
+              </a:ext>
+            </a:extLst>
+          </p:cNvPr>
+          <p:cNvSpPr>
+            <a:spLocks noGrp="1"/>
+          </p:cNvSpPr>
+          <p:nvPr>
+            <p:ph type="title"/>
+          </p:nvPr>
+        </p:nvSpPr>
+        <p:spPr/>
+        <p:txBody>
+          <a:bodyPr/>
+          <a:lstStyle/>
+          <a:p>
+            <a:r>
+              <a:rPr lang="en-US" dirty="0"/>
+              <a:t>PASSWORD RESET STEPS</a:t>
+            </a:r>
+            <a:endParaRPr lang="en-PK" dirty="0"/>
+          </a:p>
+        </p:txBody>
+      </p:sp>
+      <p:sp>
+        <p:nvSpPr>
+          <p:cNvPr id="3" name="Content Placeholder 2">
+            <a:extLst>
+              <a:ext uri="{FF2B5EF4-FFF2-40B4-BE49-F238E27FC236}">
+                <a16:creationId xmlns:a16="http://schemas.microsoft.com/office/drawing/2014/main" id="{EB565109-A1A5-3B6F-CCA2-EF18AEA4CD39}"/>
+              </a:ext>
+            </a:extLst>
+          </p:cNvPr>
+          <p:cNvSpPr>
+            <a:spLocks noGrp="1"/>
+          </p:cNvSpPr>
+          <p:nvPr>
+            <p:ph idx="1"/>
+          </p:nvPr>
+        </p:nvSpPr>
+        <p:spPr/>
+        <p:txBody>
+          <a:bodyPr/>
+          <a:lstStyle/>
+          <a:p>
+            <a:endParaRPr lang="en-PK"/>
+          </a:p>
+        </p:txBody>
+      </p:sp>
+      <p:sp>
+        <p:nvSpPr>
+          <p:cNvPr id="4" name="TextBox 3">
+            <a:extLst>
+              <a:ext uri="{FF2B5EF4-FFF2-40B4-BE49-F238E27FC236}">
+                <a16:creationId xmlns:a16="http://schemas.microsoft.com/office/drawing/2014/main" id="{7DE2F8FD-3853-9BE6-A701-FADB8423B7BD}"/>
+              </a:ext>
+            </a:extLst>
+          </p:cNvPr>
+          <p:cNvSpPr txBox="1"/>
+          <p:nvPr/>
+        </p:nvSpPr>
+        <p:spPr>
+          <a:xfrm>
+            <a:off x="152400" y="6488668"/>
+            <a:ext cx="11887200" cy="369332"/>
+          </a:xfrm>
+          <a:prstGeom prst="rect">
+            <a:avLst/>
+          </a:prstGeom>
+          <a:noFill/>
+        </p:spPr>
+        <p:txBody>
+          <a:bodyPr wrap="square" rtlCol="0">
+            <a:spAutoFit/>
+          </a:bodyPr>
+          <a:lstStyle/>
+          <a:p>
+            <a:r>
+              <a:rPr lang="en-US" b="1" dirty="0">
+                <a:solidFill>
+                  <a:srgbClr val="0070C0"/>
+                </a:solidFill>
+              </a:rPr>
+              <a:t>FACULTY OF PHARMACY AND PHARMACEUTICAL SCIENCES                                                                               </a:t>
+            </a:r>
+            <a:r>
+              <a:rPr lang="en-US" b="1" dirty="0">
+                <a:solidFill>
+                  <a:schemeClr val="accent2"/>
+                </a:solidFill>
+              </a:rPr>
+              <a:t>SOFTSOLS PAKISTAN</a:t>
+            </a:r>
+            <a:endParaRPr lang="en-PK" b="1" dirty="0">
+              <a:solidFill>
+                <a:schemeClr val="accent2"/>
+              </a:solidFill>
+            </a:endParaRPr>
+          </a:p>
+        </p:txBody>
+      </p:sp>
+    </p:spTree>
+    <p:extLst>
+      <p:ext uri="{BB962C8B-B14F-4D97-AF65-F5344CB8AC3E}">
+        <p14:creationId xmlns:p14="http://schemas.microsoft.com/office/powerpoint/2010/main" val="855210016"/>
+      </p:ext>
+    </p:extLst>
+  </p:cSld>
+  <p:clrMapOvr>
+    <a:masterClrMapping/>
+  </p:clrMapOvr>
+</p:sld>
+</file>
+
+<file path=ppt/slides/slide6.xml><?xml version="1.0" encoding="utf-8"?>
+<p:sld xmlns:a="http://schemas.openxmlformats.org/drawingml/2006/main" xmlns:r="http://schemas.openxmlformats.org/officeDocument/2006/relationships" xmlns:p="http://schemas.openxmlformats.org/presentationml/2006/main">
+  <p:cSld>
+    <p:spTree>
+      <p:nvGrpSpPr>
+        <p:cNvPr id="1" name="">
+          <a:extLst>
+            <a:ext uri="{FF2B5EF4-FFF2-40B4-BE49-F238E27FC236}">
+              <a16:creationId xmlns:a16="http://schemas.microsoft.com/office/drawing/2014/main" id="{466627F3-47A4-3FD2-419D-B9D29DAD56AC}"/>
+            </a:ext>
+          </a:extLst>
+        </p:cNvPr>
+        <p:cNvGrpSpPr/>
+        <p:nvPr/>
+      </p:nvGrpSpPr>
+      <p:grpSpPr>
+        <a:xfrm>
+          <a:off x="0" y="0"/>
+          <a:ext cx="0" cy="0"/>
+          <a:chOff x="0" y="0"/>
+          <a:chExt cx="0" cy="0"/>
+        </a:xfrm>
+      </p:grpSpPr>
+      <p:sp>
+        <p:nvSpPr>
+          <p:cNvPr id="2" name="Title 1">
+            <a:extLst>
+              <a:ext uri="{FF2B5EF4-FFF2-40B4-BE49-F238E27FC236}">
+                <a16:creationId xmlns:a16="http://schemas.microsoft.com/office/drawing/2014/main" id="{451FA9E7-73B0-4568-061E-731E7D349BFA}"/>
+              </a:ext>
+            </a:extLst>
+          </p:cNvPr>
+          <p:cNvSpPr>
+            <a:spLocks noGrp="1"/>
+          </p:cNvSpPr>
+          <p:nvPr>
+            <p:ph type="title"/>
+          </p:nvPr>
+        </p:nvSpPr>
+        <p:spPr/>
+        <p:txBody>
+          <a:bodyPr/>
+          <a:lstStyle/>
+          <a:p>
+            <a:r>
+              <a:rPr lang="en-US" b="1" dirty="0">
+                <a:solidFill>
+                  <a:srgbClr val="0070C0"/>
+                </a:solidFill>
+              </a:rPr>
+              <a:t>Reset Password</a:t>
+            </a:r>
+            <a:endParaRPr lang="en-PK" b="1" dirty="0">
+              <a:solidFill>
+                <a:srgbClr val="0070C0"/>
+              </a:solidFill>
+            </a:endParaRPr>
+          </a:p>
+        </p:txBody>
+      </p:sp>
+      <p:sp>
+        <p:nvSpPr>
+          <p:cNvPr id="4" name="Text Placeholder 3">
+            <a:extLst>
+              <a:ext uri="{FF2B5EF4-FFF2-40B4-BE49-F238E27FC236}">
+                <a16:creationId xmlns:a16="http://schemas.microsoft.com/office/drawing/2014/main" id="{835A7565-A8AE-37FF-783B-8B8D9262A2C0}"/>
+              </a:ext>
+            </a:extLst>
+          </p:cNvPr>
+          <p:cNvSpPr>
+            <a:spLocks noGrp="1"/>
+          </p:cNvSpPr>
+          <p:nvPr>
+            <p:ph type="body" sz="half" idx="2"/>
+          </p:nvPr>
+        </p:nvSpPr>
+        <p:spPr/>
+        <p:txBody>
+          <a:bodyPr/>
+          <a:lstStyle/>
+          <a:p>
+            <a:r>
+              <a:rPr lang="en-US" dirty="0"/>
+              <a:t>The confirmation message shown  on screen for Password Link Sent to the respective Email Address</a:t>
+            </a:r>
+          </a:p>
+          <a:p>
+            <a:endParaRPr lang="en-PK" dirty="0"/>
+          </a:p>
+        </p:txBody>
+      </p:sp>
+      <p:sp>
+        <p:nvSpPr>
+          <p:cNvPr id="5" name="Content Placeholder 4">
+            <a:extLst>
+              <a:ext uri="{FF2B5EF4-FFF2-40B4-BE49-F238E27FC236}">
+                <a16:creationId xmlns:a16="http://schemas.microsoft.com/office/drawing/2014/main" id="{AB36F299-0C13-AB5D-F11D-35F614842473}"/>
+              </a:ext>
+            </a:extLst>
+          </p:cNvPr>
+          <p:cNvSpPr>
+            <a:spLocks noGrp="1"/>
+          </p:cNvSpPr>
+          <p:nvPr>
+            <p:ph idx="1"/>
+          </p:nvPr>
+        </p:nvSpPr>
+        <p:spPr/>
+        <p:txBody>
+          <a:bodyPr/>
+          <a:lstStyle/>
+          <a:p>
+            <a:endParaRPr lang="en-PK"/>
+          </a:p>
+        </p:txBody>
+      </p:sp>
+      <p:pic>
+        <p:nvPicPr>
+          <p:cNvPr id="7" name="Picture 6">
+            <a:extLst>
+              <a:ext uri="{FF2B5EF4-FFF2-40B4-BE49-F238E27FC236}">
+                <a16:creationId xmlns:a16="http://schemas.microsoft.com/office/drawing/2014/main" id="{F561D4C5-B918-DF84-BDA7-FBD9A0F947B6}"/>
+              </a:ext>
+            </a:extLst>
+          </p:cNvPr>
+          <p:cNvPicPr>
+            <a:picLocks noChangeAspect="1"/>
+          </p:cNvPicPr>
+          <p:nvPr/>
+        </p:nvPicPr>
+        <p:blipFill>
+          <a:blip r:embed="rId2"/>
+          <a:stretch>
+            <a:fillRect/>
+          </a:stretch>
+        </p:blipFill>
+        <p:spPr>
+          <a:xfrm>
+            <a:off x="5046133" y="0"/>
+            <a:ext cx="7055556" cy="6378222"/>
+          </a:xfrm>
+          <a:prstGeom prst="rect">
+            <a:avLst/>
+          </a:prstGeom>
+        </p:spPr>
+      </p:pic>
+      <p:sp>
+        <p:nvSpPr>
+          <p:cNvPr id="8" name="TextBox 7">
+            <a:extLst>
+              <a:ext uri="{FF2B5EF4-FFF2-40B4-BE49-F238E27FC236}">
+                <a16:creationId xmlns:a16="http://schemas.microsoft.com/office/drawing/2014/main" id="{C345D980-CD75-838B-D401-8DB7D98C814C}"/>
+              </a:ext>
+            </a:extLst>
+          </p:cNvPr>
+          <p:cNvSpPr txBox="1"/>
+          <p:nvPr/>
+        </p:nvSpPr>
+        <p:spPr>
+          <a:xfrm>
+            <a:off x="152400" y="6488668"/>
+            <a:ext cx="11887200" cy="369332"/>
+          </a:xfrm>
+          <a:prstGeom prst="rect">
+            <a:avLst/>
+          </a:prstGeom>
+          <a:noFill/>
+        </p:spPr>
+        <p:txBody>
+          <a:bodyPr wrap="square" rtlCol="0">
+            <a:spAutoFit/>
+          </a:bodyPr>
+          <a:lstStyle/>
+          <a:p>
+            <a:r>
+              <a:rPr lang="en-US" b="1" dirty="0">
+                <a:solidFill>
+                  <a:srgbClr val="0070C0"/>
+                </a:solidFill>
+              </a:rPr>
+              <a:t>FACULTY OF PHARMACY AND PHARMACEUTICAL SCIENCES                                                                               </a:t>
+            </a:r>
+            <a:r>
+              <a:rPr lang="en-US" b="1" dirty="0">
+                <a:solidFill>
+                  <a:schemeClr val="accent2"/>
+                </a:solidFill>
+              </a:rPr>
+              <a:t>SOFTSOLS PAKISTAN</a:t>
+            </a:r>
+            <a:endParaRPr lang="en-PK" b="1" dirty="0">
+              <a:solidFill>
+                <a:schemeClr val="accent2"/>
+              </a:solidFill>
+            </a:endParaRPr>
+          </a:p>
+        </p:txBody>
+      </p:sp>
+    </p:spTree>
+    <p:extLst>
+      <p:ext uri="{BB962C8B-B14F-4D97-AF65-F5344CB8AC3E}">
+        <p14:creationId xmlns:p14="http://schemas.microsoft.com/office/powerpoint/2010/main" val="3633734758"/>
+      </p:ext>
+    </p:extLst>
+  </p:cSld>
+  <p:clrMapOvr>
+    <a:masterClrMapping/>
+  </p:clrMapOvr>
+</p:sld>
+</file>
+
+<file path=ppt/slides/slide7.xml><?xml version="1.0" encoding="utf-8"?>
 <p:sld xmlns:a="http://schemas.openxmlformats.org/drawingml/2006/main" xmlns:r="http://schemas.openxmlformats.org/officeDocument/2006/relationships" xmlns:p="http://schemas.openxmlformats.org/presentationml/2006/main">
   <p:cSld>
     <p:spTree>
@@ -4050,32 +4597,19 @@
           <a:bodyPr/>
           <a:lstStyle/>
           <a:p>
-            <a:endParaRPr lang="en-PK"/>
-          </a:p>
-        </p:txBody>
-      </p:sp>
-      <p:sp>
-        <p:nvSpPr>
-          <p:cNvPr id="3" name="Content Placeholder 2">
-            <a:extLst>
-              <a:ext uri="{FF2B5EF4-FFF2-40B4-BE49-F238E27FC236}">
-                <a16:creationId xmlns:a16="http://schemas.microsoft.com/office/drawing/2014/main" id="{7BE017C1-649A-492E-19B2-924C967111D7}"/>
-              </a:ext>
-            </a:extLst>
-          </p:cNvPr>
-          <p:cNvSpPr>
-            <a:spLocks noGrp="1"/>
-          </p:cNvSpPr>
-          <p:nvPr>
-            <p:ph idx="1"/>
-          </p:nvPr>
-        </p:nvSpPr>
-        <p:spPr/>
-        <p:txBody>
-          <a:bodyPr/>
-          <a:lstStyle/>
-          <a:p>
-            <a:endParaRPr lang="en-PK"/>
+            <a:r>
+              <a:rPr lang="en-US" dirty="0">
+                <a:solidFill>
+                  <a:srgbClr val="0070C0"/>
+                </a:solidFill>
+              </a:rPr>
+              <a:t>Email Received for Reset Link</a:t>
+            </a:r>
+            <a:endParaRPr lang="en-PK" dirty="0">
+              <a:solidFill>
+                <a:srgbClr val="0070C0"/>
+              </a:solidFill>
+            </a:endParaRPr>
           </a:p>
         </p:txBody>
       </p:sp>
@@ -4131,6 +4665,36 @@
           </a:p>
         </p:txBody>
       </p:sp>
+      <p:pic>
+        <p:nvPicPr>
+          <p:cNvPr id="12" name="Picture 11">
+            <a:extLst>
+              <a:ext uri="{FF2B5EF4-FFF2-40B4-BE49-F238E27FC236}">
+                <a16:creationId xmlns:a16="http://schemas.microsoft.com/office/drawing/2014/main" id="{0D48F520-9E03-C310-D022-34550E53A6E2}"/>
+              </a:ext>
+            </a:extLst>
+          </p:cNvPr>
+          <p:cNvPicPr>
+            <a:picLocks noChangeAspect="1"/>
+          </p:cNvPicPr>
+          <p:nvPr/>
+        </p:nvPicPr>
+        <p:blipFill>
+          <a:blip r:embed="rId2"/>
+          <a:stretch>
+            <a:fillRect/>
+          </a:stretch>
+        </p:blipFill>
+        <p:spPr>
+          <a:xfrm>
+            <a:off x="838200" y="1775371"/>
+            <a:ext cx="8725101" cy="3307258"/>
+          </a:xfrm>
+          <a:prstGeom prst="rect">
+            <a:avLst/>
+          </a:prstGeom>
+        </p:spPr>
+      </p:pic>
     </p:spTree>
     <p:extLst>
       <p:ext uri="{BB962C8B-B14F-4D97-AF65-F5344CB8AC3E}">
@@ -4144,7 +4708,7 @@
 </p:sld>
 </file>
 
-<file path=ppt/slides/slide6.xml><?xml version="1.0" encoding="utf-8"?>
+<file path=ppt/slides/slide8.xml><?xml version="1.0" encoding="utf-8"?>
 <p:sld xmlns:a="http://schemas.openxmlformats.org/drawingml/2006/main" xmlns:r="http://schemas.openxmlformats.org/officeDocument/2006/relationships" xmlns:p="http://schemas.openxmlformats.org/presentationml/2006/main">
   <p:cSld>
     <p:spTree>
@@ -4152,7 +4716,7 @@
         <p:cNvPr id="1" name="">
           <a:extLst>
             <a:ext uri="{FF2B5EF4-FFF2-40B4-BE49-F238E27FC236}">
-              <a16:creationId xmlns:a16="http://schemas.microsoft.com/office/drawing/2014/main" id="{D6188D29-524E-9030-DDF9-2FFBFB948A03}"/>
+              <a16:creationId xmlns:a16="http://schemas.microsoft.com/office/drawing/2014/main" id="{0C0E9811-B767-D58E-7C0F-5951ACC4CBD3}"/>
             </a:ext>
           </a:extLst>
         </p:cNvPr>
@@ -4172,7 +4736,7 @@
           <p:cNvPr id="2" name="Title 1">
             <a:extLst>
               <a:ext uri="{FF2B5EF4-FFF2-40B4-BE49-F238E27FC236}">
-                <a16:creationId xmlns:a16="http://schemas.microsoft.com/office/drawing/2014/main" id="{2745430A-9B0F-D826-8B17-198B41B9B6E3}"/>
+                <a16:creationId xmlns:a16="http://schemas.microsoft.com/office/drawing/2014/main" id="{3424ED0D-7A7C-0D98-B7C6-1DBB93031F3F}"/>
               </a:ext>
             </a:extLst>
           </p:cNvPr>
@@ -4188,16 +4752,59 @@
           <a:bodyPr/>
           <a:lstStyle/>
           <a:p>
-            <a:endParaRPr lang="en-PK"/>
-          </a:p>
-        </p:txBody>
-      </p:sp>
-      <p:sp>
-        <p:nvSpPr>
-          <p:cNvPr id="3" name="Content Placeholder 2">
-            <a:extLst>
-              <a:ext uri="{FF2B5EF4-FFF2-40B4-BE49-F238E27FC236}">
-                <a16:creationId xmlns:a16="http://schemas.microsoft.com/office/drawing/2014/main" id="{C686B506-1C06-0EC6-7279-1083653DB0F7}"/>
+            <a:r>
+              <a:rPr lang="en-US" b="1" dirty="0">
+                <a:solidFill>
+                  <a:srgbClr val="0070C0"/>
+                </a:solidFill>
+              </a:rPr>
+              <a:t>Reset Password</a:t>
+            </a:r>
+            <a:endParaRPr lang="en-PK" b="1" dirty="0">
+              <a:solidFill>
+                <a:srgbClr val="0070C0"/>
+              </a:solidFill>
+            </a:endParaRPr>
+          </a:p>
+        </p:txBody>
+      </p:sp>
+      <p:sp>
+        <p:nvSpPr>
+          <p:cNvPr id="4" name="Text Placeholder 3">
+            <a:extLst>
+              <a:ext uri="{FF2B5EF4-FFF2-40B4-BE49-F238E27FC236}">
+                <a16:creationId xmlns:a16="http://schemas.microsoft.com/office/drawing/2014/main" id="{0E345E06-DEED-D8B6-6179-FF6EF2F0119D}"/>
+              </a:ext>
+            </a:extLst>
+          </p:cNvPr>
+          <p:cNvSpPr>
+            <a:spLocks noGrp="1"/>
+          </p:cNvSpPr>
+          <p:nvPr>
+            <p:ph type="body" sz="half" idx="2"/>
+          </p:nvPr>
+        </p:nvSpPr>
+        <p:spPr/>
+        <p:txBody>
+          <a:bodyPr/>
+          <a:lstStyle/>
+          <a:p>
+            <a:r>
+              <a:rPr lang="en-US" dirty="0"/>
+              <a:t>The confirmation message shown  on screen for Password Link Sent to the respective Email Address</a:t>
+            </a:r>
+          </a:p>
+          <a:p>
+            <a:endParaRPr lang="en-PK" dirty="0"/>
+          </a:p>
+        </p:txBody>
+      </p:sp>
+      <p:sp>
+        <p:nvSpPr>
+          <p:cNvPr id="5" name="Content Placeholder 4">
+            <a:extLst>
+              <a:ext uri="{FF2B5EF4-FFF2-40B4-BE49-F238E27FC236}">
+                <a16:creationId xmlns:a16="http://schemas.microsoft.com/office/drawing/2014/main" id="{51C36F93-F27F-8E69-8E1C-6F4A903F7B86}"/>
               </a:ext>
             </a:extLst>
           </p:cNvPr>
@@ -4219,10 +4826,10 @@
       </p:sp>
       <p:sp>
         <p:nvSpPr>
-          <p:cNvPr id="4" name="TextBox 3">
-            <a:extLst>
-              <a:ext uri="{FF2B5EF4-FFF2-40B4-BE49-F238E27FC236}">
-                <a16:creationId xmlns:a16="http://schemas.microsoft.com/office/drawing/2014/main" id="{B389A75D-8D27-03FF-9B3B-4F371BF90BCE}"/>
+          <p:cNvPr id="8" name="TextBox 7">
+            <a:extLst>
+              <a:ext uri="{FF2B5EF4-FFF2-40B4-BE49-F238E27FC236}">
+                <a16:creationId xmlns:a16="http://schemas.microsoft.com/office/drawing/2014/main" id="{7C805266-21D8-C692-4D37-F9D08D86ED22}"/>
               </a:ext>
             </a:extLst>
           </p:cNvPr>
@@ -4269,10 +4876,234 @@
           </a:p>
         </p:txBody>
       </p:sp>
+      <p:pic>
+        <p:nvPicPr>
+          <p:cNvPr id="6" name="Picture 5">
+            <a:extLst>
+              <a:ext uri="{FF2B5EF4-FFF2-40B4-BE49-F238E27FC236}">
+                <a16:creationId xmlns:a16="http://schemas.microsoft.com/office/drawing/2014/main" id="{E790707B-CBE8-A0CB-96E6-D1701C35D33A}"/>
+              </a:ext>
+            </a:extLst>
+          </p:cNvPr>
+          <p:cNvPicPr>
+            <a:picLocks noChangeAspect="1"/>
+          </p:cNvPicPr>
+          <p:nvPr/>
+        </p:nvPicPr>
+        <p:blipFill>
+          <a:blip r:embed="rId2"/>
+          <a:stretch>
+            <a:fillRect/>
+          </a:stretch>
+        </p:blipFill>
+        <p:spPr>
+          <a:xfrm>
+            <a:off x="5034985" y="0"/>
+            <a:ext cx="6637726" cy="6261742"/>
+          </a:xfrm>
+          <a:prstGeom prst="rect">
+            <a:avLst/>
+          </a:prstGeom>
+        </p:spPr>
+      </p:pic>
     </p:spTree>
     <p:extLst>
       <p:ext uri="{BB962C8B-B14F-4D97-AF65-F5344CB8AC3E}">
-        <p14:creationId xmlns:p14="http://schemas.microsoft.com/office/powerpoint/2010/main" val="3053948027"/>
+        <p14:creationId xmlns:p14="http://schemas.microsoft.com/office/powerpoint/2010/main" val="367568422"/>
+      </p:ext>
+    </p:extLst>
+  </p:cSld>
+  <p:clrMapOvr>
+    <a:masterClrMapping/>
+  </p:clrMapOvr>
+</p:sld>
+</file>
+
+<file path=ppt/slides/slide9.xml><?xml version="1.0" encoding="utf-8"?>
+<p:sld xmlns:a="http://schemas.openxmlformats.org/drawingml/2006/main" xmlns:r="http://schemas.openxmlformats.org/officeDocument/2006/relationships" xmlns:p="http://schemas.openxmlformats.org/presentationml/2006/main">
+  <p:cSld>
+    <p:spTree>
+      <p:nvGrpSpPr>
+        <p:cNvPr id="1" name="">
+          <a:extLst>
+            <a:ext uri="{FF2B5EF4-FFF2-40B4-BE49-F238E27FC236}">
+              <a16:creationId xmlns:a16="http://schemas.microsoft.com/office/drawing/2014/main" id="{7CC6B399-AC1C-5E1D-5927-0A7A63E8E9ED}"/>
+            </a:ext>
+          </a:extLst>
+        </p:cNvPr>
+        <p:cNvGrpSpPr/>
+        <p:nvPr/>
+      </p:nvGrpSpPr>
+      <p:grpSpPr>
+        <a:xfrm>
+          <a:off x="0" y="0"/>
+          <a:ext cx="0" cy="0"/>
+          <a:chOff x="0" y="0"/>
+          <a:chExt cx="0" cy="0"/>
+        </a:xfrm>
+      </p:grpSpPr>
+      <p:sp>
+        <p:nvSpPr>
+          <p:cNvPr id="2" name="Title 1">
+            <a:extLst>
+              <a:ext uri="{FF2B5EF4-FFF2-40B4-BE49-F238E27FC236}">
+                <a16:creationId xmlns:a16="http://schemas.microsoft.com/office/drawing/2014/main" id="{2870E369-BFA4-3DAA-406F-AF0C219CA3AF}"/>
+              </a:ext>
+            </a:extLst>
+          </p:cNvPr>
+          <p:cNvSpPr>
+            <a:spLocks noGrp="1"/>
+          </p:cNvSpPr>
+          <p:nvPr>
+            <p:ph type="title"/>
+          </p:nvPr>
+        </p:nvSpPr>
+        <p:spPr/>
+        <p:txBody>
+          <a:bodyPr/>
+          <a:lstStyle/>
+          <a:p>
+            <a:r>
+              <a:rPr lang="en-US" b="1" dirty="0">
+                <a:solidFill>
+                  <a:srgbClr val="0070C0"/>
+                </a:solidFill>
+              </a:rPr>
+              <a:t>Reset Password</a:t>
+            </a:r>
+            <a:endParaRPr lang="en-PK" b="1" dirty="0">
+              <a:solidFill>
+                <a:srgbClr val="0070C0"/>
+              </a:solidFill>
+            </a:endParaRPr>
+          </a:p>
+        </p:txBody>
+      </p:sp>
+      <p:sp>
+        <p:nvSpPr>
+          <p:cNvPr id="4" name="Text Placeholder 3">
+            <a:extLst>
+              <a:ext uri="{FF2B5EF4-FFF2-40B4-BE49-F238E27FC236}">
+                <a16:creationId xmlns:a16="http://schemas.microsoft.com/office/drawing/2014/main" id="{7A7C57E4-B7DB-9435-8DDF-E9C7EEF67FCA}"/>
+              </a:ext>
+            </a:extLst>
+          </p:cNvPr>
+          <p:cNvSpPr>
+            <a:spLocks noGrp="1"/>
+          </p:cNvSpPr>
+          <p:nvPr>
+            <p:ph type="body" sz="half" idx="2"/>
+          </p:nvPr>
+        </p:nvSpPr>
+        <p:spPr/>
+        <p:txBody>
+          <a:bodyPr/>
+          <a:lstStyle/>
+          <a:p>
+            <a:r>
+              <a:rPr lang="en-US" dirty="0"/>
+              <a:t>Confirmation on Screen about Password changed.</a:t>
+            </a:r>
+          </a:p>
+          <a:p>
+            <a:r>
+              <a:rPr lang="en-US" dirty="0"/>
+              <a:t>You will login with New Password.</a:t>
+            </a:r>
+          </a:p>
+          <a:p>
+            <a:endParaRPr lang="en-PK" dirty="0"/>
+          </a:p>
+        </p:txBody>
+      </p:sp>
+      <p:pic>
+        <p:nvPicPr>
+          <p:cNvPr id="6" name="Content Placeholder 5">
+            <a:extLst>
+              <a:ext uri="{FF2B5EF4-FFF2-40B4-BE49-F238E27FC236}">
+                <a16:creationId xmlns:a16="http://schemas.microsoft.com/office/drawing/2014/main" id="{36D23433-85D2-3302-9C2C-56FF1843BC78}"/>
+              </a:ext>
+            </a:extLst>
+          </p:cNvPr>
+          <p:cNvPicPr>
+            <a:picLocks noGrp="1" noChangeAspect="1"/>
+          </p:cNvPicPr>
+          <p:nvPr>
+            <p:ph idx="1"/>
+          </p:nvPr>
+        </p:nvPicPr>
+        <p:blipFill>
+          <a:blip r:embed="rId2"/>
+          <a:stretch>
+            <a:fillRect/>
+          </a:stretch>
+        </p:blipFill>
+        <p:spPr>
+          <a:xfrm>
+            <a:off x="6197600" y="626181"/>
+            <a:ext cx="4865511" cy="5695597"/>
+          </a:xfrm>
+          <a:prstGeom prst="rect">
+            <a:avLst/>
+          </a:prstGeom>
+        </p:spPr>
+      </p:pic>
+      <p:sp>
+        <p:nvSpPr>
+          <p:cNvPr id="8" name="TextBox 7">
+            <a:extLst>
+              <a:ext uri="{FF2B5EF4-FFF2-40B4-BE49-F238E27FC236}">
+                <a16:creationId xmlns:a16="http://schemas.microsoft.com/office/drawing/2014/main" id="{48CE0525-2852-079A-A795-5141E481C4BB}"/>
+              </a:ext>
+            </a:extLst>
+          </p:cNvPr>
+          <p:cNvSpPr txBox="1"/>
+          <p:nvPr/>
+        </p:nvSpPr>
+        <p:spPr>
+          <a:xfrm>
+            <a:off x="152400" y="6488668"/>
+            <a:ext cx="11887200" cy="369332"/>
+          </a:xfrm>
+          <a:prstGeom prst="rect">
+            <a:avLst/>
+          </a:prstGeom>
+          <a:noFill/>
+        </p:spPr>
+        <p:txBody>
+          <a:bodyPr wrap="square" rtlCol="0">
+            <a:spAutoFit/>
+          </a:bodyPr>
+          <a:lstStyle/>
+          <a:p>
+            <a:r>
+              <a:rPr lang="en-US" b="1" dirty="0">
+                <a:solidFill>
+                  <a:srgbClr val="0070C0"/>
+                </a:solidFill>
+              </a:rPr>
+              <a:t>FACULTY OF PHARMACY AND PHARMACEUTICAL SCIENCES                                                                               </a:t>
+            </a:r>
+            <a:r>
+              <a:rPr lang="en-US" b="1" dirty="0">
+                <a:solidFill>
+                  <a:schemeClr val="accent2"/>
+                </a:solidFill>
+              </a:rPr>
+              <a:t>SOFTSOLS PAKISTAN</a:t>
+            </a:r>
+            <a:endParaRPr lang="en-PK" b="1" dirty="0">
+              <a:solidFill>
+                <a:schemeClr val="accent2"/>
+              </a:solidFill>
+            </a:endParaRPr>
+          </a:p>
+        </p:txBody>
+      </p:sp>
+    </p:spTree>
+    <p:extLst>
+      <p:ext uri="{BB962C8B-B14F-4D97-AF65-F5344CB8AC3E}">
+        <p14:creationId xmlns:p14="http://schemas.microsoft.com/office/powerpoint/2010/main" val="663351100"/>
       </p:ext>
     </p:extLst>
   </p:cSld>

</xml_diff>

<commit_message>
fix: Resolve Live Session dropdown issues and correctly display scheduled lectures.
</commit_message>
<xml_diff>
--- a/STUDENT REGISTRATION.pptx
+++ b/STUDENT REGISTRATION.pptx
@@ -13,8 +13,14 @@
     <p:sldId id="262" r:id="rId7"/>
     <p:sldId id="259" r:id="rId8"/>
     <p:sldId id="263" r:id="rId9"/>
-    <p:sldId id="264" r:id="rId10"/>
-    <p:sldId id="260" r:id="rId11"/>
+    <p:sldId id="260" r:id="rId10"/>
+    <p:sldId id="266" r:id="rId11"/>
+    <p:sldId id="267" r:id="rId12"/>
+    <p:sldId id="268" r:id="rId13"/>
+    <p:sldId id="269" r:id="rId14"/>
+    <p:sldId id="270" r:id="rId15"/>
+    <p:sldId id="271" r:id="rId16"/>
+    <p:sldId id="264" r:id="rId17"/>
   </p:sldIdLst>
   <p:sldSz cx="12192000" cy="6858000"/>
   <p:notesSz cx="6858000" cy="9144000"/>
@@ -3569,7 +3575,7 @@
         <p:cNvPr id="1" name="">
           <a:extLst>
             <a:ext uri="{FF2B5EF4-FFF2-40B4-BE49-F238E27FC236}">
-              <a16:creationId xmlns:a16="http://schemas.microsoft.com/office/drawing/2014/main" id="{D6188D29-524E-9030-DDF9-2FFBFB948A03}"/>
+              <a16:creationId xmlns:a16="http://schemas.microsoft.com/office/drawing/2014/main" id="{417AA6B0-EA62-B8D9-8F4B-172F4765AA7A}"/>
             </a:ext>
           </a:extLst>
         </p:cNvPr>
@@ -3589,7 +3595,7 @@
           <p:cNvPr id="2" name="Title 1">
             <a:extLst>
               <a:ext uri="{FF2B5EF4-FFF2-40B4-BE49-F238E27FC236}">
-                <a16:creationId xmlns:a16="http://schemas.microsoft.com/office/drawing/2014/main" id="{2745430A-9B0F-D826-8B17-198B41B9B6E3}"/>
+                <a16:creationId xmlns:a16="http://schemas.microsoft.com/office/drawing/2014/main" id="{CCCE2A8D-D636-1277-EDFA-23D14389CD33}"/>
               </a:ext>
             </a:extLst>
           </p:cNvPr>
@@ -3614,7 +3620,7 @@
           <p:cNvPr id="3" name="Content Placeholder 2">
             <a:extLst>
               <a:ext uri="{FF2B5EF4-FFF2-40B4-BE49-F238E27FC236}">
-                <a16:creationId xmlns:a16="http://schemas.microsoft.com/office/drawing/2014/main" id="{C686B506-1C06-0EC6-7279-1083653DB0F7}"/>
+                <a16:creationId xmlns:a16="http://schemas.microsoft.com/office/drawing/2014/main" id="{8AFE47A1-F6C3-36E9-C876-936D3582C19B}"/>
               </a:ext>
             </a:extLst>
           </p:cNvPr>
@@ -3639,7 +3645,7 @@
           <p:cNvPr id="4" name="TextBox 3">
             <a:extLst>
               <a:ext uri="{FF2B5EF4-FFF2-40B4-BE49-F238E27FC236}">
-                <a16:creationId xmlns:a16="http://schemas.microsoft.com/office/drawing/2014/main" id="{B389A75D-8D27-03FF-9B3B-4F371BF90BCE}"/>
+                <a16:creationId xmlns:a16="http://schemas.microsoft.com/office/drawing/2014/main" id="{02C7E35E-6DD7-E97D-C057-8FC8E3849A14}"/>
               </a:ext>
             </a:extLst>
           </p:cNvPr>
@@ -3689,7 +3695,891 @@
     </p:spTree>
     <p:extLst>
       <p:ext uri="{BB962C8B-B14F-4D97-AF65-F5344CB8AC3E}">
-        <p14:creationId xmlns:p14="http://schemas.microsoft.com/office/powerpoint/2010/main" val="3053948027"/>
+        <p14:creationId xmlns:p14="http://schemas.microsoft.com/office/powerpoint/2010/main" val="1272446270"/>
+      </p:ext>
+    </p:extLst>
+  </p:cSld>
+  <p:clrMapOvr>
+    <a:masterClrMapping/>
+  </p:clrMapOvr>
+</p:sld>
+</file>
+
+<file path=ppt/slides/slide11.xml><?xml version="1.0" encoding="utf-8"?>
+<p:sld xmlns:a="http://schemas.openxmlformats.org/drawingml/2006/main" xmlns:r="http://schemas.openxmlformats.org/officeDocument/2006/relationships" xmlns:p="http://schemas.openxmlformats.org/presentationml/2006/main">
+  <p:cSld>
+    <p:spTree>
+      <p:nvGrpSpPr>
+        <p:cNvPr id="1" name="">
+          <a:extLst>
+            <a:ext uri="{FF2B5EF4-FFF2-40B4-BE49-F238E27FC236}">
+              <a16:creationId xmlns:a16="http://schemas.microsoft.com/office/drawing/2014/main" id="{1F246CC1-3EEE-232A-97DB-FDE4C5C155DF}"/>
+            </a:ext>
+          </a:extLst>
+        </p:cNvPr>
+        <p:cNvGrpSpPr/>
+        <p:nvPr/>
+      </p:nvGrpSpPr>
+      <p:grpSpPr>
+        <a:xfrm>
+          <a:off x="0" y="0"/>
+          <a:ext cx="0" cy="0"/>
+          <a:chOff x="0" y="0"/>
+          <a:chExt cx="0" cy="0"/>
+        </a:xfrm>
+      </p:grpSpPr>
+      <p:sp>
+        <p:nvSpPr>
+          <p:cNvPr id="2" name="Title 1">
+            <a:extLst>
+              <a:ext uri="{FF2B5EF4-FFF2-40B4-BE49-F238E27FC236}">
+                <a16:creationId xmlns:a16="http://schemas.microsoft.com/office/drawing/2014/main" id="{69104813-3D9C-C967-DC29-4AD960165950}"/>
+              </a:ext>
+            </a:extLst>
+          </p:cNvPr>
+          <p:cNvSpPr>
+            <a:spLocks noGrp="1"/>
+          </p:cNvSpPr>
+          <p:nvPr>
+            <p:ph type="title"/>
+          </p:nvPr>
+        </p:nvSpPr>
+        <p:spPr/>
+        <p:txBody>
+          <a:bodyPr/>
+          <a:lstStyle/>
+          <a:p>
+            <a:endParaRPr lang="en-PK"/>
+          </a:p>
+        </p:txBody>
+      </p:sp>
+      <p:sp>
+        <p:nvSpPr>
+          <p:cNvPr id="3" name="Content Placeholder 2">
+            <a:extLst>
+              <a:ext uri="{FF2B5EF4-FFF2-40B4-BE49-F238E27FC236}">
+                <a16:creationId xmlns:a16="http://schemas.microsoft.com/office/drawing/2014/main" id="{4706C792-BEAC-10DB-D9C5-1A1AF109E246}"/>
+              </a:ext>
+            </a:extLst>
+          </p:cNvPr>
+          <p:cNvSpPr>
+            <a:spLocks noGrp="1"/>
+          </p:cNvSpPr>
+          <p:nvPr>
+            <p:ph idx="1"/>
+          </p:nvPr>
+        </p:nvSpPr>
+        <p:spPr/>
+        <p:txBody>
+          <a:bodyPr/>
+          <a:lstStyle/>
+          <a:p>
+            <a:endParaRPr lang="en-PK"/>
+          </a:p>
+        </p:txBody>
+      </p:sp>
+      <p:sp>
+        <p:nvSpPr>
+          <p:cNvPr id="4" name="TextBox 3">
+            <a:extLst>
+              <a:ext uri="{FF2B5EF4-FFF2-40B4-BE49-F238E27FC236}">
+                <a16:creationId xmlns:a16="http://schemas.microsoft.com/office/drawing/2014/main" id="{DD38232D-3758-F081-79C7-76848A9D49C7}"/>
+              </a:ext>
+            </a:extLst>
+          </p:cNvPr>
+          <p:cNvSpPr txBox="1"/>
+          <p:nvPr/>
+        </p:nvSpPr>
+        <p:spPr>
+          <a:xfrm>
+            <a:off x="152400" y="6488668"/>
+            <a:ext cx="11887200" cy="369332"/>
+          </a:xfrm>
+          <a:prstGeom prst="rect">
+            <a:avLst/>
+          </a:prstGeom>
+          <a:noFill/>
+        </p:spPr>
+        <p:txBody>
+          <a:bodyPr wrap="square" rtlCol="0">
+            <a:spAutoFit/>
+          </a:bodyPr>
+          <a:lstStyle/>
+          <a:p>
+            <a:r>
+              <a:rPr lang="en-US" b="1" dirty="0">
+                <a:solidFill>
+                  <a:srgbClr val="0070C0"/>
+                </a:solidFill>
+              </a:rPr>
+              <a:t>FACULTY OF PHARMACY AND PHARMACEUTICAL SCIENCES                                                                               </a:t>
+            </a:r>
+            <a:r>
+              <a:rPr lang="en-US" b="1" dirty="0">
+                <a:solidFill>
+                  <a:schemeClr val="accent2"/>
+                </a:solidFill>
+              </a:rPr>
+              <a:t>SOFTSOLS PAKISTAN</a:t>
+            </a:r>
+            <a:endParaRPr lang="en-PK" b="1" dirty="0">
+              <a:solidFill>
+                <a:schemeClr val="accent2"/>
+              </a:solidFill>
+            </a:endParaRPr>
+          </a:p>
+        </p:txBody>
+      </p:sp>
+    </p:spTree>
+    <p:extLst>
+      <p:ext uri="{BB962C8B-B14F-4D97-AF65-F5344CB8AC3E}">
+        <p14:creationId xmlns:p14="http://schemas.microsoft.com/office/powerpoint/2010/main" val="2792856011"/>
+      </p:ext>
+    </p:extLst>
+  </p:cSld>
+  <p:clrMapOvr>
+    <a:masterClrMapping/>
+  </p:clrMapOvr>
+</p:sld>
+</file>
+
+<file path=ppt/slides/slide12.xml><?xml version="1.0" encoding="utf-8"?>
+<p:sld xmlns:a="http://schemas.openxmlformats.org/drawingml/2006/main" xmlns:r="http://schemas.openxmlformats.org/officeDocument/2006/relationships" xmlns:p="http://schemas.openxmlformats.org/presentationml/2006/main">
+  <p:cSld>
+    <p:spTree>
+      <p:nvGrpSpPr>
+        <p:cNvPr id="1" name="">
+          <a:extLst>
+            <a:ext uri="{FF2B5EF4-FFF2-40B4-BE49-F238E27FC236}">
+              <a16:creationId xmlns:a16="http://schemas.microsoft.com/office/drawing/2014/main" id="{9B5254DB-ADA3-B7BE-4C31-7D082AB7B2AE}"/>
+            </a:ext>
+          </a:extLst>
+        </p:cNvPr>
+        <p:cNvGrpSpPr/>
+        <p:nvPr/>
+      </p:nvGrpSpPr>
+      <p:grpSpPr>
+        <a:xfrm>
+          <a:off x="0" y="0"/>
+          <a:ext cx="0" cy="0"/>
+          <a:chOff x="0" y="0"/>
+          <a:chExt cx="0" cy="0"/>
+        </a:xfrm>
+      </p:grpSpPr>
+      <p:sp>
+        <p:nvSpPr>
+          <p:cNvPr id="2" name="Title 1">
+            <a:extLst>
+              <a:ext uri="{FF2B5EF4-FFF2-40B4-BE49-F238E27FC236}">
+                <a16:creationId xmlns:a16="http://schemas.microsoft.com/office/drawing/2014/main" id="{20176479-9A84-D6EA-14FD-C38201841E16}"/>
+              </a:ext>
+            </a:extLst>
+          </p:cNvPr>
+          <p:cNvSpPr>
+            <a:spLocks noGrp="1"/>
+          </p:cNvSpPr>
+          <p:nvPr>
+            <p:ph type="title"/>
+          </p:nvPr>
+        </p:nvSpPr>
+        <p:spPr/>
+        <p:txBody>
+          <a:bodyPr/>
+          <a:lstStyle/>
+          <a:p>
+            <a:endParaRPr lang="en-PK"/>
+          </a:p>
+        </p:txBody>
+      </p:sp>
+      <p:sp>
+        <p:nvSpPr>
+          <p:cNvPr id="3" name="Content Placeholder 2">
+            <a:extLst>
+              <a:ext uri="{FF2B5EF4-FFF2-40B4-BE49-F238E27FC236}">
+                <a16:creationId xmlns:a16="http://schemas.microsoft.com/office/drawing/2014/main" id="{2DB52420-4189-3275-0B03-096F7A5600B2}"/>
+              </a:ext>
+            </a:extLst>
+          </p:cNvPr>
+          <p:cNvSpPr>
+            <a:spLocks noGrp="1"/>
+          </p:cNvSpPr>
+          <p:nvPr>
+            <p:ph idx="1"/>
+          </p:nvPr>
+        </p:nvSpPr>
+        <p:spPr/>
+        <p:txBody>
+          <a:bodyPr/>
+          <a:lstStyle/>
+          <a:p>
+            <a:endParaRPr lang="en-PK"/>
+          </a:p>
+        </p:txBody>
+      </p:sp>
+      <p:sp>
+        <p:nvSpPr>
+          <p:cNvPr id="4" name="TextBox 3">
+            <a:extLst>
+              <a:ext uri="{FF2B5EF4-FFF2-40B4-BE49-F238E27FC236}">
+                <a16:creationId xmlns:a16="http://schemas.microsoft.com/office/drawing/2014/main" id="{0A7E4356-78CB-9D4C-4101-1CD06109856B}"/>
+              </a:ext>
+            </a:extLst>
+          </p:cNvPr>
+          <p:cNvSpPr txBox="1"/>
+          <p:nvPr/>
+        </p:nvSpPr>
+        <p:spPr>
+          <a:xfrm>
+            <a:off x="152400" y="6488668"/>
+            <a:ext cx="11887200" cy="369332"/>
+          </a:xfrm>
+          <a:prstGeom prst="rect">
+            <a:avLst/>
+          </a:prstGeom>
+          <a:noFill/>
+        </p:spPr>
+        <p:txBody>
+          <a:bodyPr wrap="square" rtlCol="0">
+            <a:spAutoFit/>
+          </a:bodyPr>
+          <a:lstStyle/>
+          <a:p>
+            <a:r>
+              <a:rPr lang="en-US" b="1" dirty="0">
+                <a:solidFill>
+                  <a:srgbClr val="0070C0"/>
+                </a:solidFill>
+              </a:rPr>
+              <a:t>FACULTY OF PHARMACY AND PHARMACEUTICAL SCIENCES                                                                               </a:t>
+            </a:r>
+            <a:r>
+              <a:rPr lang="en-US" b="1" dirty="0">
+                <a:solidFill>
+                  <a:schemeClr val="accent2"/>
+                </a:solidFill>
+              </a:rPr>
+              <a:t>SOFTSOLS PAKISTAN</a:t>
+            </a:r>
+            <a:endParaRPr lang="en-PK" b="1" dirty="0">
+              <a:solidFill>
+                <a:schemeClr val="accent2"/>
+              </a:solidFill>
+            </a:endParaRPr>
+          </a:p>
+        </p:txBody>
+      </p:sp>
+    </p:spTree>
+    <p:extLst>
+      <p:ext uri="{BB962C8B-B14F-4D97-AF65-F5344CB8AC3E}">
+        <p14:creationId xmlns:p14="http://schemas.microsoft.com/office/powerpoint/2010/main" val="1084159943"/>
+      </p:ext>
+    </p:extLst>
+  </p:cSld>
+  <p:clrMapOvr>
+    <a:masterClrMapping/>
+  </p:clrMapOvr>
+</p:sld>
+</file>
+
+<file path=ppt/slides/slide13.xml><?xml version="1.0" encoding="utf-8"?>
+<p:sld xmlns:a="http://schemas.openxmlformats.org/drawingml/2006/main" xmlns:r="http://schemas.openxmlformats.org/officeDocument/2006/relationships" xmlns:p="http://schemas.openxmlformats.org/presentationml/2006/main">
+  <p:cSld>
+    <p:spTree>
+      <p:nvGrpSpPr>
+        <p:cNvPr id="1" name="">
+          <a:extLst>
+            <a:ext uri="{FF2B5EF4-FFF2-40B4-BE49-F238E27FC236}">
+              <a16:creationId xmlns:a16="http://schemas.microsoft.com/office/drawing/2014/main" id="{5E931C6F-5FA5-5046-C1AB-6CF052E71156}"/>
+            </a:ext>
+          </a:extLst>
+        </p:cNvPr>
+        <p:cNvGrpSpPr/>
+        <p:nvPr/>
+      </p:nvGrpSpPr>
+      <p:grpSpPr>
+        <a:xfrm>
+          <a:off x="0" y="0"/>
+          <a:ext cx="0" cy="0"/>
+          <a:chOff x="0" y="0"/>
+          <a:chExt cx="0" cy="0"/>
+        </a:xfrm>
+      </p:grpSpPr>
+      <p:sp>
+        <p:nvSpPr>
+          <p:cNvPr id="2" name="Title 1">
+            <a:extLst>
+              <a:ext uri="{FF2B5EF4-FFF2-40B4-BE49-F238E27FC236}">
+                <a16:creationId xmlns:a16="http://schemas.microsoft.com/office/drawing/2014/main" id="{A8BB61C2-6332-754F-8B45-579D7EEAAF73}"/>
+              </a:ext>
+            </a:extLst>
+          </p:cNvPr>
+          <p:cNvSpPr>
+            <a:spLocks noGrp="1"/>
+          </p:cNvSpPr>
+          <p:nvPr>
+            <p:ph type="title"/>
+          </p:nvPr>
+        </p:nvSpPr>
+        <p:spPr/>
+        <p:txBody>
+          <a:bodyPr/>
+          <a:lstStyle/>
+          <a:p>
+            <a:endParaRPr lang="en-PK"/>
+          </a:p>
+        </p:txBody>
+      </p:sp>
+      <p:sp>
+        <p:nvSpPr>
+          <p:cNvPr id="3" name="Content Placeholder 2">
+            <a:extLst>
+              <a:ext uri="{FF2B5EF4-FFF2-40B4-BE49-F238E27FC236}">
+                <a16:creationId xmlns:a16="http://schemas.microsoft.com/office/drawing/2014/main" id="{F4E42094-EB03-4D0F-2D94-279E6BFA12E2}"/>
+              </a:ext>
+            </a:extLst>
+          </p:cNvPr>
+          <p:cNvSpPr>
+            <a:spLocks noGrp="1"/>
+          </p:cNvSpPr>
+          <p:nvPr>
+            <p:ph idx="1"/>
+          </p:nvPr>
+        </p:nvSpPr>
+        <p:spPr/>
+        <p:txBody>
+          <a:bodyPr/>
+          <a:lstStyle/>
+          <a:p>
+            <a:endParaRPr lang="en-PK"/>
+          </a:p>
+        </p:txBody>
+      </p:sp>
+      <p:sp>
+        <p:nvSpPr>
+          <p:cNvPr id="4" name="TextBox 3">
+            <a:extLst>
+              <a:ext uri="{FF2B5EF4-FFF2-40B4-BE49-F238E27FC236}">
+                <a16:creationId xmlns:a16="http://schemas.microsoft.com/office/drawing/2014/main" id="{BC158E87-A0EF-164F-B1A7-094642852BB4}"/>
+              </a:ext>
+            </a:extLst>
+          </p:cNvPr>
+          <p:cNvSpPr txBox="1"/>
+          <p:nvPr/>
+        </p:nvSpPr>
+        <p:spPr>
+          <a:xfrm>
+            <a:off x="152400" y="6488668"/>
+            <a:ext cx="11887200" cy="369332"/>
+          </a:xfrm>
+          <a:prstGeom prst="rect">
+            <a:avLst/>
+          </a:prstGeom>
+          <a:noFill/>
+        </p:spPr>
+        <p:txBody>
+          <a:bodyPr wrap="square" rtlCol="0">
+            <a:spAutoFit/>
+          </a:bodyPr>
+          <a:lstStyle/>
+          <a:p>
+            <a:r>
+              <a:rPr lang="en-US" b="1" dirty="0">
+                <a:solidFill>
+                  <a:srgbClr val="0070C0"/>
+                </a:solidFill>
+              </a:rPr>
+              <a:t>FACULTY OF PHARMACY AND PHARMACEUTICAL SCIENCES                                                                               </a:t>
+            </a:r>
+            <a:r>
+              <a:rPr lang="en-US" b="1" dirty="0">
+                <a:solidFill>
+                  <a:schemeClr val="accent2"/>
+                </a:solidFill>
+              </a:rPr>
+              <a:t>SOFTSOLS PAKISTAN</a:t>
+            </a:r>
+            <a:endParaRPr lang="en-PK" b="1" dirty="0">
+              <a:solidFill>
+                <a:schemeClr val="accent2"/>
+              </a:solidFill>
+            </a:endParaRPr>
+          </a:p>
+        </p:txBody>
+      </p:sp>
+    </p:spTree>
+    <p:extLst>
+      <p:ext uri="{BB962C8B-B14F-4D97-AF65-F5344CB8AC3E}">
+        <p14:creationId xmlns:p14="http://schemas.microsoft.com/office/powerpoint/2010/main" val="2017795440"/>
+      </p:ext>
+    </p:extLst>
+  </p:cSld>
+  <p:clrMapOvr>
+    <a:masterClrMapping/>
+  </p:clrMapOvr>
+</p:sld>
+</file>
+
+<file path=ppt/slides/slide14.xml><?xml version="1.0" encoding="utf-8"?>
+<p:sld xmlns:a="http://schemas.openxmlformats.org/drawingml/2006/main" xmlns:r="http://schemas.openxmlformats.org/officeDocument/2006/relationships" xmlns:p="http://schemas.openxmlformats.org/presentationml/2006/main">
+  <p:cSld>
+    <p:spTree>
+      <p:nvGrpSpPr>
+        <p:cNvPr id="1" name="">
+          <a:extLst>
+            <a:ext uri="{FF2B5EF4-FFF2-40B4-BE49-F238E27FC236}">
+              <a16:creationId xmlns:a16="http://schemas.microsoft.com/office/drawing/2014/main" id="{C5058DD3-5E18-AA42-0926-509EBDC3EC61}"/>
+            </a:ext>
+          </a:extLst>
+        </p:cNvPr>
+        <p:cNvGrpSpPr/>
+        <p:nvPr/>
+      </p:nvGrpSpPr>
+      <p:grpSpPr>
+        <a:xfrm>
+          <a:off x="0" y="0"/>
+          <a:ext cx="0" cy="0"/>
+          <a:chOff x="0" y="0"/>
+          <a:chExt cx="0" cy="0"/>
+        </a:xfrm>
+      </p:grpSpPr>
+      <p:sp>
+        <p:nvSpPr>
+          <p:cNvPr id="2" name="Title 1">
+            <a:extLst>
+              <a:ext uri="{FF2B5EF4-FFF2-40B4-BE49-F238E27FC236}">
+                <a16:creationId xmlns:a16="http://schemas.microsoft.com/office/drawing/2014/main" id="{45685ADD-97A9-323B-38E9-EB0F2A2B1334}"/>
+              </a:ext>
+            </a:extLst>
+          </p:cNvPr>
+          <p:cNvSpPr>
+            <a:spLocks noGrp="1"/>
+          </p:cNvSpPr>
+          <p:nvPr>
+            <p:ph type="title"/>
+          </p:nvPr>
+        </p:nvSpPr>
+        <p:spPr/>
+        <p:txBody>
+          <a:bodyPr/>
+          <a:lstStyle/>
+          <a:p>
+            <a:endParaRPr lang="en-PK"/>
+          </a:p>
+        </p:txBody>
+      </p:sp>
+      <p:sp>
+        <p:nvSpPr>
+          <p:cNvPr id="3" name="Content Placeholder 2">
+            <a:extLst>
+              <a:ext uri="{FF2B5EF4-FFF2-40B4-BE49-F238E27FC236}">
+                <a16:creationId xmlns:a16="http://schemas.microsoft.com/office/drawing/2014/main" id="{E1F00411-5327-01CA-9759-C503554DBA4B}"/>
+              </a:ext>
+            </a:extLst>
+          </p:cNvPr>
+          <p:cNvSpPr>
+            <a:spLocks noGrp="1"/>
+          </p:cNvSpPr>
+          <p:nvPr>
+            <p:ph idx="1"/>
+          </p:nvPr>
+        </p:nvSpPr>
+        <p:spPr/>
+        <p:txBody>
+          <a:bodyPr/>
+          <a:lstStyle/>
+          <a:p>
+            <a:endParaRPr lang="en-PK"/>
+          </a:p>
+        </p:txBody>
+      </p:sp>
+      <p:sp>
+        <p:nvSpPr>
+          <p:cNvPr id="4" name="TextBox 3">
+            <a:extLst>
+              <a:ext uri="{FF2B5EF4-FFF2-40B4-BE49-F238E27FC236}">
+                <a16:creationId xmlns:a16="http://schemas.microsoft.com/office/drawing/2014/main" id="{C10DBB94-A7F1-0908-C6CA-812FCAA1CB1E}"/>
+              </a:ext>
+            </a:extLst>
+          </p:cNvPr>
+          <p:cNvSpPr txBox="1"/>
+          <p:nvPr/>
+        </p:nvSpPr>
+        <p:spPr>
+          <a:xfrm>
+            <a:off x="152400" y="6488668"/>
+            <a:ext cx="11887200" cy="369332"/>
+          </a:xfrm>
+          <a:prstGeom prst="rect">
+            <a:avLst/>
+          </a:prstGeom>
+          <a:noFill/>
+        </p:spPr>
+        <p:txBody>
+          <a:bodyPr wrap="square" rtlCol="0">
+            <a:spAutoFit/>
+          </a:bodyPr>
+          <a:lstStyle/>
+          <a:p>
+            <a:r>
+              <a:rPr lang="en-US" b="1" dirty="0">
+                <a:solidFill>
+                  <a:srgbClr val="0070C0"/>
+                </a:solidFill>
+              </a:rPr>
+              <a:t>FACULTY OF PHARMACY AND PHARMACEUTICAL SCIENCES                                                                               </a:t>
+            </a:r>
+            <a:r>
+              <a:rPr lang="en-US" b="1" dirty="0">
+                <a:solidFill>
+                  <a:schemeClr val="accent2"/>
+                </a:solidFill>
+              </a:rPr>
+              <a:t>SOFTSOLS PAKISTAN</a:t>
+            </a:r>
+            <a:endParaRPr lang="en-PK" b="1" dirty="0">
+              <a:solidFill>
+                <a:schemeClr val="accent2"/>
+              </a:solidFill>
+            </a:endParaRPr>
+          </a:p>
+        </p:txBody>
+      </p:sp>
+    </p:spTree>
+    <p:extLst>
+      <p:ext uri="{BB962C8B-B14F-4D97-AF65-F5344CB8AC3E}">
+        <p14:creationId xmlns:p14="http://schemas.microsoft.com/office/powerpoint/2010/main" val="4239079601"/>
+      </p:ext>
+    </p:extLst>
+  </p:cSld>
+  <p:clrMapOvr>
+    <a:masterClrMapping/>
+  </p:clrMapOvr>
+</p:sld>
+</file>
+
+<file path=ppt/slides/slide15.xml><?xml version="1.0" encoding="utf-8"?>
+<p:sld xmlns:a="http://schemas.openxmlformats.org/drawingml/2006/main" xmlns:r="http://schemas.openxmlformats.org/officeDocument/2006/relationships" xmlns:p="http://schemas.openxmlformats.org/presentationml/2006/main">
+  <p:cSld>
+    <p:spTree>
+      <p:nvGrpSpPr>
+        <p:cNvPr id="1" name="">
+          <a:extLst>
+            <a:ext uri="{FF2B5EF4-FFF2-40B4-BE49-F238E27FC236}">
+              <a16:creationId xmlns:a16="http://schemas.microsoft.com/office/drawing/2014/main" id="{BBBA152D-5B34-3F9A-AF64-72CEFEF066FA}"/>
+            </a:ext>
+          </a:extLst>
+        </p:cNvPr>
+        <p:cNvGrpSpPr/>
+        <p:nvPr/>
+      </p:nvGrpSpPr>
+      <p:grpSpPr>
+        <a:xfrm>
+          <a:off x="0" y="0"/>
+          <a:ext cx="0" cy="0"/>
+          <a:chOff x="0" y="0"/>
+          <a:chExt cx="0" cy="0"/>
+        </a:xfrm>
+      </p:grpSpPr>
+      <p:sp>
+        <p:nvSpPr>
+          <p:cNvPr id="2" name="Title 1">
+            <a:extLst>
+              <a:ext uri="{FF2B5EF4-FFF2-40B4-BE49-F238E27FC236}">
+                <a16:creationId xmlns:a16="http://schemas.microsoft.com/office/drawing/2014/main" id="{A27154D9-37A3-1FFB-D4F0-070CC3271F29}"/>
+              </a:ext>
+            </a:extLst>
+          </p:cNvPr>
+          <p:cNvSpPr>
+            <a:spLocks noGrp="1"/>
+          </p:cNvSpPr>
+          <p:nvPr>
+            <p:ph type="title"/>
+          </p:nvPr>
+        </p:nvSpPr>
+        <p:spPr/>
+        <p:txBody>
+          <a:bodyPr/>
+          <a:lstStyle/>
+          <a:p>
+            <a:endParaRPr lang="en-PK"/>
+          </a:p>
+        </p:txBody>
+      </p:sp>
+      <p:sp>
+        <p:nvSpPr>
+          <p:cNvPr id="3" name="Content Placeholder 2">
+            <a:extLst>
+              <a:ext uri="{FF2B5EF4-FFF2-40B4-BE49-F238E27FC236}">
+                <a16:creationId xmlns:a16="http://schemas.microsoft.com/office/drawing/2014/main" id="{09B29319-F0A7-21BA-41BE-BEB40DA226CC}"/>
+              </a:ext>
+            </a:extLst>
+          </p:cNvPr>
+          <p:cNvSpPr>
+            <a:spLocks noGrp="1"/>
+          </p:cNvSpPr>
+          <p:nvPr>
+            <p:ph idx="1"/>
+          </p:nvPr>
+        </p:nvSpPr>
+        <p:spPr/>
+        <p:txBody>
+          <a:bodyPr/>
+          <a:lstStyle/>
+          <a:p>
+            <a:endParaRPr lang="en-PK"/>
+          </a:p>
+        </p:txBody>
+      </p:sp>
+      <p:sp>
+        <p:nvSpPr>
+          <p:cNvPr id="4" name="TextBox 3">
+            <a:extLst>
+              <a:ext uri="{FF2B5EF4-FFF2-40B4-BE49-F238E27FC236}">
+                <a16:creationId xmlns:a16="http://schemas.microsoft.com/office/drawing/2014/main" id="{CE565390-5C24-CAE4-E92E-9F3FCE8366A5}"/>
+              </a:ext>
+            </a:extLst>
+          </p:cNvPr>
+          <p:cNvSpPr txBox="1"/>
+          <p:nvPr/>
+        </p:nvSpPr>
+        <p:spPr>
+          <a:xfrm>
+            <a:off x="152400" y="6488668"/>
+            <a:ext cx="11887200" cy="369332"/>
+          </a:xfrm>
+          <a:prstGeom prst="rect">
+            <a:avLst/>
+          </a:prstGeom>
+          <a:noFill/>
+        </p:spPr>
+        <p:txBody>
+          <a:bodyPr wrap="square" rtlCol="0">
+            <a:spAutoFit/>
+          </a:bodyPr>
+          <a:lstStyle/>
+          <a:p>
+            <a:r>
+              <a:rPr lang="en-US" b="1" dirty="0">
+                <a:solidFill>
+                  <a:srgbClr val="0070C0"/>
+                </a:solidFill>
+              </a:rPr>
+              <a:t>FACULTY OF PHARMACY AND PHARMACEUTICAL SCIENCES                                                                               </a:t>
+            </a:r>
+            <a:r>
+              <a:rPr lang="en-US" b="1" dirty="0">
+                <a:solidFill>
+                  <a:schemeClr val="accent2"/>
+                </a:solidFill>
+              </a:rPr>
+              <a:t>SOFTSOLS PAKISTAN</a:t>
+            </a:r>
+            <a:endParaRPr lang="en-PK" b="1" dirty="0">
+              <a:solidFill>
+                <a:schemeClr val="accent2"/>
+              </a:solidFill>
+            </a:endParaRPr>
+          </a:p>
+        </p:txBody>
+      </p:sp>
+    </p:spTree>
+    <p:extLst>
+      <p:ext uri="{BB962C8B-B14F-4D97-AF65-F5344CB8AC3E}">
+        <p14:creationId xmlns:p14="http://schemas.microsoft.com/office/powerpoint/2010/main" val="2145863767"/>
+      </p:ext>
+    </p:extLst>
+  </p:cSld>
+  <p:clrMapOvr>
+    <a:masterClrMapping/>
+  </p:clrMapOvr>
+</p:sld>
+</file>
+
+<file path=ppt/slides/slide16.xml><?xml version="1.0" encoding="utf-8"?>
+<p:sld xmlns:a="http://schemas.openxmlformats.org/drawingml/2006/main" xmlns:r="http://schemas.openxmlformats.org/officeDocument/2006/relationships" xmlns:p="http://schemas.openxmlformats.org/presentationml/2006/main">
+  <p:cSld>
+    <p:spTree>
+      <p:nvGrpSpPr>
+        <p:cNvPr id="1" name="">
+          <a:extLst>
+            <a:ext uri="{FF2B5EF4-FFF2-40B4-BE49-F238E27FC236}">
+              <a16:creationId xmlns:a16="http://schemas.microsoft.com/office/drawing/2014/main" id="{7CC6B399-AC1C-5E1D-5927-0A7A63E8E9ED}"/>
+            </a:ext>
+          </a:extLst>
+        </p:cNvPr>
+        <p:cNvGrpSpPr/>
+        <p:nvPr/>
+      </p:nvGrpSpPr>
+      <p:grpSpPr>
+        <a:xfrm>
+          <a:off x="0" y="0"/>
+          <a:ext cx="0" cy="0"/>
+          <a:chOff x="0" y="0"/>
+          <a:chExt cx="0" cy="0"/>
+        </a:xfrm>
+      </p:grpSpPr>
+      <p:sp>
+        <p:nvSpPr>
+          <p:cNvPr id="2" name="Title 1">
+            <a:extLst>
+              <a:ext uri="{FF2B5EF4-FFF2-40B4-BE49-F238E27FC236}">
+                <a16:creationId xmlns:a16="http://schemas.microsoft.com/office/drawing/2014/main" id="{2870E369-BFA4-3DAA-406F-AF0C219CA3AF}"/>
+              </a:ext>
+            </a:extLst>
+          </p:cNvPr>
+          <p:cNvSpPr>
+            <a:spLocks noGrp="1"/>
+          </p:cNvSpPr>
+          <p:nvPr>
+            <p:ph type="title"/>
+          </p:nvPr>
+        </p:nvSpPr>
+        <p:spPr/>
+        <p:txBody>
+          <a:bodyPr/>
+          <a:lstStyle/>
+          <a:p>
+            <a:r>
+              <a:rPr lang="en-US" b="1" dirty="0">
+                <a:solidFill>
+                  <a:srgbClr val="0070C0"/>
+                </a:solidFill>
+              </a:rPr>
+              <a:t>Reset Password</a:t>
+            </a:r>
+            <a:endParaRPr lang="en-PK" b="1" dirty="0">
+              <a:solidFill>
+                <a:srgbClr val="0070C0"/>
+              </a:solidFill>
+            </a:endParaRPr>
+          </a:p>
+        </p:txBody>
+      </p:sp>
+      <p:sp>
+        <p:nvSpPr>
+          <p:cNvPr id="4" name="Text Placeholder 3">
+            <a:extLst>
+              <a:ext uri="{FF2B5EF4-FFF2-40B4-BE49-F238E27FC236}">
+                <a16:creationId xmlns:a16="http://schemas.microsoft.com/office/drawing/2014/main" id="{7A7C57E4-B7DB-9435-8DDF-E9C7EEF67FCA}"/>
+              </a:ext>
+            </a:extLst>
+          </p:cNvPr>
+          <p:cNvSpPr>
+            <a:spLocks noGrp="1"/>
+          </p:cNvSpPr>
+          <p:nvPr>
+            <p:ph type="body" sz="half" idx="2"/>
+          </p:nvPr>
+        </p:nvSpPr>
+        <p:spPr/>
+        <p:txBody>
+          <a:bodyPr/>
+          <a:lstStyle/>
+          <a:p>
+            <a:r>
+              <a:rPr lang="en-US" dirty="0"/>
+              <a:t>Confirmation on Screen about Password changed.</a:t>
+            </a:r>
+          </a:p>
+          <a:p>
+            <a:r>
+              <a:rPr lang="en-US" dirty="0"/>
+              <a:t>You will login with New Password.</a:t>
+            </a:r>
+          </a:p>
+          <a:p>
+            <a:endParaRPr lang="en-PK" dirty="0"/>
+          </a:p>
+        </p:txBody>
+      </p:sp>
+      <p:pic>
+        <p:nvPicPr>
+          <p:cNvPr id="6" name="Content Placeholder 5">
+            <a:extLst>
+              <a:ext uri="{FF2B5EF4-FFF2-40B4-BE49-F238E27FC236}">
+                <a16:creationId xmlns:a16="http://schemas.microsoft.com/office/drawing/2014/main" id="{36D23433-85D2-3302-9C2C-56FF1843BC78}"/>
+              </a:ext>
+            </a:extLst>
+          </p:cNvPr>
+          <p:cNvPicPr>
+            <a:picLocks noGrp="1" noChangeAspect="1"/>
+          </p:cNvPicPr>
+          <p:nvPr>
+            <p:ph idx="1"/>
+          </p:nvPr>
+        </p:nvPicPr>
+        <p:blipFill>
+          <a:blip r:embed="rId2"/>
+          <a:stretch>
+            <a:fillRect/>
+          </a:stretch>
+        </p:blipFill>
+        <p:spPr>
+          <a:xfrm>
+            <a:off x="6197600" y="626181"/>
+            <a:ext cx="4865511" cy="5695597"/>
+          </a:xfrm>
+          <a:prstGeom prst="rect">
+            <a:avLst/>
+          </a:prstGeom>
+        </p:spPr>
+      </p:pic>
+      <p:sp>
+        <p:nvSpPr>
+          <p:cNvPr id="8" name="TextBox 7">
+            <a:extLst>
+              <a:ext uri="{FF2B5EF4-FFF2-40B4-BE49-F238E27FC236}">
+                <a16:creationId xmlns:a16="http://schemas.microsoft.com/office/drawing/2014/main" id="{48CE0525-2852-079A-A795-5141E481C4BB}"/>
+              </a:ext>
+            </a:extLst>
+          </p:cNvPr>
+          <p:cNvSpPr txBox="1"/>
+          <p:nvPr/>
+        </p:nvSpPr>
+        <p:spPr>
+          <a:xfrm>
+            <a:off x="152400" y="6488668"/>
+            <a:ext cx="11887200" cy="369332"/>
+          </a:xfrm>
+          <a:prstGeom prst="rect">
+            <a:avLst/>
+          </a:prstGeom>
+          <a:noFill/>
+        </p:spPr>
+        <p:txBody>
+          <a:bodyPr wrap="square" rtlCol="0">
+            <a:spAutoFit/>
+          </a:bodyPr>
+          <a:lstStyle/>
+          <a:p>
+            <a:r>
+              <a:rPr lang="en-US" b="1" dirty="0">
+                <a:solidFill>
+                  <a:srgbClr val="0070C0"/>
+                </a:solidFill>
+              </a:rPr>
+              <a:t>FACULTY OF PHARMACY AND PHARMACEUTICAL SCIENCES                                                                               </a:t>
+            </a:r>
+            <a:r>
+              <a:rPr lang="en-US" b="1" dirty="0">
+                <a:solidFill>
+                  <a:schemeClr val="accent2"/>
+                </a:solidFill>
+              </a:rPr>
+              <a:t>SOFTSOLS PAKISTAN</a:t>
+            </a:r>
+            <a:endParaRPr lang="en-PK" b="1" dirty="0">
+              <a:solidFill>
+                <a:schemeClr val="accent2"/>
+              </a:solidFill>
+            </a:endParaRPr>
+          </a:p>
+        </p:txBody>
+      </p:sp>
+    </p:spTree>
+    <p:extLst>
+      <p:ext uri="{BB962C8B-B14F-4D97-AF65-F5344CB8AC3E}">
+        <p14:creationId xmlns:p14="http://schemas.microsoft.com/office/powerpoint/2010/main" val="663351100"/>
       </p:ext>
     </p:extLst>
   </p:cSld>
@@ -4927,7 +5817,7 @@
         <p:cNvPr id="1" name="">
           <a:extLst>
             <a:ext uri="{FF2B5EF4-FFF2-40B4-BE49-F238E27FC236}">
-              <a16:creationId xmlns:a16="http://schemas.microsoft.com/office/drawing/2014/main" id="{7CC6B399-AC1C-5E1D-5927-0A7A63E8E9ED}"/>
+              <a16:creationId xmlns:a16="http://schemas.microsoft.com/office/drawing/2014/main" id="{D6188D29-524E-9030-DDF9-2FFBFB948A03}"/>
             </a:ext>
           </a:extLst>
         </p:cNvPr>
@@ -4947,7 +5837,7 @@
           <p:cNvPr id="2" name="Title 1">
             <a:extLst>
               <a:ext uri="{FF2B5EF4-FFF2-40B4-BE49-F238E27FC236}">
-                <a16:creationId xmlns:a16="http://schemas.microsoft.com/office/drawing/2014/main" id="{2870E369-BFA4-3DAA-406F-AF0C219CA3AF}"/>
+                <a16:creationId xmlns:a16="http://schemas.microsoft.com/office/drawing/2014/main" id="{2745430A-9B0F-D826-8B17-198B41B9B6E3}"/>
               </a:ext>
             </a:extLst>
           </p:cNvPr>
@@ -4963,97 +5853,41 @@
           <a:bodyPr/>
           <a:lstStyle/>
           <a:p>
-            <a:r>
-              <a:rPr lang="en-US" b="1" dirty="0">
-                <a:solidFill>
-                  <a:srgbClr val="0070C0"/>
-                </a:solidFill>
-              </a:rPr>
-              <a:t>Reset Password</a:t>
-            </a:r>
-            <a:endParaRPr lang="en-PK" b="1" dirty="0">
-              <a:solidFill>
-                <a:srgbClr val="0070C0"/>
-              </a:solidFill>
-            </a:endParaRPr>
-          </a:p>
-        </p:txBody>
-      </p:sp>
-      <p:sp>
-        <p:nvSpPr>
-          <p:cNvPr id="4" name="Text Placeholder 3">
-            <a:extLst>
-              <a:ext uri="{FF2B5EF4-FFF2-40B4-BE49-F238E27FC236}">
-                <a16:creationId xmlns:a16="http://schemas.microsoft.com/office/drawing/2014/main" id="{7A7C57E4-B7DB-9435-8DDF-E9C7EEF67FCA}"/>
-              </a:ext>
-            </a:extLst>
-          </p:cNvPr>
-          <p:cNvSpPr>
-            <a:spLocks noGrp="1"/>
-          </p:cNvSpPr>
-          <p:nvPr>
-            <p:ph type="body" sz="half" idx="2"/>
-          </p:nvPr>
-        </p:nvSpPr>
-        <p:spPr/>
-        <p:txBody>
-          <a:bodyPr/>
-          <a:lstStyle/>
-          <a:p>
-            <a:r>
-              <a:rPr lang="en-US" dirty="0"/>
-              <a:t>Confirmation on Screen about Password changed.</a:t>
-            </a:r>
-          </a:p>
-          <a:p>
-            <a:r>
-              <a:rPr lang="en-US" dirty="0"/>
-              <a:t>You will login with New Password.</a:t>
-            </a:r>
-          </a:p>
-          <a:p>
-            <a:endParaRPr lang="en-PK" dirty="0"/>
-          </a:p>
-        </p:txBody>
-      </p:sp>
-      <p:pic>
-        <p:nvPicPr>
-          <p:cNvPr id="6" name="Content Placeholder 5">
-            <a:extLst>
-              <a:ext uri="{FF2B5EF4-FFF2-40B4-BE49-F238E27FC236}">
-                <a16:creationId xmlns:a16="http://schemas.microsoft.com/office/drawing/2014/main" id="{36D23433-85D2-3302-9C2C-56FF1843BC78}"/>
-              </a:ext>
-            </a:extLst>
-          </p:cNvPr>
-          <p:cNvPicPr>
-            <a:picLocks noGrp="1" noChangeAspect="1"/>
-          </p:cNvPicPr>
+            <a:endParaRPr lang="en-PK"/>
+          </a:p>
+        </p:txBody>
+      </p:sp>
+      <p:sp>
+        <p:nvSpPr>
+          <p:cNvPr id="3" name="Content Placeholder 2">
+            <a:extLst>
+              <a:ext uri="{FF2B5EF4-FFF2-40B4-BE49-F238E27FC236}">
+                <a16:creationId xmlns:a16="http://schemas.microsoft.com/office/drawing/2014/main" id="{C686B506-1C06-0EC6-7279-1083653DB0F7}"/>
+              </a:ext>
+            </a:extLst>
+          </p:cNvPr>
+          <p:cNvSpPr>
+            <a:spLocks noGrp="1"/>
+          </p:cNvSpPr>
           <p:nvPr>
             <p:ph idx="1"/>
           </p:nvPr>
-        </p:nvPicPr>
-        <p:blipFill>
-          <a:blip r:embed="rId2"/>
-          <a:stretch>
-            <a:fillRect/>
-          </a:stretch>
-        </p:blipFill>
-        <p:spPr>
-          <a:xfrm>
-            <a:off x="6197600" y="626181"/>
-            <a:ext cx="4865511" cy="5695597"/>
-          </a:xfrm>
-          <a:prstGeom prst="rect">
-            <a:avLst/>
-          </a:prstGeom>
-        </p:spPr>
-      </p:pic>
-      <p:sp>
-        <p:nvSpPr>
-          <p:cNvPr id="8" name="TextBox 7">
-            <a:extLst>
-              <a:ext uri="{FF2B5EF4-FFF2-40B4-BE49-F238E27FC236}">
-                <a16:creationId xmlns:a16="http://schemas.microsoft.com/office/drawing/2014/main" id="{48CE0525-2852-079A-A795-5141E481C4BB}"/>
+        </p:nvSpPr>
+        <p:spPr/>
+        <p:txBody>
+          <a:bodyPr/>
+          <a:lstStyle/>
+          <a:p>
+            <a:endParaRPr lang="en-PK"/>
+          </a:p>
+        </p:txBody>
+      </p:sp>
+      <p:sp>
+        <p:nvSpPr>
+          <p:cNvPr id="4" name="TextBox 3">
+            <a:extLst>
+              <a:ext uri="{FF2B5EF4-FFF2-40B4-BE49-F238E27FC236}">
+                <a16:creationId xmlns:a16="http://schemas.microsoft.com/office/drawing/2014/main" id="{B389A75D-8D27-03FF-9B3B-4F371BF90BCE}"/>
               </a:ext>
             </a:extLst>
           </p:cNvPr>
@@ -5100,10 +5934,118 @@
           </a:p>
         </p:txBody>
       </p:sp>
+      <p:pic>
+        <p:nvPicPr>
+          <p:cNvPr id="6" name="Picture 5">
+            <a:extLst>
+              <a:ext uri="{FF2B5EF4-FFF2-40B4-BE49-F238E27FC236}">
+                <a16:creationId xmlns:a16="http://schemas.microsoft.com/office/drawing/2014/main" id="{1BFCBF52-5753-10B4-5522-7C642C9474BE}"/>
+              </a:ext>
+            </a:extLst>
+          </p:cNvPr>
+          <p:cNvPicPr>
+            <a:picLocks noChangeAspect="1"/>
+          </p:cNvPicPr>
+          <p:nvPr/>
+        </p:nvPicPr>
+        <p:blipFill>
+          <a:blip r:embed="rId2"/>
+          <a:stretch>
+            <a:fillRect/>
+          </a:stretch>
+        </p:blipFill>
+        <p:spPr>
+          <a:xfrm>
+            <a:off x="0" y="-1"/>
+            <a:ext cx="12192000" cy="6310489"/>
+          </a:xfrm>
+          <a:prstGeom prst="rect">
+            <a:avLst/>
+          </a:prstGeom>
+        </p:spPr>
+      </p:pic>
+      <p:sp>
+        <p:nvSpPr>
+          <p:cNvPr id="7" name="TextBox 6">
+            <a:extLst>
+              <a:ext uri="{FF2B5EF4-FFF2-40B4-BE49-F238E27FC236}">
+                <a16:creationId xmlns:a16="http://schemas.microsoft.com/office/drawing/2014/main" id="{08704BFE-ED11-DC85-CF4F-7A1E80A7DC7A}"/>
+              </a:ext>
+            </a:extLst>
+          </p:cNvPr>
+          <p:cNvSpPr txBox="1"/>
+          <p:nvPr/>
+        </p:nvSpPr>
+        <p:spPr>
+          <a:xfrm>
+            <a:off x="4752622" y="2585156"/>
+            <a:ext cx="5294489" cy="1754326"/>
+          </a:xfrm>
+          <a:prstGeom prst="rect">
+            <a:avLst/>
+          </a:prstGeom>
+          <a:noFill/>
+        </p:spPr>
+        <p:txBody>
+          <a:bodyPr wrap="square" rtlCol="0">
+            <a:spAutoFit/>
+          </a:bodyPr>
+          <a:lstStyle/>
+          <a:p>
+            <a:r>
+              <a:rPr lang="en-US" dirty="0">
+                <a:solidFill>
+                  <a:srgbClr val="FF0000"/>
+                </a:solidFill>
+              </a:rPr>
+              <a:t>1:1 CHAT / MESSENGER between Faculty Members (Teachers), HODs, Dean Office and Dean </a:t>
+            </a:r>
+          </a:p>
+          <a:p>
+            <a:endParaRPr lang="en-US" dirty="0">
+              <a:solidFill>
+                <a:srgbClr val="FF0000"/>
+              </a:solidFill>
+            </a:endParaRPr>
+          </a:p>
+          <a:p>
+            <a:r>
+              <a:rPr lang="en-US" dirty="0">
+                <a:solidFill>
+                  <a:srgbClr val="FF0000"/>
+                </a:solidFill>
+              </a:rPr>
+              <a:t>Any Member will send message to other.</a:t>
+            </a:r>
+          </a:p>
+          <a:p>
+            <a:endParaRPr lang="en-US" dirty="0">
+              <a:solidFill>
+                <a:srgbClr val="FF0000"/>
+              </a:solidFill>
+            </a:endParaRPr>
+          </a:p>
+          <a:p>
+            <a:r>
+              <a:rPr lang="en-US" dirty="0">
+                <a:solidFill>
+                  <a:srgbClr val="FF0000"/>
+                </a:solidFill>
+              </a:rPr>
+              <a:t>100% Encrypted chat</a:t>
+            </a:r>
+            <a:endParaRPr lang="en-PK" dirty="0">
+              <a:solidFill>
+                <a:srgbClr val="FF0000"/>
+              </a:solidFill>
+            </a:endParaRPr>
+          </a:p>
+        </p:txBody>
+      </p:sp>
     </p:spTree>
     <p:extLst>
       <p:ext uri="{BB962C8B-B14F-4D97-AF65-F5344CB8AC3E}">
-        <p14:creationId xmlns:p14="http://schemas.microsoft.com/office/powerpoint/2010/main" val="663351100"/>
+        <p14:creationId xmlns:p14="http://schemas.microsoft.com/office/powerpoint/2010/main" val="3053948027"/>
       </p:ext>
     </p:extLst>
   </p:cSld>

</xml_diff>

<commit_message>
feat: unified scheduled lecture join classroom, added recording deletion, and attendance UI overhaul
</commit_message>
<xml_diff>
--- a/STUDENT REGISTRATION.pptx
+++ b/STUDENT REGISTRATION.pptx
@@ -13,14 +13,15 @@
     <p:sldId id="262" r:id="rId7"/>
     <p:sldId id="259" r:id="rId8"/>
     <p:sldId id="263" r:id="rId9"/>
-    <p:sldId id="260" r:id="rId10"/>
-    <p:sldId id="266" r:id="rId11"/>
-    <p:sldId id="267" r:id="rId12"/>
-    <p:sldId id="268" r:id="rId13"/>
-    <p:sldId id="269" r:id="rId14"/>
-    <p:sldId id="270" r:id="rId15"/>
-    <p:sldId id="271" r:id="rId16"/>
-    <p:sldId id="264" r:id="rId17"/>
+    <p:sldId id="269" r:id="rId10"/>
+    <p:sldId id="270" r:id="rId11"/>
+    <p:sldId id="271" r:id="rId12"/>
+    <p:sldId id="272" r:id="rId13"/>
+    <p:sldId id="274" r:id="rId14"/>
+    <p:sldId id="275" r:id="rId15"/>
+    <p:sldId id="276" r:id="rId16"/>
+    <p:sldId id="273" r:id="rId17"/>
+    <p:sldId id="264" r:id="rId18"/>
   </p:sldIdLst>
   <p:sldSz cx="12192000" cy="6858000"/>
   <p:notesSz cx="6858000" cy="9144000"/>
@@ -3575,558 +3576,6 @@
         <p:cNvPr id="1" name="">
           <a:extLst>
             <a:ext uri="{FF2B5EF4-FFF2-40B4-BE49-F238E27FC236}">
-              <a16:creationId xmlns:a16="http://schemas.microsoft.com/office/drawing/2014/main" id="{417AA6B0-EA62-B8D9-8F4B-172F4765AA7A}"/>
-            </a:ext>
-          </a:extLst>
-        </p:cNvPr>
-        <p:cNvGrpSpPr/>
-        <p:nvPr/>
-      </p:nvGrpSpPr>
-      <p:grpSpPr>
-        <a:xfrm>
-          <a:off x="0" y="0"/>
-          <a:ext cx="0" cy="0"/>
-          <a:chOff x="0" y="0"/>
-          <a:chExt cx="0" cy="0"/>
-        </a:xfrm>
-      </p:grpSpPr>
-      <p:sp>
-        <p:nvSpPr>
-          <p:cNvPr id="2" name="Title 1">
-            <a:extLst>
-              <a:ext uri="{FF2B5EF4-FFF2-40B4-BE49-F238E27FC236}">
-                <a16:creationId xmlns:a16="http://schemas.microsoft.com/office/drawing/2014/main" id="{CCCE2A8D-D636-1277-EDFA-23D14389CD33}"/>
-              </a:ext>
-            </a:extLst>
-          </p:cNvPr>
-          <p:cNvSpPr>
-            <a:spLocks noGrp="1"/>
-          </p:cNvSpPr>
-          <p:nvPr>
-            <p:ph type="title"/>
-          </p:nvPr>
-        </p:nvSpPr>
-        <p:spPr/>
-        <p:txBody>
-          <a:bodyPr/>
-          <a:lstStyle/>
-          <a:p>
-            <a:endParaRPr lang="en-PK"/>
-          </a:p>
-        </p:txBody>
-      </p:sp>
-      <p:sp>
-        <p:nvSpPr>
-          <p:cNvPr id="3" name="Content Placeholder 2">
-            <a:extLst>
-              <a:ext uri="{FF2B5EF4-FFF2-40B4-BE49-F238E27FC236}">
-                <a16:creationId xmlns:a16="http://schemas.microsoft.com/office/drawing/2014/main" id="{8AFE47A1-F6C3-36E9-C876-936D3582C19B}"/>
-              </a:ext>
-            </a:extLst>
-          </p:cNvPr>
-          <p:cNvSpPr>
-            <a:spLocks noGrp="1"/>
-          </p:cNvSpPr>
-          <p:nvPr>
-            <p:ph idx="1"/>
-          </p:nvPr>
-        </p:nvSpPr>
-        <p:spPr/>
-        <p:txBody>
-          <a:bodyPr/>
-          <a:lstStyle/>
-          <a:p>
-            <a:endParaRPr lang="en-PK"/>
-          </a:p>
-        </p:txBody>
-      </p:sp>
-      <p:sp>
-        <p:nvSpPr>
-          <p:cNvPr id="4" name="TextBox 3">
-            <a:extLst>
-              <a:ext uri="{FF2B5EF4-FFF2-40B4-BE49-F238E27FC236}">
-                <a16:creationId xmlns:a16="http://schemas.microsoft.com/office/drawing/2014/main" id="{02C7E35E-6DD7-E97D-C057-8FC8E3849A14}"/>
-              </a:ext>
-            </a:extLst>
-          </p:cNvPr>
-          <p:cNvSpPr txBox="1"/>
-          <p:nvPr/>
-        </p:nvSpPr>
-        <p:spPr>
-          <a:xfrm>
-            <a:off x="152400" y="6488668"/>
-            <a:ext cx="11887200" cy="369332"/>
-          </a:xfrm>
-          <a:prstGeom prst="rect">
-            <a:avLst/>
-          </a:prstGeom>
-          <a:noFill/>
-        </p:spPr>
-        <p:txBody>
-          <a:bodyPr wrap="square" rtlCol="0">
-            <a:spAutoFit/>
-          </a:bodyPr>
-          <a:lstStyle/>
-          <a:p>
-            <a:r>
-              <a:rPr lang="en-US" b="1" dirty="0">
-                <a:solidFill>
-                  <a:srgbClr val="0070C0"/>
-                </a:solidFill>
-              </a:rPr>
-              <a:t>FACULTY OF PHARMACY AND PHARMACEUTICAL SCIENCES                                                                               </a:t>
-            </a:r>
-            <a:r>
-              <a:rPr lang="en-US" b="1" dirty="0">
-                <a:solidFill>
-                  <a:schemeClr val="accent2"/>
-                </a:solidFill>
-              </a:rPr>
-              <a:t>SOFTSOLS PAKISTAN</a:t>
-            </a:r>
-            <a:endParaRPr lang="en-PK" b="1" dirty="0">
-              <a:solidFill>
-                <a:schemeClr val="accent2"/>
-              </a:solidFill>
-            </a:endParaRPr>
-          </a:p>
-        </p:txBody>
-      </p:sp>
-    </p:spTree>
-    <p:extLst>
-      <p:ext uri="{BB962C8B-B14F-4D97-AF65-F5344CB8AC3E}">
-        <p14:creationId xmlns:p14="http://schemas.microsoft.com/office/powerpoint/2010/main" val="1272446270"/>
-      </p:ext>
-    </p:extLst>
-  </p:cSld>
-  <p:clrMapOvr>
-    <a:masterClrMapping/>
-  </p:clrMapOvr>
-</p:sld>
-</file>
-
-<file path=ppt/slides/slide11.xml><?xml version="1.0" encoding="utf-8"?>
-<p:sld xmlns:a="http://schemas.openxmlformats.org/drawingml/2006/main" xmlns:r="http://schemas.openxmlformats.org/officeDocument/2006/relationships" xmlns:p="http://schemas.openxmlformats.org/presentationml/2006/main">
-  <p:cSld>
-    <p:spTree>
-      <p:nvGrpSpPr>
-        <p:cNvPr id="1" name="">
-          <a:extLst>
-            <a:ext uri="{FF2B5EF4-FFF2-40B4-BE49-F238E27FC236}">
-              <a16:creationId xmlns:a16="http://schemas.microsoft.com/office/drawing/2014/main" id="{1F246CC1-3EEE-232A-97DB-FDE4C5C155DF}"/>
-            </a:ext>
-          </a:extLst>
-        </p:cNvPr>
-        <p:cNvGrpSpPr/>
-        <p:nvPr/>
-      </p:nvGrpSpPr>
-      <p:grpSpPr>
-        <a:xfrm>
-          <a:off x="0" y="0"/>
-          <a:ext cx="0" cy="0"/>
-          <a:chOff x="0" y="0"/>
-          <a:chExt cx="0" cy="0"/>
-        </a:xfrm>
-      </p:grpSpPr>
-      <p:sp>
-        <p:nvSpPr>
-          <p:cNvPr id="2" name="Title 1">
-            <a:extLst>
-              <a:ext uri="{FF2B5EF4-FFF2-40B4-BE49-F238E27FC236}">
-                <a16:creationId xmlns:a16="http://schemas.microsoft.com/office/drawing/2014/main" id="{69104813-3D9C-C967-DC29-4AD960165950}"/>
-              </a:ext>
-            </a:extLst>
-          </p:cNvPr>
-          <p:cNvSpPr>
-            <a:spLocks noGrp="1"/>
-          </p:cNvSpPr>
-          <p:nvPr>
-            <p:ph type="title"/>
-          </p:nvPr>
-        </p:nvSpPr>
-        <p:spPr/>
-        <p:txBody>
-          <a:bodyPr/>
-          <a:lstStyle/>
-          <a:p>
-            <a:endParaRPr lang="en-PK"/>
-          </a:p>
-        </p:txBody>
-      </p:sp>
-      <p:sp>
-        <p:nvSpPr>
-          <p:cNvPr id="3" name="Content Placeholder 2">
-            <a:extLst>
-              <a:ext uri="{FF2B5EF4-FFF2-40B4-BE49-F238E27FC236}">
-                <a16:creationId xmlns:a16="http://schemas.microsoft.com/office/drawing/2014/main" id="{4706C792-BEAC-10DB-D9C5-1A1AF109E246}"/>
-              </a:ext>
-            </a:extLst>
-          </p:cNvPr>
-          <p:cNvSpPr>
-            <a:spLocks noGrp="1"/>
-          </p:cNvSpPr>
-          <p:nvPr>
-            <p:ph idx="1"/>
-          </p:nvPr>
-        </p:nvSpPr>
-        <p:spPr/>
-        <p:txBody>
-          <a:bodyPr/>
-          <a:lstStyle/>
-          <a:p>
-            <a:endParaRPr lang="en-PK"/>
-          </a:p>
-        </p:txBody>
-      </p:sp>
-      <p:sp>
-        <p:nvSpPr>
-          <p:cNvPr id="4" name="TextBox 3">
-            <a:extLst>
-              <a:ext uri="{FF2B5EF4-FFF2-40B4-BE49-F238E27FC236}">
-                <a16:creationId xmlns:a16="http://schemas.microsoft.com/office/drawing/2014/main" id="{DD38232D-3758-F081-79C7-76848A9D49C7}"/>
-              </a:ext>
-            </a:extLst>
-          </p:cNvPr>
-          <p:cNvSpPr txBox="1"/>
-          <p:nvPr/>
-        </p:nvSpPr>
-        <p:spPr>
-          <a:xfrm>
-            <a:off x="152400" y="6488668"/>
-            <a:ext cx="11887200" cy="369332"/>
-          </a:xfrm>
-          <a:prstGeom prst="rect">
-            <a:avLst/>
-          </a:prstGeom>
-          <a:noFill/>
-        </p:spPr>
-        <p:txBody>
-          <a:bodyPr wrap="square" rtlCol="0">
-            <a:spAutoFit/>
-          </a:bodyPr>
-          <a:lstStyle/>
-          <a:p>
-            <a:r>
-              <a:rPr lang="en-US" b="1" dirty="0">
-                <a:solidFill>
-                  <a:srgbClr val="0070C0"/>
-                </a:solidFill>
-              </a:rPr>
-              <a:t>FACULTY OF PHARMACY AND PHARMACEUTICAL SCIENCES                                                                               </a:t>
-            </a:r>
-            <a:r>
-              <a:rPr lang="en-US" b="1" dirty="0">
-                <a:solidFill>
-                  <a:schemeClr val="accent2"/>
-                </a:solidFill>
-              </a:rPr>
-              <a:t>SOFTSOLS PAKISTAN</a:t>
-            </a:r>
-            <a:endParaRPr lang="en-PK" b="1" dirty="0">
-              <a:solidFill>
-                <a:schemeClr val="accent2"/>
-              </a:solidFill>
-            </a:endParaRPr>
-          </a:p>
-        </p:txBody>
-      </p:sp>
-    </p:spTree>
-    <p:extLst>
-      <p:ext uri="{BB962C8B-B14F-4D97-AF65-F5344CB8AC3E}">
-        <p14:creationId xmlns:p14="http://schemas.microsoft.com/office/powerpoint/2010/main" val="2792856011"/>
-      </p:ext>
-    </p:extLst>
-  </p:cSld>
-  <p:clrMapOvr>
-    <a:masterClrMapping/>
-  </p:clrMapOvr>
-</p:sld>
-</file>
-
-<file path=ppt/slides/slide12.xml><?xml version="1.0" encoding="utf-8"?>
-<p:sld xmlns:a="http://schemas.openxmlformats.org/drawingml/2006/main" xmlns:r="http://schemas.openxmlformats.org/officeDocument/2006/relationships" xmlns:p="http://schemas.openxmlformats.org/presentationml/2006/main">
-  <p:cSld>
-    <p:spTree>
-      <p:nvGrpSpPr>
-        <p:cNvPr id="1" name="">
-          <a:extLst>
-            <a:ext uri="{FF2B5EF4-FFF2-40B4-BE49-F238E27FC236}">
-              <a16:creationId xmlns:a16="http://schemas.microsoft.com/office/drawing/2014/main" id="{9B5254DB-ADA3-B7BE-4C31-7D082AB7B2AE}"/>
-            </a:ext>
-          </a:extLst>
-        </p:cNvPr>
-        <p:cNvGrpSpPr/>
-        <p:nvPr/>
-      </p:nvGrpSpPr>
-      <p:grpSpPr>
-        <a:xfrm>
-          <a:off x="0" y="0"/>
-          <a:ext cx="0" cy="0"/>
-          <a:chOff x="0" y="0"/>
-          <a:chExt cx="0" cy="0"/>
-        </a:xfrm>
-      </p:grpSpPr>
-      <p:sp>
-        <p:nvSpPr>
-          <p:cNvPr id="2" name="Title 1">
-            <a:extLst>
-              <a:ext uri="{FF2B5EF4-FFF2-40B4-BE49-F238E27FC236}">
-                <a16:creationId xmlns:a16="http://schemas.microsoft.com/office/drawing/2014/main" id="{20176479-9A84-D6EA-14FD-C38201841E16}"/>
-              </a:ext>
-            </a:extLst>
-          </p:cNvPr>
-          <p:cNvSpPr>
-            <a:spLocks noGrp="1"/>
-          </p:cNvSpPr>
-          <p:nvPr>
-            <p:ph type="title"/>
-          </p:nvPr>
-        </p:nvSpPr>
-        <p:spPr/>
-        <p:txBody>
-          <a:bodyPr/>
-          <a:lstStyle/>
-          <a:p>
-            <a:endParaRPr lang="en-PK"/>
-          </a:p>
-        </p:txBody>
-      </p:sp>
-      <p:sp>
-        <p:nvSpPr>
-          <p:cNvPr id="3" name="Content Placeholder 2">
-            <a:extLst>
-              <a:ext uri="{FF2B5EF4-FFF2-40B4-BE49-F238E27FC236}">
-                <a16:creationId xmlns:a16="http://schemas.microsoft.com/office/drawing/2014/main" id="{2DB52420-4189-3275-0B03-096F7A5600B2}"/>
-              </a:ext>
-            </a:extLst>
-          </p:cNvPr>
-          <p:cNvSpPr>
-            <a:spLocks noGrp="1"/>
-          </p:cNvSpPr>
-          <p:nvPr>
-            <p:ph idx="1"/>
-          </p:nvPr>
-        </p:nvSpPr>
-        <p:spPr/>
-        <p:txBody>
-          <a:bodyPr/>
-          <a:lstStyle/>
-          <a:p>
-            <a:endParaRPr lang="en-PK"/>
-          </a:p>
-        </p:txBody>
-      </p:sp>
-      <p:sp>
-        <p:nvSpPr>
-          <p:cNvPr id="4" name="TextBox 3">
-            <a:extLst>
-              <a:ext uri="{FF2B5EF4-FFF2-40B4-BE49-F238E27FC236}">
-                <a16:creationId xmlns:a16="http://schemas.microsoft.com/office/drawing/2014/main" id="{0A7E4356-78CB-9D4C-4101-1CD06109856B}"/>
-              </a:ext>
-            </a:extLst>
-          </p:cNvPr>
-          <p:cNvSpPr txBox="1"/>
-          <p:nvPr/>
-        </p:nvSpPr>
-        <p:spPr>
-          <a:xfrm>
-            <a:off x="152400" y="6488668"/>
-            <a:ext cx="11887200" cy="369332"/>
-          </a:xfrm>
-          <a:prstGeom prst="rect">
-            <a:avLst/>
-          </a:prstGeom>
-          <a:noFill/>
-        </p:spPr>
-        <p:txBody>
-          <a:bodyPr wrap="square" rtlCol="0">
-            <a:spAutoFit/>
-          </a:bodyPr>
-          <a:lstStyle/>
-          <a:p>
-            <a:r>
-              <a:rPr lang="en-US" b="1" dirty="0">
-                <a:solidFill>
-                  <a:srgbClr val="0070C0"/>
-                </a:solidFill>
-              </a:rPr>
-              <a:t>FACULTY OF PHARMACY AND PHARMACEUTICAL SCIENCES                                                                               </a:t>
-            </a:r>
-            <a:r>
-              <a:rPr lang="en-US" b="1" dirty="0">
-                <a:solidFill>
-                  <a:schemeClr val="accent2"/>
-                </a:solidFill>
-              </a:rPr>
-              <a:t>SOFTSOLS PAKISTAN</a:t>
-            </a:r>
-            <a:endParaRPr lang="en-PK" b="1" dirty="0">
-              <a:solidFill>
-                <a:schemeClr val="accent2"/>
-              </a:solidFill>
-            </a:endParaRPr>
-          </a:p>
-        </p:txBody>
-      </p:sp>
-    </p:spTree>
-    <p:extLst>
-      <p:ext uri="{BB962C8B-B14F-4D97-AF65-F5344CB8AC3E}">
-        <p14:creationId xmlns:p14="http://schemas.microsoft.com/office/powerpoint/2010/main" val="1084159943"/>
-      </p:ext>
-    </p:extLst>
-  </p:cSld>
-  <p:clrMapOvr>
-    <a:masterClrMapping/>
-  </p:clrMapOvr>
-</p:sld>
-</file>
-
-<file path=ppt/slides/slide13.xml><?xml version="1.0" encoding="utf-8"?>
-<p:sld xmlns:a="http://schemas.openxmlformats.org/drawingml/2006/main" xmlns:r="http://schemas.openxmlformats.org/officeDocument/2006/relationships" xmlns:p="http://schemas.openxmlformats.org/presentationml/2006/main">
-  <p:cSld>
-    <p:spTree>
-      <p:nvGrpSpPr>
-        <p:cNvPr id="1" name="">
-          <a:extLst>
-            <a:ext uri="{FF2B5EF4-FFF2-40B4-BE49-F238E27FC236}">
-              <a16:creationId xmlns:a16="http://schemas.microsoft.com/office/drawing/2014/main" id="{5E931C6F-5FA5-5046-C1AB-6CF052E71156}"/>
-            </a:ext>
-          </a:extLst>
-        </p:cNvPr>
-        <p:cNvGrpSpPr/>
-        <p:nvPr/>
-      </p:nvGrpSpPr>
-      <p:grpSpPr>
-        <a:xfrm>
-          <a:off x="0" y="0"/>
-          <a:ext cx="0" cy="0"/>
-          <a:chOff x="0" y="0"/>
-          <a:chExt cx="0" cy="0"/>
-        </a:xfrm>
-      </p:grpSpPr>
-      <p:sp>
-        <p:nvSpPr>
-          <p:cNvPr id="2" name="Title 1">
-            <a:extLst>
-              <a:ext uri="{FF2B5EF4-FFF2-40B4-BE49-F238E27FC236}">
-                <a16:creationId xmlns:a16="http://schemas.microsoft.com/office/drawing/2014/main" id="{A8BB61C2-6332-754F-8B45-579D7EEAAF73}"/>
-              </a:ext>
-            </a:extLst>
-          </p:cNvPr>
-          <p:cNvSpPr>
-            <a:spLocks noGrp="1"/>
-          </p:cNvSpPr>
-          <p:nvPr>
-            <p:ph type="title"/>
-          </p:nvPr>
-        </p:nvSpPr>
-        <p:spPr/>
-        <p:txBody>
-          <a:bodyPr/>
-          <a:lstStyle/>
-          <a:p>
-            <a:endParaRPr lang="en-PK"/>
-          </a:p>
-        </p:txBody>
-      </p:sp>
-      <p:sp>
-        <p:nvSpPr>
-          <p:cNvPr id="3" name="Content Placeholder 2">
-            <a:extLst>
-              <a:ext uri="{FF2B5EF4-FFF2-40B4-BE49-F238E27FC236}">
-                <a16:creationId xmlns:a16="http://schemas.microsoft.com/office/drawing/2014/main" id="{F4E42094-EB03-4D0F-2D94-279E6BFA12E2}"/>
-              </a:ext>
-            </a:extLst>
-          </p:cNvPr>
-          <p:cNvSpPr>
-            <a:spLocks noGrp="1"/>
-          </p:cNvSpPr>
-          <p:nvPr>
-            <p:ph idx="1"/>
-          </p:nvPr>
-        </p:nvSpPr>
-        <p:spPr/>
-        <p:txBody>
-          <a:bodyPr/>
-          <a:lstStyle/>
-          <a:p>
-            <a:endParaRPr lang="en-PK"/>
-          </a:p>
-        </p:txBody>
-      </p:sp>
-      <p:sp>
-        <p:nvSpPr>
-          <p:cNvPr id="4" name="TextBox 3">
-            <a:extLst>
-              <a:ext uri="{FF2B5EF4-FFF2-40B4-BE49-F238E27FC236}">
-                <a16:creationId xmlns:a16="http://schemas.microsoft.com/office/drawing/2014/main" id="{BC158E87-A0EF-164F-B1A7-094642852BB4}"/>
-              </a:ext>
-            </a:extLst>
-          </p:cNvPr>
-          <p:cNvSpPr txBox="1"/>
-          <p:nvPr/>
-        </p:nvSpPr>
-        <p:spPr>
-          <a:xfrm>
-            <a:off x="152400" y="6488668"/>
-            <a:ext cx="11887200" cy="369332"/>
-          </a:xfrm>
-          <a:prstGeom prst="rect">
-            <a:avLst/>
-          </a:prstGeom>
-          <a:noFill/>
-        </p:spPr>
-        <p:txBody>
-          <a:bodyPr wrap="square" rtlCol="0">
-            <a:spAutoFit/>
-          </a:bodyPr>
-          <a:lstStyle/>
-          <a:p>
-            <a:r>
-              <a:rPr lang="en-US" b="1" dirty="0">
-                <a:solidFill>
-                  <a:srgbClr val="0070C0"/>
-                </a:solidFill>
-              </a:rPr>
-              <a:t>FACULTY OF PHARMACY AND PHARMACEUTICAL SCIENCES                                                                               </a:t>
-            </a:r>
-            <a:r>
-              <a:rPr lang="en-US" b="1" dirty="0">
-                <a:solidFill>
-                  <a:schemeClr val="accent2"/>
-                </a:solidFill>
-              </a:rPr>
-              <a:t>SOFTSOLS PAKISTAN</a:t>
-            </a:r>
-            <a:endParaRPr lang="en-PK" b="1" dirty="0">
-              <a:solidFill>
-                <a:schemeClr val="accent2"/>
-              </a:solidFill>
-            </a:endParaRPr>
-          </a:p>
-        </p:txBody>
-      </p:sp>
-    </p:spTree>
-    <p:extLst>
-      <p:ext uri="{BB962C8B-B14F-4D97-AF65-F5344CB8AC3E}">
-        <p14:creationId xmlns:p14="http://schemas.microsoft.com/office/powerpoint/2010/main" val="2017795440"/>
-      </p:ext>
-    </p:extLst>
-  </p:cSld>
-  <p:clrMapOvr>
-    <a:masterClrMapping/>
-  </p:clrMapOvr>
-</p:sld>
-</file>
-
-<file path=ppt/slides/slide14.xml><?xml version="1.0" encoding="utf-8"?>
-<p:sld xmlns:a="http://schemas.openxmlformats.org/drawingml/2006/main" xmlns:r="http://schemas.openxmlformats.org/officeDocument/2006/relationships" xmlns:p="http://schemas.openxmlformats.org/presentationml/2006/main">
-  <p:cSld>
-    <p:spTree>
-      <p:nvGrpSpPr>
-        <p:cNvPr id="1" name="">
-          <a:extLst>
-            <a:ext uri="{FF2B5EF4-FFF2-40B4-BE49-F238E27FC236}">
               <a16:creationId xmlns:a16="http://schemas.microsoft.com/office/drawing/2014/main" id="{C5058DD3-5E18-AA42-0926-509EBDC3EC61}"/>
             </a:ext>
           </a:extLst>
@@ -4244,6 +3693,106 @@
           </a:p>
         </p:txBody>
       </p:sp>
+      <p:pic>
+        <p:nvPicPr>
+          <p:cNvPr id="6" name="Picture 5">
+            <a:extLst>
+              <a:ext uri="{FF2B5EF4-FFF2-40B4-BE49-F238E27FC236}">
+                <a16:creationId xmlns:a16="http://schemas.microsoft.com/office/drawing/2014/main" id="{347AD79F-F674-6999-8751-67C8E8CEA824}"/>
+              </a:ext>
+            </a:extLst>
+          </p:cNvPr>
+          <p:cNvPicPr>
+            <a:picLocks noChangeAspect="1"/>
+          </p:cNvPicPr>
+          <p:nvPr/>
+        </p:nvPicPr>
+        <p:blipFill>
+          <a:blip r:embed="rId2"/>
+          <a:stretch>
+            <a:fillRect/>
+          </a:stretch>
+        </p:blipFill>
+        <p:spPr>
+          <a:xfrm>
+            <a:off x="0" y="-1"/>
+            <a:ext cx="12192000" cy="6176963"/>
+          </a:xfrm>
+          <a:prstGeom prst="rect">
+            <a:avLst/>
+          </a:prstGeom>
+        </p:spPr>
+      </p:pic>
+      <p:sp>
+        <p:nvSpPr>
+          <p:cNvPr id="7" name="TextBox 6">
+            <a:extLst>
+              <a:ext uri="{FF2B5EF4-FFF2-40B4-BE49-F238E27FC236}">
+                <a16:creationId xmlns:a16="http://schemas.microsoft.com/office/drawing/2014/main" id="{2ADBF171-DAFA-60D2-ACD8-119BDE2819BD}"/>
+              </a:ext>
+            </a:extLst>
+          </p:cNvPr>
+          <p:cNvSpPr txBox="1"/>
+          <p:nvPr/>
+        </p:nvSpPr>
+        <p:spPr>
+          <a:xfrm>
+            <a:off x="3183467" y="3905956"/>
+            <a:ext cx="6310489" cy="1477328"/>
+          </a:xfrm>
+          <a:prstGeom prst="rect">
+            <a:avLst/>
+          </a:prstGeom>
+          <a:noFill/>
+        </p:spPr>
+        <p:txBody>
+          <a:bodyPr wrap="square" rtlCol="0">
+            <a:spAutoFit/>
+          </a:bodyPr>
+          <a:lstStyle/>
+          <a:p>
+            <a:r>
+              <a:rPr lang="en-US" b="1" dirty="0">
+                <a:solidFill>
+                  <a:srgbClr val="FF0000"/>
+                </a:solidFill>
+              </a:rPr>
+              <a:t>In Result Page, Teacher, HOD and Admin will be able to Post and Access Result of any Subject which will be viewable to higher </a:t>
+            </a:r>
+            <a:r>
+              <a:rPr lang="en-US" b="1" dirty="0" err="1">
+                <a:solidFill>
+                  <a:srgbClr val="FF0000"/>
+                </a:solidFill>
+              </a:rPr>
+              <a:t>hirerchy</a:t>
+            </a:r>
+            <a:r>
+              <a:rPr lang="en-US" b="1" dirty="0">
+                <a:solidFill>
+                  <a:srgbClr val="FF0000"/>
+                </a:solidFill>
+              </a:rPr>
+              <a:t>.</a:t>
+            </a:r>
+          </a:p>
+          <a:p>
+            <a:r>
+              <a:rPr lang="en-US" b="1" dirty="0">
+                <a:solidFill>
+                  <a:srgbClr val="FF0000"/>
+                </a:solidFill>
+              </a:rPr>
+              <a:t>Like any Teacher post Result then it will be viewable to respective HOD and Dean.</a:t>
+            </a:r>
+            <a:endParaRPr lang="en-PK" b="1" dirty="0">
+              <a:solidFill>
+                <a:srgbClr val="FF0000"/>
+              </a:solidFill>
+            </a:endParaRPr>
+          </a:p>
+        </p:txBody>
+      </p:sp>
     </p:spTree>
     <p:extLst>
       <p:ext uri="{BB962C8B-B14F-4D97-AF65-F5344CB8AC3E}">
@@ -4257,7 +3806,7 @@
 </p:sld>
 </file>
 
-<file path=ppt/slides/slide15.xml><?xml version="1.0" encoding="utf-8"?>
+<file path=ppt/slides/slide11.xml><?xml version="1.0" encoding="utf-8"?>
 <p:sld xmlns:a="http://schemas.openxmlformats.org/drawingml/2006/main" xmlns:r="http://schemas.openxmlformats.org/officeDocument/2006/relationships" xmlns:p="http://schemas.openxmlformats.org/presentationml/2006/main">
   <p:cSld>
     <p:spTree>
@@ -4382,6 +3931,80 @@
           </a:p>
         </p:txBody>
       </p:sp>
+      <p:pic>
+        <p:nvPicPr>
+          <p:cNvPr id="6" name="Picture 5">
+            <a:extLst>
+              <a:ext uri="{FF2B5EF4-FFF2-40B4-BE49-F238E27FC236}">
+                <a16:creationId xmlns:a16="http://schemas.microsoft.com/office/drawing/2014/main" id="{9CE91497-74AB-C859-CAC4-609EBB3D3166}"/>
+              </a:ext>
+            </a:extLst>
+          </p:cNvPr>
+          <p:cNvPicPr>
+            <a:picLocks noChangeAspect="1"/>
+          </p:cNvPicPr>
+          <p:nvPr/>
+        </p:nvPicPr>
+        <p:blipFill>
+          <a:blip r:embed="rId2"/>
+          <a:stretch>
+            <a:fillRect/>
+          </a:stretch>
+        </p:blipFill>
+        <p:spPr>
+          <a:xfrm>
+            <a:off x="0" y="0"/>
+            <a:ext cx="12192000" cy="6276622"/>
+          </a:xfrm>
+          <a:prstGeom prst="rect">
+            <a:avLst/>
+          </a:prstGeom>
+        </p:spPr>
+      </p:pic>
+      <p:sp>
+        <p:nvSpPr>
+          <p:cNvPr id="7" name="TextBox 6">
+            <a:extLst>
+              <a:ext uri="{FF2B5EF4-FFF2-40B4-BE49-F238E27FC236}">
+                <a16:creationId xmlns:a16="http://schemas.microsoft.com/office/drawing/2014/main" id="{3A857F7E-8077-3723-8DB7-240ADF0280AA}"/>
+              </a:ext>
+            </a:extLst>
+          </p:cNvPr>
+          <p:cNvSpPr txBox="1"/>
+          <p:nvPr/>
+        </p:nvSpPr>
+        <p:spPr>
+          <a:xfrm>
+            <a:off x="3149600" y="4301067"/>
+            <a:ext cx="6739467" cy="646331"/>
+          </a:xfrm>
+          <a:prstGeom prst="rect">
+            <a:avLst/>
+          </a:prstGeom>
+          <a:noFill/>
+        </p:spPr>
+        <p:txBody>
+          <a:bodyPr wrap="square" rtlCol="0">
+            <a:spAutoFit/>
+          </a:bodyPr>
+          <a:lstStyle/>
+          <a:p>
+            <a:r>
+              <a:rPr lang="en-US" b="1" dirty="0">
+                <a:solidFill>
+                  <a:srgbClr val="FF0000"/>
+                </a:solidFill>
+              </a:rPr>
+              <a:t>Dean Office (Sub-Admin) and Dean (Admin) able to add Examination Date Sheet and Exam Results will be added by respective Teacher</a:t>
+            </a:r>
+            <a:endParaRPr lang="en-PK" b="1" dirty="0">
+              <a:solidFill>
+                <a:srgbClr val="FF0000"/>
+              </a:solidFill>
+            </a:endParaRPr>
+          </a:p>
+        </p:txBody>
+      </p:sp>
     </p:spTree>
     <p:extLst>
       <p:ext uri="{BB962C8B-B14F-4D97-AF65-F5344CB8AC3E}">
@@ -4395,7 +4018,771 @@
 </p:sld>
 </file>
 
+<file path=ppt/slides/slide12.xml><?xml version="1.0" encoding="utf-8"?>
+<p:sld xmlns:a="http://schemas.openxmlformats.org/drawingml/2006/main" xmlns:r="http://schemas.openxmlformats.org/officeDocument/2006/relationships" xmlns:p="http://schemas.openxmlformats.org/presentationml/2006/main">
+  <p:cSld>
+    <p:spTree>
+      <p:nvGrpSpPr>
+        <p:cNvPr id="1" name="">
+          <a:extLst>
+            <a:ext uri="{FF2B5EF4-FFF2-40B4-BE49-F238E27FC236}">
+              <a16:creationId xmlns:a16="http://schemas.microsoft.com/office/drawing/2014/main" id="{82528CEC-B39E-5887-06DF-A3A7BC89B011}"/>
+            </a:ext>
+          </a:extLst>
+        </p:cNvPr>
+        <p:cNvGrpSpPr/>
+        <p:nvPr/>
+      </p:nvGrpSpPr>
+      <p:grpSpPr>
+        <a:xfrm>
+          <a:off x="0" y="0"/>
+          <a:ext cx="0" cy="0"/>
+          <a:chOff x="0" y="0"/>
+          <a:chExt cx="0" cy="0"/>
+        </a:xfrm>
+      </p:grpSpPr>
+      <p:sp>
+        <p:nvSpPr>
+          <p:cNvPr id="2" name="Title 1">
+            <a:extLst>
+              <a:ext uri="{FF2B5EF4-FFF2-40B4-BE49-F238E27FC236}">
+                <a16:creationId xmlns:a16="http://schemas.microsoft.com/office/drawing/2014/main" id="{53BD4E10-CF2E-EBA3-5BFD-411E6D14B8C8}"/>
+              </a:ext>
+            </a:extLst>
+          </p:cNvPr>
+          <p:cNvSpPr>
+            <a:spLocks noGrp="1"/>
+          </p:cNvSpPr>
+          <p:nvPr>
+            <p:ph type="title"/>
+          </p:nvPr>
+        </p:nvSpPr>
+        <p:spPr/>
+        <p:txBody>
+          <a:bodyPr/>
+          <a:lstStyle/>
+          <a:p>
+            <a:endParaRPr lang="en-PK"/>
+          </a:p>
+        </p:txBody>
+      </p:sp>
+      <p:sp>
+        <p:nvSpPr>
+          <p:cNvPr id="3" name="Content Placeholder 2">
+            <a:extLst>
+              <a:ext uri="{FF2B5EF4-FFF2-40B4-BE49-F238E27FC236}">
+                <a16:creationId xmlns:a16="http://schemas.microsoft.com/office/drawing/2014/main" id="{53A0FBDC-596F-56E7-2BC8-9F070F7B0F8B}"/>
+              </a:ext>
+            </a:extLst>
+          </p:cNvPr>
+          <p:cNvSpPr>
+            <a:spLocks noGrp="1"/>
+          </p:cNvSpPr>
+          <p:nvPr>
+            <p:ph idx="1"/>
+          </p:nvPr>
+        </p:nvSpPr>
+        <p:spPr/>
+        <p:txBody>
+          <a:bodyPr/>
+          <a:lstStyle/>
+          <a:p>
+            <a:endParaRPr lang="en-PK"/>
+          </a:p>
+        </p:txBody>
+      </p:sp>
+      <p:sp>
+        <p:nvSpPr>
+          <p:cNvPr id="4" name="TextBox 3">
+            <a:extLst>
+              <a:ext uri="{FF2B5EF4-FFF2-40B4-BE49-F238E27FC236}">
+                <a16:creationId xmlns:a16="http://schemas.microsoft.com/office/drawing/2014/main" id="{74CD3557-C7DC-0B07-9832-ECC114F81296}"/>
+              </a:ext>
+            </a:extLst>
+          </p:cNvPr>
+          <p:cNvSpPr txBox="1"/>
+          <p:nvPr/>
+        </p:nvSpPr>
+        <p:spPr>
+          <a:xfrm>
+            <a:off x="152400" y="6488668"/>
+            <a:ext cx="11887200" cy="369332"/>
+          </a:xfrm>
+          <a:prstGeom prst="rect">
+            <a:avLst/>
+          </a:prstGeom>
+          <a:noFill/>
+        </p:spPr>
+        <p:txBody>
+          <a:bodyPr wrap="square" rtlCol="0">
+            <a:spAutoFit/>
+          </a:bodyPr>
+          <a:lstStyle/>
+          <a:p>
+            <a:r>
+              <a:rPr lang="en-US" b="1" dirty="0">
+                <a:solidFill>
+                  <a:srgbClr val="0070C0"/>
+                </a:solidFill>
+              </a:rPr>
+              <a:t>FACULTY OF PHARMACY AND PHARMACEUTICAL SCIENCES                                                                               </a:t>
+            </a:r>
+            <a:r>
+              <a:rPr lang="en-US" b="1" dirty="0">
+                <a:solidFill>
+                  <a:schemeClr val="accent2"/>
+                </a:solidFill>
+              </a:rPr>
+              <a:t>SOFTSOLS PAKISTAN</a:t>
+            </a:r>
+            <a:endParaRPr lang="en-PK" b="1" dirty="0">
+              <a:solidFill>
+                <a:schemeClr val="accent2"/>
+              </a:solidFill>
+            </a:endParaRPr>
+          </a:p>
+        </p:txBody>
+      </p:sp>
+      <p:pic>
+        <p:nvPicPr>
+          <p:cNvPr id="6" name="Picture 5">
+            <a:extLst>
+              <a:ext uri="{FF2B5EF4-FFF2-40B4-BE49-F238E27FC236}">
+                <a16:creationId xmlns:a16="http://schemas.microsoft.com/office/drawing/2014/main" id="{28DD3AEE-CD37-6ADB-B5E2-EC399E20E73D}"/>
+              </a:ext>
+            </a:extLst>
+          </p:cNvPr>
+          <p:cNvPicPr>
+            <a:picLocks noChangeAspect="1"/>
+          </p:cNvPicPr>
+          <p:nvPr/>
+        </p:nvPicPr>
+        <p:blipFill>
+          <a:blip r:embed="rId2"/>
+          <a:stretch>
+            <a:fillRect/>
+          </a:stretch>
+        </p:blipFill>
+        <p:spPr>
+          <a:xfrm>
+            <a:off x="0" y="155985"/>
+            <a:ext cx="12192000" cy="6020978"/>
+          </a:xfrm>
+          <a:prstGeom prst="rect">
+            <a:avLst/>
+          </a:prstGeom>
+        </p:spPr>
+      </p:pic>
+      <p:sp>
+        <p:nvSpPr>
+          <p:cNvPr id="7" name="TextBox 6">
+            <a:extLst>
+              <a:ext uri="{FF2B5EF4-FFF2-40B4-BE49-F238E27FC236}">
+                <a16:creationId xmlns:a16="http://schemas.microsoft.com/office/drawing/2014/main" id="{BF9B2BDA-1DB4-4C9C-D1FD-C995DBB7DACA}"/>
+              </a:ext>
+            </a:extLst>
+          </p:cNvPr>
+          <p:cNvSpPr txBox="1"/>
+          <p:nvPr/>
+        </p:nvSpPr>
+        <p:spPr>
+          <a:xfrm>
+            <a:off x="8669867" y="2585156"/>
+            <a:ext cx="2946400" cy="1200329"/>
+          </a:xfrm>
+          <a:prstGeom prst="rect">
+            <a:avLst/>
+          </a:prstGeom>
+          <a:noFill/>
+        </p:spPr>
+        <p:txBody>
+          <a:bodyPr wrap="square" rtlCol="0">
+            <a:spAutoFit/>
+          </a:bodyPr>
+          <a:lstStyle/>
+          <a:p>
+            <a:r>
+              <a:rPr lang="en-US" b="1" dirty="0">
+                <a:solidFill>
+                  <a:srgbClr val="FF0000"/>
+                </a:solidFill>
+              </a:rPr>
+              <a:t>Semester Wise Time Table will be added by Dean Office and Department Head and also by Dean (Admin)</a:t>
+            </a:r>
+            <a:endParaRPr lang="en-PK" b="1" dirty="0">
+              <a:solidFill>
+                <a:srgbClr val="FF0000"/>
+              </a:solidFill>
+            </a:endParaRPr>
+          </a:p>
+        </p:txBody>
+      </p:sp>
+    </p:spTree>
+    <p:extLst>
+      <p:ext uri="{BB962C8B-B14F-4D97-AF65-F5344CB8AC3E}">
+        <p14:creationId xmlns:p14="http://schemas.microsoft.com/office/powerpoint/2010/main" val="3616657786"/>
+      </p:ext>
+    </p:extLst>
+  </p:cSld>
+  <p:clrMapOvr>
+    <a:masterClrMapping/>
+  </p:clrMapOvr>
+</p:sld>
+</file>
+
+<file path=ppt/slides/slide13.xml><?xml version="1.0" encoding="utf-8"?>
+<p:sld xmlns:a="http://schemas.openxmlformats.org/drawingml/2006/main" xmlns:r="http://schemas.openxmlformats.org/officeDocument/2006/relationships" xmlns:p="http://schemas.openxmlformats.org/presentationml/2006/main">
+  <p:cSld>
+    <p:spTree>
+      <p:nvGrpSpPr>
+        <p:cNvPr id="1" name="">
+          <a:extLst>
+            <a:ext uri="{FF2B5EF4-FFF2-40B4-BE49-F238E27FC236}">
+              <a16:creationId xmlns:a16="http://schemas.microsoft.com/office/drawing/2014/main" id="{89555F76-597A-A21F-811D-B0F2D42B9A6F}"/>
+            </a:ext>
+          </a:extLst>
+        </p:cNvPr>
+        <p:cNvGrpSpPr/>
+        <p:nvPr/>
+      </p:nvGrpSpPr>
+      <p:grpSpPr>
+        <a:xfrm>
+          <a:off x="0" y="0"/>
+          <a:ext cx="0" cy="0"/>
+          <a:chOff x="0" y="0"/>
+          <a:chExt cx="0" cy="0"/>
+        </a:xfrm>
+      </p:grpSpPr>
+      <p:sp>
+        <p:nvSpPr>
+          <p:cNvPr id="2" name="Title 1">
+            <a:extLst>
+              <a:ext uri="{FF2B5EF4-FFF2-40B4-BE49-F238E27FC236}">
+                <a16:creationId xmlns:a16="http://schemas.microsoft.com/office/drawing/2014/main" id="{5443DFF4-A16F-3DD5-59C3-DC264A45B93E}"/>
+              </a:ext>
+            </a:extLst>
+          </p:cNvPr>
+          <p:cNvSpPr>
+            <a:spLocks noGrp="1"/>
+          </p:cNvSpPr>
+          <p:nvPr>
+            <p:ph type="title"/>
+          </p:nvPr>
+        </p:nvSpPr>
+        <p:spPr/>
+        <p:txBody>
+          <a:bodyPr/>
+          <a:lstStyle/>
+          <a:p>
+            <a:endParaRPr lang="en-PK"/>
+          </a:p>
+        </p:txBody>
+      </p:sp>
+      <p:sp>
+        <p:nvSpPr>
+          <p:cNvPr id="3" name="Content Placeholder 2">
+            <a:extLst>
+              <a:ext uri="{FF2B5EF4-FFF2-40B4-BE49-F238E27FC236}">
+                <a16:creationId xmlns:a16="http://schemas.microsoft.com/office/drawing/2014/main" id="{EB6FA396-1426-A944-022E-E7665C8C76FD}"/>
+              </a:ext>
+            </a:extLst>
+          </p:cNvPr>
+          <p:cNvSpPr>
+            <a:spLocks noGrp="1"/>
+          </p:cNvSpPr>
+          <p:nvPr>
+            <p:ph idx="1"/>
+          </p:nvPr>
+        </p:nvSpPr>
+        <p:spPr/>
+        <p:txBody>
+          <a:bodyPr/>
+          <a:lstStyle/>
+          <a:p>
+            <a:endParaRPr lang="en-PK"/>
+          </a:p>
+        </p:txBody>
+      </p:sp>
+      <p:sp>
+        <p:nvSpPr>
+          <p:cNvPr id="4" name="TextBox 3">
+            <a:extLst>
+              <a:ext uri="{FF2B5EF4-FFF2-40B4-BE49-F238E27FC236}">
+                <a16:creationId xmlns:a16="http://schemas.microsoft.com/office/drawing/2014/main" id="{93023CD9-E1EA-4665-6957-8C2D508378CA}"/>
+              </a:ext>
+            </a:extLst>
+          </p:cNvPr>
+          <p:cNvSpPr txBox="1"/>
+          <p:nvPr/>
+        </p:nvSpPr>
+        <p:spPr>
+          <a:xfrm>
+            <a:off x="152400" y="6488668"/>
+            <a:ext cx="11887200" cy="369332"/>
+          </a:xfrm>
+          <a:prstGeom prst="rect">
+            <a:avLst/>
+          </a:prstGeom>
+          <a:noFill/>
+        </p:spPr>
+        <p:txBody>
+          <a:bodyPr wrap="square" rtlCol="0">
+            <a:spAutoFit/>
+          </a:bodyPr>
+          <a:lstStyle/>
+          <a:p>
+            <a:r>
+              <a:rPr lang="en-US" b="1" dirty="0">
+                <a:solidFill>
+                  <a:srgbClr val="0070C0"/>
+                </a:solidFill>
+              </a:rPr>
+              <a:t>FACULTY OF PHARMACY AND PHARMACEUTICAL SCIENCES                                                                               </a:t>
+            </a:r>
+            <a:r>
+              <a:rPr lang="en-US" b="1" dirty="0">
+                <a:solidFill>
+                  <a:schemeClr val="accent2"/>
+                </a:solidFill>
+              </a:rPr>
+              <a:t>SOFTSOLS PAKISTAN</a:t>
+            </a:r>
+            <a:endParaRPr lang="en-PK" b="1" dirty="0">
+              <a:solidFill>
+                <a:schemeClr val="accent2"/>
+              </a:solidFill>
+            </a:endParaRPr>
+          </a:p>
+        </p:txBody>
+      </p:sp>
+    </p:spTree>
+    <p:extLst>
+      <p:ext uri="{BB962C8B-B14F-4D97-AF65-F5344CB8AC3E}">
+        <p14:creationId xmlns:p14="http://schemas.microsoft.com/office/powerpoint/2010/main" val="1043758876"/>
+      </p:ext>
+    </p:extLst>
+  </p:cSld>
+  <p:clrMapOvr>
+    <a:masterClrMapping/>
+  </p:clrMapOvr>
+</p:sld>
+</file>
+
+<file path=ppt/slides/slide14.xml><?xml version="1.0" encoding="utf-8"?>
+<p:sld xmlns:a="http://schemas.openxmlformats.org/drawingml/2006/main" xmlns:r="http://schemas.openxmlformats.org/officeDocument/2006/relationships" xmlns:p="http://schemas.openxmlformats.org/presentationml/2006/main">
+  <p:cSld>
+    <p:spTree>
+      <p:nvGrpSpPr>
+        <p:cNvPr id="1" name="">
+          <a:extLst>
+            <a:ext uri="{FF2B5EF4-FFF2-40B4-BE49-F238E27FC236}">
+              <a16:creationId xmlns:a16="http://schemas.microsoft.com/office/drawing/2014/main" id="{B61347C6-86B1-26B4-A47C-8092F41F3F54}"/>
+            </a:ext>
+          </a:extLst>
+        </p:cNvPr>
+        <p:cNvGrpSpPr/>
+        <p:nvPr/>
+      </p:nvGrpSpPr>
+      <p:grpSpPr>
+        <a:xfrm>
+          <a:off x="0" y="0"/>
+          <a:ext cx="0" cy="0"/>
+          <a:chOff x="0" y="0"/>
+          <a:chExt cx="0" cy="0"/>
+        </a:xfrm>
+      </p:grpSpPr>
+      <p:sp>
+        <p:nvSpPr>
+          <p:cNvPr id="2" name="Title 1">
+            <a:extLst>
+              <a:ext uri="{FF2B5EF4-FFF2-40B4-BE49-F238E27FC236}">
+                <a16:creationId xmlns:a16="http://schemas.microsoft.com/office/drawing/2014/main" id="{F5922625-5AD7-FD8C-FC94-5F15DFCCFC23}"/>
+              </a:ext>
+            </a:extLst>
+          </p:cNvPr>
+          <p:cNvSpPr>
+            <a:spLocks noGrp="1"/>
+          </p:cNvSpPr>
+          <p:nvPr>
+            <p:ph type="title"/>
+          </p:nvPr>
+        </p:nvSpPr>
+        <p:spPr/>
+        <p:txBody>
+          <a:bodyPr/>
+          <a:lstStyle/>
+          <a:p>
+            <a:endParaRPr lang="en-PK"/>
+          </a:p>
+        </p:txBody>
+      </p:sp>
+      <p:sp>
+        <p:nvSpPr>
+          <p:cNvPr id="3" name="Content Placeholder 2">
+            <a:extLst>
+              <a:ext uri="{FF2B5EF4-FFF2-40B4-BE49-F238E27FC236}">
+                <a16:creationId xmlns:a16="http://schemas.microsoft.com/office/drawing/2014/main" id="{B0362F03-0E4C-B28D-D0BA-E40794A5EAF9}"/>
+              </a:ext>
+            </a:extLst>
+          </p:cNvPr>
+          <p:cNvSpPr>
+            <a:spLocks noGrp="1"/>
+          </p:cNvSpPr>
+          <p:nvPr>
+            <p:ph idx="1"/>
+          </p:nvPr>
+        </p:nvSpPr>
+        <p:spPr/>
+        <p:txBody>
+          <a:bodyPr/>
+          <a:lstStyle/>
+          <a:p>
+            <a:endParaRPr lang="en-PK"/>
+          </a:p>
+        </p:txBody>
+      </p:sp>
+      <p:sp>
+        <p:nvSpPr>
+          <p:cNvPr id="4" name="TextBox 3">
+            <a:extLst>
+              <a:ext uri="{FF2B5EF4-FFF2-40B4-BE49-F238E27FC236}">
+                <a16:creationId xmlns:a16="http://schemas.microsoft.com/office/drawing/2014/main" id="{B20A7A6C-92BC-769A-33A4-7AAE83913A7B}"/>
+              </a:ext>
+            </a:extLst>
+          </p:cNvPr>
+          <p:cNvSpPr txBox="1"/>
+          <p:nvPr/>
+        </p:nvSpPr>
+        <p:spPr>
+          <a:xfrm>
+            <a:off x="152400" y="6488668"/>
+            <a:ext cx="11887200" cy="369332"/>
+          </a:xfrm>
+          <a:prstGeom prst="rect">
+            <a:avLst/>
+          </a:prstGeom>
+          <a:noFill/>
+        </p:spPr>
+        <p:txBody>
+          <a:bodyPr wrap="square" rtlCol="0">
+            <a:spAutoFit/>
+          </a:bodyPr>
+          <a:lstStyle/>
+          <a:p>
+            <a:r>
+              <a:rPr lang="en-US" b="1" dirty="0">
+                <a:solidFill>
+                  <a:srgbClr val="0070C0"/>
+                </a:solidFill>
+              </a:rPr>
+              <a:t>FACULTY OF PHARMACY AND PHARMACEUTICAL SCIENCES                                                                               </a:t>
+            </a:r>
+            <a:r>
+              <a:rPr lang="en-US" b="1" dirty="0">
+                <a:solidFill>
+                  <a:schemeClr val="accent2"/>
+                </a:solidFill>
+              </a:rPr>
+              <a:t>SOFTSOLS PAKISTAN</a:t>
+            </a:r>
+            <a:endParaRPr lang="en-PK" b="1" dirty="0">
+              <a:solidFill>
+                <a:schemeClr val="accent2"/>
+              </a:solidFill>
+            </a:endParaRPr>
+          </a:p>
+        </p:txBody>
+      </p:sp>
+    </p:spTree>
+    <p:extLst>
+      <p:ext uri="{BB962C8B-B14F-4D97-AF65-F5344CB8AC3E}">
+        <p14:creationId xmlns:p14="http://schemas.microsoft.com/office/powerpoint/2010/main" val="2648722791"/>
+      </p:ext>
+    </p:extLst>
+  </p:cSld>
+  <p:clrMapOvr>
+    <a:masterClrMapping/>
+  </p:clrMapOvr>
+</p:sld>
+</file>
+
+<file path=ppt/slides/slide15.xml><?xml version="1.0" encoding="utf-8"?>
+<p:sld xmlns:a="http://schemas.openxmlformats.org/drawingml/2006/main" xmlns:r="http://schemas.openxmlformats.org/officeDocument/2006/relationships" xmlns:p="http://schemas.openxmlformats.org/presentationml/2006/main">
+  <p:cSld>
+    <p:spTree>
+      <p:nvGrpSpPr>
+        <p:cNvPr id="1" name="">
+          <a:extLst>
+            <a:ext uri="{FF2B5EF4-FFF2-40B4-BE49-F238E27FC236}">
+              <a16:creationId xmlns:a16="http://schemas.microsoft.com/office/drawing/2014/main" id="{DC53E94A-DC0B-B097-EBAD-F10012F145A9}"/>
+            </a:ext>
+          </a:extLst>
+        </p:cNvPr>
+        <p:cNvGrpSpPr/>
+        <p:nvPr/>
+      </p:nvGrpSpPr>
+      <p:grpSpPr>
+        <a:xfrm>
+          <a:off x="0" y="0"/>
+          <a:ext cx="0" cy="0"/>
+          <a:chOff x="0" y="0"/>
+          <a:chExt cx="0" cy="0"/>
+        </a:xfrm>
+      </p:grpSpPr>
+      <p:sp>
+        <p:nvSpPr>
+          <p:cNvPr id="2" name="Title 1">
+            <a:extLst>
+              <a:ext uri="{FF2B5EF4-FFF2-40B4-BE49-F238E27FC236}">
+                <a16:creationId xmlns:a16="http://schemas.microsoft.com/office/drawing/2014/main" id="{1831C7F5-164B-8352-D346-016979F198AB}"/>
+              </a:ext>
+            </a:extLst>
+          </p:cNvPr>
+          <p:cNvSpPr>
+            <a:spLocks noGrp="1"/>
+          </p:cNvSpPr>
+          <p:nvPr>
+            <p:ph type="title"/>
+          </p:nvPr>
+        </p:nvSpPr>
+        <p:spPr/>
+        <p:txBody>
+          <a:bodyPr/>
+          <a:lstStyle/>
+          <a:p>
+            <a:endParaRPr lang="en-PK"/>
+          </a:p>
+        </p:txBody>
+      </p:sp>
+      <p:sp>
+        <p:nvSpPr>
+          <p:cNvPr id="3" name="Content Placeholder 2">
+            <a:extLst>
+              <a:ext uri="{FF2B5EF4-FFF2-40B4-BE49-F238E27FC236}">
+                <a16:creationId xmlns:a16="http://schemas.microsoft.com/office/drawing/2014/main" id="{EC52DA70-E8B1-5EAD-77B4-68241CAD3E6F}"/>
+              </a:ext>
+            </a:extLst>
+          </p:cNvPr>
+          <p:cNvSpPr>
+            <a:spLocks noGrp="1"/>
+          </p:cNvSpPr>
+          <p:nvPr>
+            <p:ph idx="1"/>
+          </p:nvPr>
+        </p:nvSpPr>
+        <p:spPr/>
+        <p:txBody>
+          <a:bodyPr/>
+          <a:lstStyle/>
+          <a:p>
+            <a:endParaRPr lang="en-PK"/>
+          </a:p>
+        </p:txBody>
+      </p:sp>
+      <p:sp>
+        <p:nvSpPr>
+          <p:cNvPr id="4" name="TextBox 3">
+            <a:extLst>
+              <a:ext uri="{FF2B5EF4-FFF2-40B4-BE49-F238E27FC236}">
+                <a16:creationId xmlns:a16="http://schemas.microsoft.com/office/drawing/2014/main" id="{9E42B541-08A2-E3BF-3AA3-42AFFDCFDDBA}"/>
+              </a:ext>
+            </a:extLst>
+          </p:cNvPr>
+          <p:cNvSpPr txBox="1"/>
+          <p:nvPr/>
+        </p:nvSpPr>
+        <p:spPr>
+          <a:xfrm>
+            <a:off x="152400" y="6488668"/>
+            <a:ext cx="11887200" cy="369332"/>
+          </a:xfrm>
+          <a:prstGeom prst="rect">
+            <a:avLst/>
+          </a:prstGeom>
+          <a:noFill/>
+        </p:spPr>
+        <p:txBody>
+          <a:bodyPr wrap="square" rtlCol="0">
+            <a:spAutoFit/>
+          </a:bodyPr>
+          <a:lstStyle/>
+          <a:p>
+            <a:r>
+              <a:rPr lang="en-US" b="1" dirty="0">
+                <a:solidFill>
+                  <a:srgbClr val="0070C0"/>
+                </a:solidFill>
+              </a:rPr>
+              <a:t>FACULTY OF PHARMACY AND PHARMACEUTICAL SCIENCES                                                                               </a:t>
+            </a:r>
+            <a:r>
+              <a:rPr lang="en-US" b="1" dirty="0">
+                <a:solidFill>
+                  <a:schemeClr val="accent2"/>
+                </a:solidFill>
+              </a:rPr>
+              <a:t>SOFTSOLS PAKISTAN</a:t>
+            </a:r>
+            <a:endParaRPr lang="en-PK" b="1" dirty="0">
+              <a:solidFill>
+                <a:schemeClr val="accent2"/>
+              </a:solidFill>
+            </a:endParaRPr>
+          </a:p>
+        </p:txBody>
+      </p:sp>
+    </p:spTree>
+    <p:extLst>
+      <p:ext uri="{BB962C8B-B14F-4D97-AF65-F5344CB8AC3E}">
+        <p14:creationId xmlns:p14="http://schemas.microsoft.com/office/powerpoint/2010/main" val="122651837"/>
+      </p:ext>
+    </p:extLst>
+  </p:cSld>
+  <p:clrMapOvr>
+    <a:masterClrMapping/>
+  </p:clrMapOvr>
+</p:sld>
+</file>
+
 <file path=ppt/slides/slide16.xml><?xml version="1.0" encoding="utf-8"?>
+<p:sld xmlns:a="http://schemas.openxmlformats.org/drawingml/2006/main" xmlns:r="http://schemas.openxmlformats.org/officeDocument/2006/relationships" xmlns:p="http://schemas.openxmlformats.org/presentationml/2006/main">
+  <p:cSld>
+    <p:spTree>
+      <p:nvGrpSpPr>
+        <p:cNvPr id="1" name="">
+          <a:extLst>
+            <a:ext uri="{FF2B5EF4-FFF2-40B4-BE49-F238E27FC236}">
+              <a16:creationId xmlns:a16="http://schemas.microsoft.com/office/drawing/2014/main" id="{4D44BE88-E1A3-9A2B-311B-7889E618CCD9}"/>
+            </a:ext>
+          </a:extLst>
+        </p:cNvPr>
+        <p:cNvGrpSpPr/>
+        <p:nvPr/>
+      </p:nvGrpSpPr>
+      <p:grpSpPr>
+        <a:xfrm>
+          <a:off x="0" y="0"/>
+          <a:ext cx="0" cy="0"/>
+          <a:chOff x="0" y="0"/>
+          <a:chExt cx="0" cy="0"/>
+        </a:xfrm>
+      </p:grpSpPr>
+      <p:sp>
+        <p:nvSpPr>
+          <p:cNvPr id="2" name="Title 1">
+            <a:extLst>
+              <a:ext uri="{FF2B5EF4-FFF2-40B4-BE49-F238E27FC236}">
+                <a16:creationId xmlns:a16="http://schemas.microsoft.com/office/drawing/2014/main" id="{11A7C9D1-9227-82DB-DDDA-1BFAC36453DF}"/>
+              </a:ext>
+            </a:extLst>
+          </p:cNvPr>
+          <p:cNvSpPr>
+            <a:spLocks noGrp="1"/>
+          </p:cNvSpPr>
+          <p:nvPr>
+            <p:ph type="title"/>
+          </p:nvPr>
+        </p:nvSpPr>
+        <p:spPr/>
+        <p:txBody>
+          <a:bodyPr/>
+          <a:lstStyle/>
+          <a:p>
+            <a:endParaRPr lang="en-PK"/>
+          </a:p>
+        </p:txBody>
+      </p:sp>
+      <p:sp>
+        <p:nvSpPr>
+          <p:cNvPr id="3" name="Content Placeholder 2">
+            <a:extLst>
+              <a:ext uri="{FF2B5EF4-FFF2-40B4-BE49-F238E27FC236}">
+                <a16:creationId xmlns:a16="http://schemas.microsoft.com/office/drawing/2014/main" id="{C9F8FDC2-9B50-6534-0E45-AC5F1D4DDE3C}"/>
+              </a:ext>
+            </a:extLst>
+          </p:cNvPr>
+          <p:cNvSpPr>
+            <a:spLocks noGrp="1"/>
+          </p:cNvSpPr>
+          <p:nvPr>
+            <p:ph idx="1"/>
+          </p:nvPr>
+        </p:nvSpPr>
+        <p:spPr/>
+        <p:txBody>
+          <a:bodyPr/>
+          <a:lstStyle/>
+          <a:p>
+            <a:endParaRPr lang="en-PK"/>
+          </a:p>
+        </p:txBody>
+      </p:sp>
+      <p:sp>
+        <p:nvSpPr>
+          <p:cNvPr id="4" name="TextBox 3">
+            <a:extLst>
+              <a:ext uri="{FF2B5EF4-FFF2-40B4-BE49-F238E27FC236}">
+                <a16:creationId xmlns:a16="http://schemas.microsoft.com/office/drawing/2014/main" id="{33644825-4221-DCE7-4AAE-8120B854DD3F}"/>
+              </a:ext>
+            </a:extLst>
+          </p:cNvPr>
+          <p:cNvSpPr txBox="1"/>
+          <p:nvPr/>
+        </p:nvSpPr>
+        <p:spPr>
+          <a:xfrm>
+            <a:off x="152400" y="6488668"/>
+            <a:ext cx="11887200" cy="369332"/>
+          </a:xfrm>
+          <a:prstGeom prst="rect">
+            <a:avLst/>
+          </a:prstGeom>
+          <a:noFill/>
+        </p:spPr>
+        <p:txBody>
+          <a:bodyPr wrap="square" rtlCol="0">
+            <a:spAutoFit/>
+          </a:bodyPr>
+          <a:lstStyle/>
+          <a:p>
+            <a:r>
+              <a:rPr lang="en-US" b="1" dirty="0">
+                <a:solidFill>
+                  <a:srgbClr val="0070C0"/>
+                </a:solidFill>
+              </a:rPr>
+              <a:t>FACULTY OF PHARMACY AND PHARMACEUTICAL SCIENCES                                                                               </a:t>
+            </a:r>
+            <a:r>
+              <a:rPr lang="en-US" b="1" dirty="0">
+                <a:solidFill>
+                  <a:schemeClr val="accent2"/>
+                </a:solidFill>
+              </a:rPr>
+              <a:t>SOFTSOLS PAKISTAN</a:t>
+            </a:r>
+            <a:endParaRPr lang="en-PK" b="1" dirty="0">
+              <a:solidFill>
+                <a:schemeClr val="accent2"/>
+              </a:solidFill>
+            </a:endParaRPr>
+          </a:p>
+        </p:txBody>
+      </p:sp>
+    </p:spTree>
+    <p:extLst>
+      <p:ext uri="{BB962C8B-B14F-4D97-AF65-F5344CB8AC3E}">
+        <p14:creationId xmlns:p14="http://schemas.microsoft.com/office/powerpoint/2010/main" val="3455459425"/>
+      </p:ext>
+    </p:extLst>
+  </p:cSld>
+  <p:clrMapOvr>
+    <a:masterClrMapping/>
+  </p:clrMapOvr>
+</p:sld>
+</file>
+
+<file path=ppt/slides/slide17.xml><?xml version="1.0" encoding="utf-8"?>
 <p:sld xmlns:a="http://schemas.openxmlformats.org/drawingml/2006/main" xmlns:r="http://schemas.openxmlformats.org/officeDocument/2006/relationships" xmlns:p="http://schemas.openxmlformats.org/presentationml/2006/main">
   <p:cSld>
     <p:spTree>
@@ -5817,7 +6204,7 @@
         <p:cNvPr id="1" name="">
           <a:extLst>
             <a:ext uri="{FF2B5EF4-FFF2-40B4-BE49-F238E27FC236}">
-              <a16:creationId xmlns:a16="http://schemas.microsoft.com/office/drawing/2014/main" id="{D6188D29-524E-9030-DDF9-2FFBFB948A03}"/>
+              <a16:creationId xmlns:a16="http://schemas.microsoft.com/office/drawing/2014/main" id="{5E931C6F-5FA5-5046-C1AB-6CF052E71156}"/>
             </a:ext>
           </a:extLst>
         </p:cNvPr>
@@ -5837,7 +6224,7 @@
           <p:cNvPr id="2" name="Title 1">
             <a:extLst>
               <a:ext uri="{FF2B5EF4-FFF2-40B4-BE49-F238E27FC236}">
-                <a16:creationId xmlns:a16="http://schemas.microsoft.com/office/drawing/2014/main" id="{2745430A-9B0F-D826-8B17-198B41B9B6E3}"/>
+                <a16:creationId xmlns:a16="http://schemas.microsoft.com/office/drawing/2014/main" id="{A8BB61C2-6332-754F-8B45-579D7EEAAF73}"/>
               </a:ext>
             </a:extLst>
           </p:cNvPr>
@@ -5862,7 +6249,7 @@
           <p:cNvPr id="3" name="Content Placeholder 2">
             <a:extLst>
               <a:ext uri="{FF2B5EF4-FFF2-40B4-BE49-F238E27FC236}">
-                <a16:creationId xmlns:a16="http://schemas.microsoft.com/office/drawing/2014/main" id="{C686B506-1C06-0EC6-7279-1083653DB0F7}"/>
+                <a16:creationId xmlns:a16="http://schemas.microsoft.com/office/drawing/2014/main" id="{F4E42094-EB03-4D0F-2D94-279E6BFA12E2}"/>
               </a:ext>
             </a:extLst>
           </p:cNvPr>
@@ -5887,7 +6274,7 @@
           <p:cNvPr id="4" name="TextBox 3">
             <a:extLst>
               <a:ext uri="{FF2B5EF4-FFF2-40B4-BE49-F238E27FC236}">
-                <a16:creationId xmlns:a16="http://schemas.microsoft.com/office/drawing/2014/main" id="{B389A75D-8D27-03FF-9B3B-4F371BF90BCE}"/>
+                <a16:creationId xmlns:a16="http://schemas.microsoft.com/office/drawing/2014/main" id="{BC158E87-A0EF-164F-B1A7-094642852BB4}"/>
               </a:ext>
             </a:extLst>
           </p:cNvPr>
@@ -5939,7 +6326,7 @@
           <p:cNvPr id="6" name="Picture 5">
             <a:extLst>
               <a:ext uri="{FF2B5EF4-FFF2-40B4-BE49-F238E27FC236}">
-                <a16:creationId xmlns:a16="http://schemas.microsoft.com/office/drawing/2014/main" id="{1BFCBF52-5753-10B4-5522-7C642C9474BE}"/>
+                <a16:creationId xmlns:a16="http://schemas.microsoft.com/office/drawing/2014/main" id="{E1D6CA62-52BB-2714-BC40-4E4DE612C753}"/>
               </a:ext>
             </a:extLst>
           </p:cNvPr>
@@ -5956,96 +6343,18 @@
         </p:blipFill>
         <p:spPr>
           <a:xfrm>
-            <a:off x="0" y="-1"/>
-            <a:ext cx="12192000" cy="6310489"/>
+            <a:off x="0" y="0"/>
+            <a:ext cx="12192000" cy="6321778"/>
           </a:xfrm>
           <a:prstGeom prst="rect">
             <a:avLst/>
           </a:prstGeom>
         </p:spPr>
       </p:pic>
-      <p:sp>
-        <p:nvSpPr>
-          <p:cNvPr id="7" name="TextBox 6">
-            <a:extLst>
-              <a:ext uri="{FF2B5EF4-FFF2-40B4-BE49-F238E27FC236}">
-                <a16:creationId xmlns:a16="http://schemas.microsoft.com/office/drawing/2014/main" id="{08704BFE-ED11-DC85-CF4F-7A1E80A7DC7A}"/>
-              </a:ext>
-            </a:extLst>
-          </p:cNvPr>
-          <p:cNvSpPr txBox="1"/>
-          <p:nvPr/>
-        </p:nvSpPr>
-        <p:spPr>
-          <a:xfrm>
-            <a:off x="4752622" y="2585156"/>
-            <a:ext cx="5294489" cy="1754326"/>
-          </a:xfrm>
-          <a:prstGeom prst="rect">
-            <a:avLst/>
-          </a:prstGeom>
-          <a:noFill/>
-        </p:spPr>
-        <p:txBody>
-          <a:bodyPr wrap="square" rtlCol="0">
-            <a:spAutoFit/>
-          </a:bodyPr>
-          <a:lstStyle/>
-          <a:p>
-            <a:r>
-              <a:rPr lang="en-US" dirty="0">
-                <a:solidFill>
-                  <a:srgbClr val="FF0000"/>
-                </a:solidFill>
-              </a:rPr>
-              <a:t>1:1 CHAT / MESSENGER between Faculty Members (Teachers), HODs, Dean Office and Dean </a:t>
-            </a:r>
-          </a:p>
-          <a:p>
-            <a:endParaRPr lang="en-US" dirty="0">
-              <a:solidFill>
-                <a:srgbClr val="FF0000"/>
-              </a:solidFill>
-            </a:endParaRPr>
-          </a:p>
-          <a:p>
-            <a:r>
-              <a:rPr lang="en-US" dirty="0">
-                <a:solidFill>
-                  <a:srgbClr val="FF0000"/>
-                </a:solidFill>
-              </a:rPr>
-              <a:t>Any Member will send message to other.</a:t>
-            </a:r>
-          </a:p>
-          <a:p>
-            <a:endParaRPr lang="en-US" dirty="0">
-              <a:solidFill>
-                <a:srgbClr val="FF0000"/>
-              </a:solidFill>
-            </a:endParaRPr>
-          </a:p>
-          <a:p>
-            <a:r>
-              <a:rPr lang="en-US" dirty="0">
-                <a:solidFill>
-                  <a:srgbClr val="FF0000"/>
-                </a:solidFill>
-              </a:rPr>
-              <a:t>100% Encrypted chat</a:t>
-            </a:r>
-            <a:endParaRPr lang="en-PK" dirty="0">
-              <a:solidFill>
-                <a:srgbClr val="FF0000"/>
-              </a:solidFill>
-            </a:endParaRPr>
-          </a:p>
-        </p:txBody>
-      </p:sp>
     </p:spTree>
     <p:extLst>
       <p:ext uri="{BB962C8B-B14F-4D97-AF65-F5344CB8AC3E}">
-        <p14:creationId xmlns:p14="http://schemas.microsoft.com/office/powerpoint/2010/main" val="3053948027"/>
+        <p14:creationId xmlns:p14="http://schemas.microsoft.com/office/powerpoint/2010/main" val="2017795440"/>
       </p:ext>
     </p:extLst>
   </p:cSld>

</xml_diff>

<commit_message>
fix: updated parsePKTToUTC to return string to fix FormData.append type errors
</commit_message>
<xml_diff>
--- a/STUDENT REGISTRATION.pptx
+++ b/STUDENT REGISTRATION.pptx
@@ -13,15 +13,11 @@
     <p:sldId id="262" r:id="rId7"/>
     <p:sldId id="259" r:id="rId8"/>
     <p:sldId id="263" r:id="rId9"/>
-    <p:sldId id="269" r:id="rId10"/>
-    <p:sldId id="270" r:id="rId11"/>
-    <p:sldId id="271" r:id="rId12"/>
-    <p:sldId id="272" r:id="rId13"/>
-    <p:sldId id="274" r:id="rId14"/>
-    <p:sldId id="275" r:id="rId15"/>
-    <p:sldId id="276" r:id="rId16"/>
-    <p:sldId id="273" r:id="rId17"/>
-    <p:sldId id="264" r:id="rId18"/>
+    <p:sldId id="274" r:id="rId10"/>
+    <p:sldId id="275" r:id="rId11"/>
+    <p:sldId id="276" r:id="rId12"/>
+    <p:sldId id="273" r:id="rId13"/>
+    <p:sldId id="264" r:id="rId14"/>
   </p:sldIdLst>
   <p:sldSz cx="12192000" cy="6858000"/>
   <p:notesSz cx="6858000" cy="9144000"/>
@@ -3576,806 +3572,6 @@
         <p:cNvPr id="1" name="">
           <a:extLst>
             <a:ext uri="{FF2B5EF4-FFF2-40B4-BE49-F238E27FC236}">
-              <a16:creationId xmlns:a16="http://schemas.microsoft.com/office/drawing/2014/main" id="{C5058DD3-5E18-AA42-0926-509EBDC3EC61}"/>
-            </a:ext>
-          </a:extLst>
-        </p:cNvPr>
-        <p:cNvGrpSpPr/>
-        <p:nvPr/>
-      </p:nvGrpSpPr>
-      <p:grpSpPr>
-        <a:xfrm>
-          <a:off x="0" y="0"/>
-          <a:ext cx="0" cy="0"/>
-          <a:chOff x="0" y="0"/>
-          <a:chExt cx="0" cy="0"/>
-        </a:xfrm>
-      </p:grpSpPr>
-      <p:sp>
-        <p:nvSpPr>
-          <p:cNvPr id="2" name="Title 1">
-            <a:extLst>
-              <a:ext uri="{FF2B5EF4-FFF2-40B4-BE49-F238E27FC236}">
-                <a16:creationId xmlns:a16="http://schemas.microsoft.com/office/drawing/2014/main" id="{45685ADD-97A9-323B-38E9-EB0F2A2B1334}"/>
-              </a:ext>
-            </a:extLst>
-          </p:cNvPr>
-          <p:cNvSpPr>
-            <a:spLocks noGrp="1"/>
-          </p:cNvSpPr>
-          <p:nvPr>
-            <p:ph type="title"/>
-          </p:nvPr>
-        </p:nvSpPr>
-        <p:spPr/>
-        <p:txBody>
-          <a:bodyPr/>
-          <a:lstStyle/>
-          <a:p>
-            <a:endParaRPr lang="en-PK"/>
-          </a:p>
-        </p:txBody>
-      </p:sp>
-      <p:sp>
-        <p:nvSpPr>
-          <p:cNvPr id="3" name="Content Placeholder 2">
-            <a:extLst>
-              <a:ext uri="{FF2B5EF4-FFF2-40B4-BE49-F238E27FC236}">
-                <a16:creationId xmlns:a16="http://schemas.microsoft.com/office/drawing/2014/main" id="{E1F00411-5327-01CA-9759-C503554DBA4B}"/>
-              </a:ext>
-            </a:extLst>
-          </p:cNvPr>
-          <p:cNvSpPr>
-            <a:spLocks noGrp="1"/>
-          </p:cNvSpPr>
-          <p:nvPr>
-            <p:ph idx="1"/>
-          </p:nvPr>
-        </p:nvSpPr>
-        <p:spPr/>
-        <p:txBody>
-          <a:bodyPr/>
-          <a:lstStyle/>
-          <a:p>
-            <a:endParaRPr lang="en-PK"/>
-          </a:p>
-        </p:txBody>
-      </p:sp>
-      <p:sp>
-        <p:nvSpPr>
-          <p:cNvPr id="4" name="TextBox 3">
-            <a:extLst>
-              <a:ext uri="{FF2B5EF4-FFF2-40B4-BE49-F238E27FC236}">
-                <a16:creationId xmlns:a16="http://schemas.microsoft.com/office/drawing/2014/main" id="{C10DBB94-A7F1-0908-C6CA-812FCAA1CB1E}"/>
-              </a:ext>
-            </a:extLst>
-          </p:cNvPr>
-          <p:cNvSpPr txBox="1"/>
-          <p:nvPr/>
-        </p:nvSpPr>
-        <p:spPr>
-          <a:xfrm>
-            <a:off x="152400" y="6488668"/>
-            <a:ext cx="11887200" cy="369332"/>
-          </a:xfrm>
-          <a:prstGeom prst="rect">
-            <a:avLst/>
-          </a:prstGeom>
-          <a:noFill/>
-        </p:spPr>
-        <p:txBody>
-          <a:bodyPr wrap="square" rtlCol="0">
-            <a:spAutoFit/>
-          </a:bodyPr>
-          <a:lstStyle/>
-          <a:p>
-            <a:r>
-              <a:rPr lang="en-US" b="1" dirty="0">
-                <a:solidFill>
-                  <a:srgbClr val="0070C0"/>
-                </a:solidFill>
-              </a:rPr>
-              <a:t>FACULTY OF PHARMACY AND PHARMACEUTICAL SCIENCES                                                                               </a:t>
-            </a:r>
-            <a:r>
-              <a:rPr lang="en-US" b="1" dirty="0">
-                <a:solidFill>
-                  <a:schemeClr val="accent2"/>
-                </a:solidFill>
-              </a:rPr>
-              <a:t>SOFTSOLS PAKISTAN</a:t>
-            </a:r>
-            <a:endParaRPr lang="en-PK" b="1" dirty="0">
-              <a:solidFill>
-                <a:schemeClr val="accent2"/>
-              </a:solidFill>
-            </a:endParaRPr>
-          </a:p>
-        </p:txBody>
-      </p:sp>
-      <p:pic>
-        <p:nvPicPr>
-          <p:cNvPr id="6" name="Picture 5">
-            <a:extLst>
-              <a:ext uri="{FF2B5EF4-FFF2-40B4-BE49-F238E27FC236}">
-                <a16:creationId xmlns:a16="http://schemas.microsoft.com/office/drawing/2014/main" id="{347AD79F-F674-6999-8751-67C8E8CEA824}"/>
-              </a:ext>
-            </a:extLst>
-          </p:cNvPr>
-          <p:cNvPicPr>
-            <a:picLocks noChangeAspect="1"/>
-          </p:cNvPicPr>
-          <p:nvPr/>
-        </p:nvPicPr>
-        <p:blipFill>
-          <a:blip r:embed="rId2"/>
-          <a:stretch>
-            <a:fillRect/>
-          </a:stretch>
-        </p:blipFill>
-        <p:spPr>
-          <a:xfrm>
-            <a:off x="0" y="-1"/>
-            <a:ext cx="12192000" cy="6176963"/>
-          </a:xfrm>
-          <a:prstGeom prst="rect">
-            <a:avLst/>
-          </a:prstGeom>
-        </p:spPr>
-      </p:pic>
-      <p:sp>
-        <p:nvSpPr>
-          <p:cNvPr id="7" name="TextBox 6">
-            <a:extLst>
-              <a:ext uri="{FF2B5EF4-FFF2-40B4-BE49-F238E27FC236}">
-                <a16:creationId xmlns:a16="http://schemas.microsoft.com/office/drawing/2014/main" id="{2ADBF171-DAFA-60D2-ACD8-119BDE2819BD}"/>
-              </a:ext>
-            </a:extLst>
-          </p:cNvPr>
-          <p:cNvSpPr txBox="1"/>
-          <p:nvPr/>
-        </p:nvSpPr>
-        <p:spPr>
-          <a:xfrm>
-            <a:off x="3183467" y="3905956"/>
-            <a:ext cx="6310489" cy="1477328"/>
-          </a:xfrm>
-          <a:prstGeom prst="rect">
-            <a:avLst/>
-          </a:prstGeom>
-          <a:noFill/>
-        </p:spPr>
-        <p:txBody>
-          <a:bodyPr wrap="square" rtlCol="0">
-            <a:spAutoFit/>
-          </a:bodyPr>
-          <a:lstStyle/>
-          <a:p>
-            <a:r>
-              <a:rPr lang="en-US" b="1" dirty="0">
-                <a:solidFill>
-                  <a:srgbClr val="FF0000"/>
-                </a:solidFill>
-              </a:rPr>
-              <a:t>In Result Page, Teacher, HOD and Admin will be able to Post and Access Result of any Subject which will be viewable to higher </a:t>
-            </a:r>
-            <a:r>
-              <a:rPr lang="en-US" b="1" dirty="0" err="1">
-                <a:solidFill>
-                  <a:srgbClr val="FF0000"/>
-                </a:solidFill>
-              </a:rPr>
-              <a:t>hirerchy</a:t>
-            </a:r>
-            <a:r>
-              <a:rPr lang="en-US" b="1" dirty="0">
-                <a:solidFill>
-                  <a:srgbClr val="FF0000"/>
-                </a:solidFill>
-              </a:rPr>
-              <a:t>.</a:t>
-            </a:r>
-          </a:p>
-          <a:p>
-            <a:r>
-              <a:rPr lang="en-US" b="1" dirty="0">
-                <a:solidFill>
-                  <a:srgbClr val="FF0000"/>
-                </a:solidFill>
-              </a:rPr>
-              <a:t>Like any Teacher post Result then it will be viewable to respective HOD and Dean.</a:t>
-            </a:r>
-            <a:endParaRPr lang="en-PK" b="1" dirty="0">
-              <a:solidFill>
-                <a:srgbClr val="FF0000"/>
-              </a:solidFill>
-            </a:endParaRPr>
-          </a:p>
-        </p:txBody>
-      </p:sp>
-    </p:spTree>
-    <p:extLst>
-      <p:ext uri="{BB962C8B-B14F-4D97-AF65-F5344CB8AC3E}">
-        <p14:creationId xmlns:p14="http://schemas.microsoft.com/office/powerpoint/2010/main" val="4239079601"/>
-      </p:ext>
-    </p:extLst>
-  </p:cSld>
-  <p:clrMapOvr>
-    <a:masterClrMapping/>
-  </p:clrMapOvr>
-</p:sld>
-</file>
-
-<file path=ppt/slides/slide11.xml><?xml version="1.0" encoding="utf-8"?>
-<p:sld xmlns:a="http://schemas.openxmlformats.org/drawingml/2006/main" xmlns:r="http://schemas.openxmlformats.org/officeDocument/2006/relationships" xmlns:p="http://schemas.openxmlformats.org/presentationml/2006/main">
-  <p:cSld>
-    <p:spTree>
-      <p:nvGrpSpPr>
-        <p:cNvPr id="1" name="">
-          <a:extLst>
-            <a:ext uri="{FF2B5EF4-FFF2-40B4-BE49-F238E27FC236}">
-              <a16:creationId xmlns:a16="http://schemas.microsoft.com/office/drawing/2014/main" id="{BBBA152D-5B34-3F9A-AF64-72CEFEF066FA}"/>
-            </a:ext>
-          </a:extLst>
-        </p:cNvPr>
-        <p:cNvGrpSpPr/>
-        <p:nvPr/>
-      </p:nvGrpSpPr>
-      <p:grpSpPr>
-        <a:xfrm>
-          <a:off x="0" y="0"/>
-          <a:ext cx="0" cy="0"/>
-          <a:chOff x="0" y="0"/>
-          <a:chExt cx="0" cy="0"/>
-        </a:xfrm>
-      </p:grpSpPr>
-      <p:sp>
-        <p:nvSpPr>
-          <p:cNvPr id="2" name="Title 1">
-            <a:extLst>
-              <a:ext uri="{FF2B5EF4-FFF2-40B4-BE49-F238E27FC236}">
-                <a16:creationId xmlns:a16="http://schemas.microsoft.com/office/drawing/2014/main" id="{A27154D9-37A3-1FFB-D4F0-070CC3271F29}"/>
-              </a:ext>
-            </a:extLst>
-          </p:cNvPr>
-          <p:cNvSpPr>
-            <a:spLocks noGrp="1"/>
-          </p:cNvSpPr>
-          <p:nvPr>
-            <p:ph type="title"/>
-          </p:nvPr>
-        </p:nvSpPr>
-        <p:spPr/>
-        <p:txBody>
-          <a:bodyPr/>
-          <a:lstStyle/>
-          <a:p>
-            <a:endParaRPr lang="en-PK"/>
-          </a:p>
-        </p:txBody>
-      </p:sp>
-      <p:sp>
-        <p:nvSpPr>
-          <p:cNvPr id="3" name="Content Placeholder 2">
-            <a:extLst>
-              <a:ext uri="{FF2B5EF4-FFF2-40B4-BE49-F238E27FC236}">
-                <a16:creationId xmlns:a16="http://schemas.microsoft.com/office/drawing/2014/main" id="{09B29319-F0A7-21BA-41BE-BEB40DA226CC}"/>
-              </a:ext>
-            </a:extLst>
-          </p:cNvPr>
-          <p:cNvSpPr>
-            <a:spLocks noGrp="1"/>
-          </p:cNvSpPr>
-          <p:nvPr>
-            <p:ph idx="1"/>
-          </p:nvPr>
-        </p:nvSpPr>
-        <p:spPr/>
-        <p:txBody>
-          <a:bodyPr/>
-          <a:lstStyle/>
-          <a:p>
-            <a:endParaRPr lang="en-PK"/>
-          </a:p>
-        </p:txBody>
-      </p:sp>
-      <p:sp>
-        <p:nvSpPr>
-          <p:cNvPr id="4" name="TextBox 3">
-            <a:extLst>
-              <a:ext uri="{FF2B5EF4-FFF2-40B4-BE49-F238E27FC236}">
-                <a16:creationId xmlns:a16="http://schemas.microsoft.com/office/drawing/2014/main" id="{CE565390-5C24-CAE4-E92E-9F3FCE8366A5}"/>
-              </a:ext>
-            </a:extLst>
-          </p:cNvPr>
-          <p:cNvSpPr txBox="1"/>
-          <p:nvPr/>
-        </p:nvSpPr>
-        <p:spPr>
-          <a:xfrm>
-            <a:off x="152400" y="6488668"/>
-            <a:ext cx="11887200" cy="369332"/>
-          </a:xfrm>
-          <a:prstGeom prst="rect">
-            <a:avLst/>
-          </a:prstGeom>
-          <a:noFill/>
-        </p:spPr>
-        <p:txBody>
-          <a:bodyPr wrap="square" rtlCol="0">
-            <a:spAutoFit/>
-          </a:bodyPr>
-          <a:lstStyle/>
-          <a:p>
-            <a:r>
-              <a:rPr lang="en-US" b="1" dirty="0">
-                <a:solidFill>
-                  <a:srgbClr val="0070C0"/>
-                </a:solidFill>
-              </a:rPr>
-              <a:t>FACULTY OF PHARMACY AND PHARMACEUTICAL SCIENCES                                                                               </a:t>
-            </a:r>
-            <a:r>
-              <a:rPr lang="en-US" b="1" dirty="0">
-                <a:solidFill>
-                  <a:schemeClr val="accent2"/>
-                </a:solidFill>
-              </a:rPr>
-              <a:t>SOFTSOLS PAKISTAN</a:t>
-            </a:r>
-            <a:endParaRPr lang="en-PK" b="1" dirty="0">
-              <a:solidFill>
-                <a:schemeClr val="accent2"/>
-              </a:solidFill>
-            </a:endParaRPr>
-          </a:p>
-        </p:txBody>
-      </p:sp>
-      <p:pic>
-        <p:nvPicPr>
-          <p:cNvPr id="6" name="Picture 5">
-            <a:extLst>
-              <a:ext uri="{FF2B5EF4-FFF2-40B4-BE49-F238E27FC236}">
-                <a16:creationId xmlns:a16="http://schemas.microsoft.com/office/drawing/2014/main" id="{9CE91497-74AB-C859-CAC4-609EBB3D3166}"/>
-              </a:ext>
-            </a:extLst>
-          </p:cNvPr>
-          <p:cNvPicPr>
-            <a:picLocks noChangeAspect="1"/>
-          </p:cNvPicPr>
-          <p:nvPr/>
-        </p:nvPicPr>
-        <p:blipFill>
-          <a:blip r:embed="rId2"/>
-          <a:stretch>
-            <a:fillRect/>
-          </a:stretch>
-        </p:blipFill>
-        <p:spPr>
-          <a:xfrm>
-            <a:off x="0" y="0"/>
-            <a:ext cx="12192000" cy="6276622"/>
-          </a:xfrm>
-          <a:prstGeom prst="rect">
-            <a:avLst/>
-          </a:prstGeom>
-        </p:spPr>
-      </p:pic>
-      <p:sp>
-        <p:nvSpPr>
-          <p:cNvPr id="7" name="TextBox 6">
-            <a:extLst>
-              <a:ext uri="{FF2B5EF4-FFF2-40B4-BE49-F238E27FC236}">
-                <a16:creationId xmlns:a16="http://schemas.microsoft.com/office/drawing/2014/main" id="{3A857F7E-8077-3723-8DB7-240ADF0280AA}"/>
-              </a:ext>
-            </a:extLst>
-          </p:cNvPr>
-          <p:cNvSpPr txBox="1"/>
-          <p:nvPr/>
-        </p:nvSpPr>
-        <p:spPr>
-          <a:xfrm>
-            <a:off x="3149600" y="4301067"/>
-            <a:ext cx="6739467" cy="646331"/>
-          </a:xfrm>
-          <a:prstGeom prst="rect">
-            <a:avLst/>
-          </a:prstGeom>
-          <a:noFill/>
-        </p:spPr>
-        <p:txBody>
-          <a:bodyPr wrap="square" rtlCol="0">
-            <a:spAutoFit/>
-          </a:bodyPr>
-          <a:lstStyle/>
-          <a:p>
-            <a:r>
-              <a:rPr lang="en-US" b="1" dirty="0">
-                <a:solidFill>
-                  <a:srgbClr val="FF0000"/>
-                </a:solidFill>
-              </a:rPr>
-              <a:t>Dean Office (Sub-Admin) and Dean (Admin) able to add Examination Date Sheet and Exam Results will be added by respective Teacher</a:t>
-            </a:r>
-            <a:endParaRPr lang="en-PK" b="1" dirty="0">
-              <a:solidFill>
-                <a:srgbClr val="FF0000"/>
-              </a:solidFill>
-            </a:endParaRPr>
-          </a:p>
-        </p:txBody>
-      </p:sp>
-    </p:spTree>
-    <p:extLst>
-      <p:ext uri="{BB962C8B-B14F-4D97-AF65-F5344CB8AC3E}">
-        <p14:creationId xmlns:p14="http://schemas.microsoft.com/office/powerpoint/2010/main" val="2145863767"/>
-      </p:ext>
-    </p:extLst>
-  </p:cSld>
-  <p:clrMapOvr>
-    <a:masterClrMapping/>
-  </p:clrMapOvr>
-</p:sld>
-</file>
-
-<file path=ppt/slides/slide12.xml><?xml version="1.0" encoding="utf-8"?>
-<p:sld xmlns:a="http://schemas.openxmlformats.org/drawingml/2006/main" xmlns:r="http://schemas.openxmlformats.org/officeDocument/2006/relationships" xmlns:p="http://schemas.openxmlformats.org/presentationml/2006/main">
-  <p:cSld>
-    <p:spTree>
-      <p:nvGrpSpPr>
-        <p:cNvPr id="1" name="">
-          <a:extLst>
-            <a:ext uri="{FF2B5EF4-FFF2-40B4-BE49-F238E27FC236}">
-              <a16:creationId xmlns:a16="http://schemas.microsoft.com/office/drawing/2014/main" id="{82528CEC-B39E-5887-06DF-A3A7BC89B011}"/>
-            </a:ext>
-          </a:extLst>
-        </p:cNvPr>
-        <p:cNvGrpSpPr/>
-        <p:nvPr/>
-      </p:nvGrpSpPr>
-      <p:grpSpPr>
-        <a:xfrm>
-          <a:off x="0" y="0"/>
-          <a:ext cx="0" cy="0"/>
-          <a:chOff x="0" y="0"/>
-          <a:chExt cx="0" cy="0"/>
-        </a:xfrm>
-      </p:grpSpPr>
-      <p:sp>
-        <p:nvSpPr>
-          <p:cNvPr id="2" name="Title 1">
-            <a:extLst>
-              <a:ext uri="{FF2B5EF4-FFF2-40B4-BE49-F238E27FC236}">
-                <a16:creationId xmlns:a16="http://schemas.microsoft.com/office/drawing/2014/main" id="{53BD4E10-CF2E-EBA3-5BFD-411E6D14B8C8}"/>
-              </a:ext>
-            </a:extLst>
-          </p:cNvPr>
-          <p:cNvSpPr>
-            <a:spLocks noGrp="1"/>
-          </p:cNvSpPr>
-          <p:nvPr>
-            <p:ph type="title"/>
-          </p:nvPr>
-        </p:nvSpPr>
-        <p:spPr/>
-        <p:txBody>
-          <a:bodyPr/>
-          <a:lstStyle/>
-          <a:p>
-            <a:endParaRPr lang="en-PK"/>
-          </a:p>
-        </p:txBody>
-      </p:sp>
-      <p:sp>
-        <p:nvSpPr>
-          <p:cNvPr id="3" name="Content Placeholder 2">
-            <a:extLst>
-              <a:ext uri="{FF2B5EF4-FFF2-40B4-BE49-F238E27FC236}">
-                <a16:creationId xmlns:a16="http://schemas.microsoft.com/office/drawing/2014/main" id="{53A0FBDC-596F-56E7-2BC8-9F070F7B0F8B}"/>
-              </a:ext>
-            </a:extLst>
-          </p:cNvPr>
-          <p:cNvSpPr>
-            <a:spLocks noGrp="1"/>
-          </p:cNvSpPr>
-          <p:nvPr>
-            <p:ph idx="1"/>
-          </p:nvPr>
-        </p:nvSpPr>
-        <p:spPr/>
-        <p:txBody>
-          <a:bodyPr/>
-          <a:lstStyle/>
-          <a:p>
-            <a:endParaRPr lang="en-PK"/>
-          </a:p>
-        </p:txBody>
-      </p:sp>
-      <p:sp>
-        <p:nvSpPr>
-          <p:cNvPr id="4" name="TextBox 3">
-            <a:extLst>
-              <a:ext uri="{FF2B5EF4-FFF2-40B4-BE49-F238E27FC236}">
-                <a16:creationId xmlns:a16="http://schemas.microsoft.com/office/drawing/2014/main" id="{74CD3557-C7DC-0B07-9832-ECC114F81296}"/>
-              </a:ext>
-            </a:extLst>
-          </p:cNvPr>
-          <p:cNvSpPr txBox="1"/>
-          <p:nvPr/>
-        </p:nvSpPr>
-        <p:spPr>
-          <a:xfrm>
-            <a:off x="152400" y="6488668"/>
-            <a:ext cx="11887200" cy="369332"/>
-          </a:xfrm>
-          <a:prstGeom prst="rect">
-            <a:avLst/>
-          </a:prstGeom>
-          <a:noFill/>
-        </p:spPr>
-        <p:txBody>
-          <a:bodyPr wrap="square" rtlCol="0">
-            <a:spAutoFit/>
-          </a:bodyPr>
-          <a:lstStyle/>
-          <a:p>
-            <a:r>
-              <a:rPr lang="en-US" b="1" dirty="0">
-                <a:solidFill>
-                  <a:srgbClr val="0070C0"/>
-                </a:solidFill>
-              </a:rPr>
-              <a:t>FACULTY OF PHARMACY AND PHARMACEUTICAL SCIENCES                                                                               </a:t>
-            </a:r>
-            <a:r>
-              <a:rPr lang="en-US" b="1" dirty="0">
-                <a:solidFill>
-                  <a:schemeClr val="accent2"/>
-                </a:solidFill>
-              </a:rPr>
-              <a:t>SOFTSOLS PAKISTAN</a:t>
-            </a:r>
-            <a:endParaRPr lang="en-PK" b="1" dirty="0">
-              <a:solidFill>
-                <a:schemeClr val="accent2"/>
-              </a:solidFill>
-            </a:endParaRPr>
-          </a:p>
-        </p:txBody>
-      </p:sp>
-      <p:pic>
-        <p:nvPicPr>
-          <p:cNvPr id="6" name="Picture 5">
-            <a:extLst>
-              <a:ext uri="{FF2B5EF4-FFF2-40B4-BE49-F238E27FC236}">
-                <a16:creationId xmlns:a16="http://schemas.microsoft.com/office/drawing/2014/main" id="{28DD3AEE-CD37-6ADB-B5E2-EC399E20E73D}"/>
-              </a:ext>
-            </a:extLst>
-          </p:cNvPr>
-          <p:cNvPicPr>
-            <a:picLocks noChangeAspect="1"/>
-          </p:cNvPicPr>
-          <p:nvPr/>
-        </p:nvPicPr>
-        <p:blipFill>
-          <a:blip r:embed="rId2"/>
-          <a:stretch>
-            <a:fillRect/>
-          </a:stretch>
-        </p:blipFill>
-        <p:spPr>
-          <a:xfrm>
-            <a:off x="0" y="155985"/>
-            <a:ext cx="12192000" cy="6020978"/>
-          </a:xfrm>
-          <a:prstGeom prst="rect">
-            <a:avLst/>
-          </a:prstGeom>
-        </p:spPr>
-      </p:pic>
-      <p:sp>
-        <p:nvSpPr>
-          <p:cNvPr id="7" name="TextBox 6">
-            <a:extLst>
-              <a:ext uri="{FF2B5EF4-FFF2-40B4-BE49-F238E27FC236}">
-                <a16:creationId xmlns:a16="http://schemas.microsoft.com/office/drawing/2014/main" id="{BF9B2BDA-1DB4-4C9C-D1FD-C995DBB7DACA}"/>
-              </a:ext>
-            </a:extLst>
-          </p:cNvPr>
-          <p:cNvSpPr txBox="1"/>
-          <p:nvPr/>
-        </p:nvSpPr>
-        <p:spPr>
-          <a:xfrm>
-            <a:off x="8669867" y="2585156"/>
-            <a:ext cx="2946400" cy="1200329"/>
-          </a:xfrm>
-          <a:prstGeom prst="rect">
-            <a:avLst/>
-          </a:prstGeom>
-          <a:noFill/>
-        </p:spPr>
-        <p:txBody>
-          <a:bodyPr wrap="square" rtlCol="0">
-            <a:spAutoFit/>
-          </a:bodyPr>
-          <a:lstStyle/>
-          <a:p>
-            <a:r>
-              <a:rPr lang="en-US" b="1" dirty="0">
-                <a:solidFill>
-                  <a:srgbClr val="FF0000"/>
-                </a:solidFill>
-              </a:rPr>
-              <a:t>Semester Wise Time Table will be added by Dean Office and Department Head and also by Dean (Admin)</a:t>
-            </a:r>
-            <a:endParaRPr lang="en-PK" b="1" dirty="0">
-              <a:solidFill>
-                <a:srgbClr val="FF0000"/>
-              </a:solidFill>
-            </a:endParaRPr>
-          </a:p>
-        </p:txBody>
-      </p:sp>
-    </p:spTree>
-    <p:extLst>
-      <p:ext uri="{BB962C8B-B14F-4D97-AF65-F5344CB8AC3E}">
-        <p14:creationId xmlns:p14="http://schemas.microsoft.com/office/powerpoint/2010/main" val="3616657786"/>
-      </p:ext>
-    </p:extLst>
-  </p:cSld>
-  <p:clrMapOvr>
-    <a:masterClrMapping/>
-  </p:clrMapOvr>
-</p:sld>
-</file>
-
-<file path=ppt/slides/slide13.xml><?xml version="1.0" encoding="utf-8"?>
-<p:sld xmlns:a="http://schemas.openxmlformats.org/drawingml/2006/main" xmlns:r="http://schemas.openxmlformats.org/officeDocument/2006/relationships" xmlns:p="http://schemas.openxmlformats.org/presentationml/2006/main">
-  <p:cSld>
-    <p:spTree>
-      <p:nvGrpSpPr>
-        <p:cNvPr id="1" name="">
-          <a:extLst>
-            <a:ext uri="{FF2B5EF4-FFF2-40B4-BE49-F238E27FC236}">
-              <a16:creationId xmlns:a16="http://schemas.microsoft.com/office/drawing/2014/main" id="{89555F76-597A-A21F-811D-B0F2D42B9A6F}"/>
-            </a:ext>
-          </a:extLst>
-        </p:cNvPr>
-        <p:cNvGrpSpPr/>
-        <p:nvPr/>
-      </p:nvGrpSpPr>
-      <p:grpSpPr>
-        <a:xfrm>
-          <a:off x="0" y="0"/>
-          <a:ext cx="0" cy="0"/>
-          <a:chOff x="0" y="0"/>
-          <a:chExt cx="0" cy="0"/>
-        </a:xfrm>
-      </p:grpSpPr>
-      <p:sp>
-        <p:nvSpPr>
-          <p:cNvPr id="2" name="Title 1">
-            <a:extLst>
-              <a:ext uri="{FF2B5EF4-FFF2-40B4-BE49-F238E27FC236}">
-                <a16:creationId xmlns:a16="http://schemas.microsoft.com/office/drawing/2014/main" id="{5443DFF4-A16F-3DD5-59C3-DC264A45B93E}"/>
-              </a:ext>
-            </a:extLst>
-          </p:cNvPr>
-          <p:cNvSpPr>
-            <a:spLocks noGrp="1"/>
-          </p:cNvSpPr>
-          <p:nvPr>
-            <p:ph type="title"/>
-          </p:nvPr>
-        </p:nvSpPr>
-        <p:spPr/>
-        <p:txBody>
-          <a:bodyPr/>
-          <a:lstStyle/>
-          <a:p>
-            <a:endParaRPr lang="en-PK"/>
-          </a:p>
-        </p:txBody>
-      </p:sp>
-      <p:sp>
-        <p:nvSpPr>
-          <p:cNvPr id="3" name="Content Placeholder 2">
-            <a:extLst>
-              <a:ext uri="{FF2B5EF4-FFF2-40B4-BE49-F238E27FC236}">
-                <a16:creationId xmlns:a16="http://schemas.microsoft.com/office/drawing/2014/main" id="{EB6FA396-1426-A944-022E-E7665C8C76FD}"/>
-              </a:ext>
-            </a:extLst>
-          </p:cNvPr>
-          <p:cNvSpPr>
-            <a:spLocks noGrp="1"/>
-          </p:cNvSpPr>
-          <p:nvPr>
-            <p:ph idx="1"/>
-          </p:nvPr>
-        </p:nvSpPr>
-        <p:spPr/>
-        <p:txBody>
-          <a:bodyPr/>
-          <a:lstStyle/>
-          <a:p>
-            <a:endParaRPr lang="en-PK"/>
-          </a:p>
-        </p:txBody>
-      </p:sp>
-      <p:sp>
-        <p:nvSpPr>
-          <p:cNvPr id="4" name="TextBox 3">
-            <a:extLst>
-              <a:ext uri="{FF2B5EF4-FFF2-40B4-BE49-F238E27FC236}">
-                <a16:creationId xmlns:a16="http://schemas.microsoft.com/office/drawing/2014/main" id="{93023CD9-E1EA-4665-6957-8C2D508378CA}"/>
-              </a:ext>
-            </a:extLst>
-          </p:cNvPr>
-          <p:cNvSpPr txBox="1"/>
-          <p:nvPr/>
-        </p:nvSpPr>
-        <p:spPr>
-          <a:xfrm>
-            <a:off x="152400" y="6488668"/>
-            <a:ext cx="11887200" cy="369332"/>
-          </a:xfrm>
-          <a:prstGeom prst="rect">
-            <a:avLst/>
-          </a:prstGeom>
-          <a:noFill/>
-        </p:spPr>
-        <p:txBody>
-          <a:bodyPr wrap="square" rtlCol="0">
-            <a:spAutoFit/>
-          </a:bodyPr>
-          <a:lstStyle/>
-          <a:p>
-            <a:r>
-              <a:rPr lang="en-US" b="1" dirty="0">
-                <a:solidFill>
-                  <a:srgbClr val="0070C0"/>
-                </a:solidFill>
-              </a:rPr>
-              <a:t>FACULTY OF PHARMACY AND PHARMACEUTICAL SCIENCES                                                                               </a:t>
-            </a:r>
-            <a:r>
-              <a:rPr lang="en-US" b="1" dirty="0">
-                <a:solidFill>
-                  <a:schemeClr val="accent2"/>
-                </a:solidFill>
-              </a:rPr>
-              <a:t>SOFTSOLS PAKISTAN</a:t>
-            </a:r>
-            <a:endParaRPr lang="en-PK" b="1" dirty="0">
-              <a:solidFill>
-                <a:schemeClr val="accent2"/>
-              </a:solidFill>
-            </a:endParaRPr>
-          </a:p>
-        </p:txBody>
-      </p:sp>
-    </p:spTree>
-    <p:extLst>
-      <p:ext uri="{BB962C8B-B14F-4D97-AF65-F5344CB8AC3E}">
-        <p14:creationId xmlns:p14="http://schemas.microsoft.com/office/powerpoint/2010/main" val="1043758876"/>
-      </p:ext>
-    </p:extLst>
-  </p:cSld>
-  <p:clrMapOvr>
-    <a:masterClrMapping/>
-  </p:clrMapOvr>
-</p:sld>
-</file>
-
-<file path=ppt/slides/slide14.xml><?xml version="1.0" encoding="utf-8"?>
-<p:sld xmlns:a="http://schemas.openxmlformats.org/drawingml/2006/main" xmlns:r="http://schemas.openxmlformats.org/officeDocument/2006/relationships" xmlns:p="http://schemas.openxmlformats.org/presentationml/2006/main">
-  <p:cSld>
-    <p:spTree>
-      <p:nvGrpSpPr>
-        <p:cNvPr id="1" name="">
-          <a:extLst>
-            <a:ext uri="{FF2B5EF4-FFF2-40B4-BE49-F238E27FC236}">
               <a16:creationId xmlns:a16="http://schemas.microsoft.com/office/drawing/2014/main" id="{B61347C6-86B1-26B4-A47C-8092F41F3F54}"/>
             </a:ext>
           </a:extLst>
@@ -4506,7 +3702,7 @@
 </p:sld>
 </file>
 
-<file path=ppt/slides/slide15.xml><?xml version="1.0" encoding="utf-8"?>
+<file path=ppt/slides/slide11.xml><?xml version="1.0" encoding="utf-8"?>
 <p:sld xmlns:a="http://schemas.openxmlformats.org/drawingml/2006/main" xmlns:r="http://schemas.openxmlformats.org/officeDocument/2006/relationships" xmlns:p="http://schemas.openxmlformats.org/presentationml/2006/main">
   <p:cSld>
     <p:spTree>
@@ -4644,7 +3840,7 @@
 </p:sld>
 </file>
 
-<file path=ppt/slides/slide16.xml><?xml version="1.0" encoding="utf-8"?>
+<file path=ppt/slides/slide12.xml><?xml version="1.0" encoding="utf-8"?>
 <p:sld xmlns:a="http://schemas.openxmlformats.org/drawingml/2006/main" xmlns:r="http://schemas.openxmlformats.org/officeDocument/2006/relationships" xmlns:p="http://schemas.openxmlformats.org/presentationml/2006/main">
   <p:cSld>
     <p:spTree>
@@ -4782,7 +3978,7 @@
 </p:sld>
 </file>
 
-<file path=ppt/slides/slide17.xml><?xml version="1.0" encoding="utf-8"?>
+<file path=ppt/slides/slide13.xml><?xml version="1.0" encoding="utf-8"?>
 <p:sld xmlns:a="http://schemas.openxmlformats.org/drawingml/2006/main" xmlns:r="http://schemas.openxmlformats.org/officeDocument/2006/relationships" xmlns:p="http://schemas.openxmlformats.org/presentationml/2006/main">
   <p:cSld>
     <p:spTree>
@@ -6204,7 +5400,7 @@
         <p:cNvPr id="1" name="">
           <a:extLst>
             <a:ext uri="{FF2B5EF4-FFF2-40B4-BE49-F238E27FC236}">
-              <a16:creationId xmlns:a16="http://schemas.microsoft.com/office/drawing/2014/main" id="{5E931C6F-5FA5-5046-C1AB-6CF052E71156}"/>
+              <a16:creationId xmlns:a16="http://schemas.microsoft.com/office/drawing/2014/main" id="{89555F76-597A-A21F-811D-B0F2D42B9A6F}"/>
             </a:ext>
           </a:extLst>
         </p:cNvPr>
@@ -6224,7 +5420,7 @@
           <p:cNvPr id="2" name="Title 1">
             <a:extLst>
               <a:ext uri="{FF2B5EF4-FFF2-40B4-BE49-F238E27FC236}">
-                <a16:creationId xmlns:a16="http://schemas.microsoft.com/office/drawing/2014/main" id="{A8BB61C2-6332-754F-8B45-579D7EEAAF73}"/>
+                <a16:creationId xmlns:a16="http://schemas.microsoft.com/office/drawing/2014/main" id="{5443DFF4-A16F-3DD5-59C3-DC264A45B93E}"/>
               </a:ext>
             </a:extLst>
           </p:cNvPr>
@@ -6249,7 +5445,7 @@
           <p:cNvPr id="3" name="Content Placeholder 2">
             <a:extLst>
               <a:ext uri="{FF2B5EF4-FFF2-40B4-BE49-F238E27FC236}">
-                <a16:creationId xmlns:a16="http://schemas.microsoft.com/office/drawing/2014/main" id="{F4E42094-EB03-4D0F-2D94-279E6BFA12E2}"/>
+                <a16:creationId xmlns:a16="http://schemas.microsoft.com/office/drawing/2014/main" id="{EB6FA396-1426-A944-022E-E7665C8C76FD}"/>
               </a:ext>
             </a:extLst>
           </p:cNvPr>
@@ -6274,7 +5470,7 @@
           <p:cNvPr id="4" name="TextBox 3">
             <a:extLst>
               <a:ext uri="{FF2B5EF4-FFF2-40B4-BE49-F238E27FC236}">
-                <a16:creationId xmlns:a16="http://schemas.microsoft.com/office/drawing/2014/main" id="{BC158E87-A0EF-164F-B1A7-094642852BB4}"/>
+                <a16:creationId xmlns:a16="http://schemas.microsoft.com/office/drawing/2014/main" id="{93023CD9-E1EA-4665-6957-8C2D508378CA}"/>
               </a:ext>
             </a:extLst>
           </p:cNvPr>
@@ -6321,40 +5517,10 @@
           </a:p>
         </p:txBody>
       </p:sp>
-      <p:pic>
-        <p:nvPicPr>
-          <p:cNvPr id="6" name="Picture 5">
-            <a:extLst>
-              <a:ext uri="{FF2B5EF4-FFF2-40B4-BE49-F238E27FC236}">
-                <a16:creationId xmlns:a16="http://schemas.microsoft.com/office/drawing/2014/main" id="{E1D6CA62-52BB-2714-BC40-4E4DE612C753}"/>
-              </a:ext>
-            </a:extLst>
-          </p:cNvPr>
-          <p:cNvPicPr>
-            <a:picLocks noChangeAspect="1"/>
-          </p:cNvPicPr>
-          <p:nvPr/>
-        </p:nvPicPr>
-        <p:blipFill>
-          <a:blip r:embed="rId2"/>
-          <a:stretch>
-            <a:fillRect/>
-          </a:stretch>
-        </p:blipFill>
-        <p:spPr>
-          <a:xfrm>
-            <a:off x="0" y="0"/>
-            <a:ext cx="12192000" cy="6321778"/>
-          </a:xfrm>
-          <a:prstGeom prst="rect">
-            <a:avLst/>
-          </a:prstGeom>
-        </p:spPr>
-      </p:pic>
     </p:spTree>
     <p:extLst>
       <p:ext uri="{BB962C8B-B14F-4D97-AF65-F5344CB8AC3E}">
-        <p14:creationId xmlns:p14="http://schemas.microsoft.com/office/powerpoint/2010/main" val="2017795440"/>
+        <p14:creationId xmlns:p14="http://schemas.microsoft.com/office/powerpoint/2010/main" val="1043758876"/>
       </p:ext>
     </p:extLst>
   </p:cSld>

</xml_diff>